<commit_message>
Cat kich ban xuong khung 7 phut noi + 4 phut demo
Thay bao cao duoc 7 phut va demo 3-5 phut thay vi 10 phut nhu ban dau.

- docs/KICH_BAN_7P.md: ban cat. Phan noi 8:45 -> 5:55 bang cach an
  slide 3 (Tai san) va slide 6 (Pipeline) -- noi dung gop thanh mot
  cau o slide 2 va slide 5. Demo 9:30 -> 3:55, giu KB2 va KB6,
  chuyen KB1/KB3/KB4/KB5 sang muc hoi dap.
- docs/SLIDE.pptx: ghi chu nguoi noi ca 12 slide viet lai theo so
  giay moi. Slide 3 va 6 ghi ro "AN SLIDE NAY khi trinh bay".

Hai file goc SLIDE.md va HUONG_DAN_DEMO.md giu nguyen ban 10 phut,
dung khi can tra chi tiet tung lenh.

Co-Authored-By: Claude Opus 5 <noreply@anthropic.com>
</commit_message>
<xml_diff>
--- a/docs/SLIDE.pptx
+++ b/docs/SLIDE.pptx
@@ -633,9 +633,20 @@
           <a:p>
             <a:r>
               <a:rPr lang="en-US"/>
-              <a:t>30 giây. Nói ngay câu chốt: "Câu hỏi của đồ án này là — hệ thống dựa vào đâu để tin một thông tin."</a:t>
-            </a:r>
-            <a:endParaRPr lang="en-US" smtClean="0"/>
+              <a:t>15 GIÂY. Tên đề tài + câu chốt: "Câu hỏi của đồ án này là — hệ thống dựa vào đâu để tin một thông tin."</a:t>
+            </a:r>
+          </a:p>
+          <a:p>
+            <a:r>
+              <a:rPr lang="en-US"/>
+              <a:t/>
+            </a:r>
+          </a:p>
+          <a:p>
+            <a:r>
+              <a:rPr lang="en-US"/>
+              <a:t>Đừng đọc tên từng thành viên — thầy đã có trong báo cáo.</a:t>
+            </a:r>
           </a:p>
         </p:txBody>
       </p:sp>
@@ -846,9 +857,50 @@
           <a:p>
             <a:r>
               <a:rPr lang="en-US"/>
-              <a:t>60 giây. Đây là slide ghi điểm: có số thật, không nói chung chung.</a:t>
-            </a:r>
-            <a:endParaRPr lang="en-US" smtClean="0"/>
+              <a:t>50 GIÂY. SLIDE GHI ĐIỂM.</a:t>
+            </a:r>
+          </a:p>
+          <a:p>
+            <a:r>
+              <a:rPr lang="en-US"/>
+              <a:t/>
+            </a:r>
+          </a:p>
+          <a:p>
+            <a:r>
+              <a:rPr lang="en-US"/>
+              <a:t>Chỉ đọc ba con số:</a:t>
+            </a:r>
+          </a:p>
+          <a:p>
+            <a:r>
+              <a:rPr lang="en-US"/>
+              <a:t>  1 sửa / 30 giây</a:t>
+            </a:r>
+          </a:p>
+          <a:p>
+            <a:r>
+              <a:rPr lang="en-US"/>
+              <a:t>  PL1 chặn oan 0/15</a:t>
+            </a:r>
+          </a:p>
+          <a:p>
+            <a:r>
+              <a:rPr lang="en-US"/>
+              <a:t>  RTO 5–6 giây</a:t>
+            </a:r>
+          </a:p>
+          <a:p>
+            <a:r>
+              <a:rPr lang="en-US"/>
+              <a:t/>
+            </a:r>
+          </a:p>
+          <a:p>
+            <a:r>
+              <a:rPr lang="en-US"/>
+              <a:t>DỄ VỠ NGÂN SÁCH: đừng kể quá trình đo, chỉ đọc kết quả.</a:t>
+            </a:r>
           </a:p>
         </p:txBody>
       </p:sp>
@@ -1059,9 +1111,38 @@
           <a:p>
             <a:r>
               <a:rPr lang="en-US"/>
-              <a:t>45 giây. Biết mình chưa làm gì — nói thẳng, đừng né.</a:t>
-            </a:r>
-            <a:endParaRPr lang="en-US" smtClean="0"/>
+              <a:t>25 GIÂY. Đọc nhanh đúng 2 dòng:</a:t>
+            </a:r>
+          </a:p>
+          <a:p>
+            <a:r>
+              <a:rPr lang="en-US"/>
+              <a:t>  TOTP không chống AiTM → Passkey/WebAuthn</a:t>
+            </a:r>
+          </a:p>
+          <a:p>
+            <a:r>
+              <a:rPr lang="en-US"/>
+              <a:t>  Superuser DB vẫn tính lại được hash-chain → SIEM + WORM</a:t>
+            </a:r>
+          </a:p>
+          <a:p>
+            <a:r>
+              <a:rPr lang="en-US"/>
+              <a:t/>
+            </a:r>
+          </a:p>
+          <a:p>
+            <a:r>
+              <a:rPr lang="en-US"/>
+              <a:t>DỄ VỠ NGÂN SÁCH: đừng xin lỗi dài dòng.</a:t>
+            </a:r>
+          </a:p>
+          <a:p>
+            <a:r>
+              <a:rPr lang="en-US"/>
+              <a:t>Nếu phần nói đã quá 6:30 thì cắt slide này còn 15 giây.</a:t>
+            </a:r>
           </a:p>
         </p:txBody>
       </p:sp>
@@ -1272,9 +1353,20 @@
           <a:p>
             <a:r>
               <a:rPr lang="en-US"/>
-              <a:t>Đọc chậm bốn câu, dừng lại sau câu 3. Rồi mời hỏi đáp.</a:t>
-            </a:r>
-            <a:endParaRPr lang="en-US" smtClean="0"/>
+              <a:t>30 GIÂY. Bốn câu, đọc chậm, dừng lại sau câu 3. Rồi mời hỏi đáp.</a:t>
+            </a:r>
+          </a:p>
+          <a:p>
+            <a:r>
+              <a:rPr lang="en-US"/>
+              <a:t/>
+            </a:r>
+          </a:p>
+          <a:p>
+            <a:r>
+              <a:rPr lang="en-US"/>
+              <a:t>TỔNG PHẦN NÓI: 5 phút 55 — dư 65 giây so với khung 7 phút.</a:t>
+            </a:r>
           </a:p>
         </p:txBody>
       </p:sp>
@@ -1485,9 +1577,32 @@
           <a:p>
             <a:r>
               <a:rPr lang="en-US"/>
-              <a:t>45 giây. Đây là cái móc của cả bài: đừng vội nói về kỹ thuật.</a:t>
-            </a:r>
-            <a:endParaRPr lang="en-US" smtClean="0"/>
+              <a:t>45 GIÂY. Điểm là tài sản toàn vẹn → cổng vào duy nhất là tài khoản GV → dừng ở câu hỏi lớn.</a:t>
+            </a:r>
+          </a:p>
+          <a:p>
+            <a:r>
+              <a:rPr lang="en-US"/>
+              <a:t/>
+            </a:r>
+          </a:p>
+          <a:p>
+            <a:r>
+              <a:rPr lang="en-US"/>
+              <a:t>THÊM MỘT CÂU (vì slide 3 đã ẩn): "tác nhân nguy hiểm nhất là insider có quyền DB — phần lớn đồ án bỏ qua."</a:t>
+            </a:r>
+          </a:p>
+          <a:p>
+            <a:r>
+              <a:rPr lang="en-US"/>
+              <a:t/>
+            </a:r>
+          </a:p>
+          <a:p>
+            <a:r>
+              <a:rPr lang="en-US"/>
+              <a:t>Đây là cái móc của cả bài: đừng vội nói về kỹ thuật.</a:t>
+            </a:r>
           </a:p>
         </p:txBody>
       </p:sp>
@@ -1698,9 +1813,26 @@
           <a:p>
             <a:r>
               <a:rPr lang="en-US"/>
-              <a:t>45 giây. Nhấn vào dòng insider: hầu hết đồ án bỏ qua tác nhân này.</a:t>
-            </a:r>
-            <a:endParaRPr lang="en-US" smtClean="0"/>
+              <a:t>ẨN SLIDE NÀY khi trình bày.</a:t>
+            </a:r>
+          </a:p>
+          <a:p>
+            <a:r>
+              <a:rPr lang="en-US"/>
+              <a:t>PowerPoint: chuột phải vào slide ở khung bên trái → Hide Slide.</a:t>
+            </a:r>
+          </a:p>
+          <a:p>
+            <a:r>
+              <a:rPr lang="en-US"/>
+              <a:t/>
+            </a:r>
+          </a:p>
+          <a:p>
+            <a:r>
+              <a:rPr lang="en-US"/>
+              <a:t>Chỉ mở khi thầy hỏi "tài sản nào quan trọng nhất". Nội dung đã gộp một câu vào slide 2.</a:t>
+            </a:r>
           </a:p>
         </p:txBody>
       </p:sp>
@@ -1911,9 +2043,32 @@
           <a:p>
             <a:r>
               <a:rPr lang="en-US"/>
-              <a:t>60 giây. Nói hệ quả của D4: có RCE trong app cũng không exfiltrate được dữ liệu.</a:t>
-            </a:r>
-            <a:endParaRPr lang="en-US" smtClean="0"/>
+              <a:t>50 GIÂY. 3 zone · chỉ WAF có port.</a:t>
+            </a:r>
+          </a:p>
+          <a:p>
+            <a:r>
+              <a:rPr lang="en-US"/>
+              <a:t/>
+            </a:r>
+          </a:p>
+          <a:p>
+            <a:r>
+              <a:rPr lang="en-US"/>
+              <a:t>NHẤN D4: app không gọi được ra Internet, nên có RCE trong app cũng không exfiltrate được dữ liệu.</a:t>
+            </a:r>
+          </a:p>
+          <a:p>
+            <a:r>
+              <a:rPr lang="en-US"/>
+              <a:t/>
+            </a:r>
+          </a:p>
+          <a:p>
+            <a:r>
+              <a:rPr lang="en-US"/>
+              <a:t>Đừng đọc hết 5 luồng bị chặn.</a:t>
+            </a:r>
           </a:p>
         </p:txBody>
       </p:sp>
@@ -2124,9 +2279,44 @@
           <a:p>
             <a:r>
               <a:rPr lang="en-US"/>
-              <a:t>75 giây. Dòng cuối là điểm nhấn: không tin cả DB của mình.</a:t>
-            </a:r>
-            <a:endParaRPr lang="en-US" smtClean="0"/>
+              <a:t>70 GIÂY — slide dài nhất, bấm giờ riêng khi tổng duyệt.</a:t>
+            </a:r>
+          </a:p>
+          <a:p>
+            <a:r>
+              <a:rPr lang="en-US"/>
+              <a:t/>
+            </a:r>
+          </a:p>
+          <a:p>
+            <a:r>
+              <a:rPr lang="en-US"/>
+              <a:t>Đọc 5 dòng bảng, dừng lại ở dòng cuối (không tin cả DB của mình).</a:t>
+            </a:r>
+          </a:p>
+          <a:p>
+            <a:r>
+              <a:rPr lang="en-US"/>
+              <a:t/>
+            </a:r>
+          </a:p>
+          <a:p>
+            <a:r>
+              <a:rPr lang="en-US"/>
+              <a:t>THÊM MỘT CÂU (vì slide 6 đã ẩn): "cụ thể hoá thành 12 lớp kiểm chứng, một request sửa điểm phải qua hết."</a:t>
+            </a:r>
+          </a:p>
+          <a:p>
+            <a:r>
+              <a:rPr lang="en-US"/>
+              <a:t/>
+            </a:r>
+          </a:p>
+          <a:p>
+            <a:r>
+              <a:rPr lang="en-US"/>
+              <a:t>DỄ VỠ NGÂN SÁCH: đừng giải thích từng dòng.</a:t>
+            </a:r>
           </a:p>
         </p:txBody>
       </p:sp>
@@ -2337,9 +2527,26 @@
           <a:p>
             <a:r>
               <a:rPr lang="en-US"/>
-              <a:t>60 giây. Chỉ đọc 4 lớp tô đậm (5 Fingerprint, 8 Step-up OTP, 10 Ownership, 12 Audit hash-chain), đừng đọc hết 12.</a:t>
-            </a:r>
-            <a:endParaRPr lang="en-US" smtClean="0"/>
+              <a:t>ẨN SLIDE NÀY khi trình bày.</a:t>
+            </a:r>
+          </a:p>
+          <a:p>
+            <a:r>
+              <a:rPr lang="en-US"/>
+              <a:t>PowerPoint: chuột phải vào slide ở khung bên trái → Hide Slide.</a:t>
+            </a:r>
+          </a:p>
+          <a:p>
+            <a:r>
+              <a:rPr lang="en-US"/>
+              <a:t/>
+            </a:r>
+          </a:p>
+          <a:p>
+            <a:r>
+              <a:rPr lang="en-US"/>
+              <a:t>Chỉ mở khi thầy hỏi "12 lớp là những lớp nào". Đã nói bằng một câu ở slide 5.</a:t>
+            </a:r>
           </a:p>
         </p:txBody>
       </p:sp>
@@ -2550,9 +2757,20 @@
           <a:p>
             <a:r>
               <a:rPr lang="en-US"/>
-              <a:t>45 giây. Dừng lại ở dòng R08: insider có quyền DB.</a:t>
-            </a:r>
-            <a:endParaRPr lang="en-US" smtClean="0"/>
+              <a:t>40 GIÂY. Lướt nhanh 4 dòng đầu.</a:t>
+            </a:r>
+          </a:p>
+          <a:p>
+            <a:r>
+              <a:rPr lang="en-US"/>
+              <a:t/>
+            </a:r>
+          </a:p>
+          <a:p>
+            <a:r>
+              <a:rPr lang="en-US"/>
+              <a:t>DỮNG Ở R08: insider sửa DB, audit_log append-only, hash-chain, TC22–TC24. Đây là dòng phân biệt đồ án này với đồ án khác.</a:t>
+            </a:r>
           </a:p>
         </p:txBody>
       </p:sp>
@@ -2763,9 +2981,62 @@
           <a:p>
             <a:r>
               <a:rPr lang="en-US"/>
-              <a:t>Theo kịch bản demo 9 phút 30. Nếu máy lỗi: phát video OBS dự phòng.</a:t>
-            </a:r>
-            <a:endParaRPr lang="en-US" smtClean="0"/>
+              <a:t>5 GIÂY. "Chuyển sang màn hình live."</a:t>
+            </a:r>
+          </a:p>
+          <a:p>
+            <a:r>
+              <a:rPr lang="en-US"/>
+              <a:t/>
+            </a:r>
+          </a:p>
+          <a:p>
+            <a:r>
+              <a:rPr lang="en-US"/>
+              <a:t>DEMO 4 PHÚT theo docs/KICH_BAN_7P.md:</a:t>
+            </a:r>
+          </a:p>
+          <a:p>
+            <a:r>
+              <a:rPr lang="en-US"/>
+              <a:t>  D1 0:00–0:25  phân vùng (2 lệnh)</a:t>
+            </a:r>
+          </a:p>
+          <a:p>
+            <a:r>
+              <a:rPr lang="en-US"/>
+              <a:t>  D2 0:25–1:10  sửa điểm hợp lệ + step-up OTP</a:t>
+            </a:r>
+          </a:p>
+          <a:p>
+            <a:r>
+              <a:rPr lang="en-US"/>
+              <a:t>  D3 1:10–2:20  KB2 đánh cắp cookie</a:t>
+            </a:r>
+          </a:p>
+          <a:p>
+            <a:r>
+              <a:rPr lang="en-US"/>
+              <a:t>  D4 2:20–3:45  KB6 insider sửa DB</a:t>
+            </a:r>
+          </a:p>
+          <a:p>
+            <a:r>
+              <a:rPr lang="en-US"/>
+              <a:t/>
+            </a:r>
+          </a:p>
+          <a:p>
+            <a:r>
+              <a:rPr lang="en-US"/>
+              <a:t>KB1 / KB3 / KB4 / KB5 để dành cho hỏi đáp.</a:t>
+            </a:r>
+          </a:p>
+          <a:p>
+            <a:r>
+              <a:rPr lang="en-US"/>
+              <a:t>NHỚT TRƯỚC KHI BẤM GIỜ: gv01 và admin đã đăng nhập sẵn, đã chạy docker compose restart app, lệnh dán sẵn trong file text.</a:t>
+            </a:r>
           </a:p>
         </p:txBody>
       </p:sp>
@@ -2976,9 +3247,20 @@
           <a:p>
             <a:r>
               <a:rPr lang="en-US"/>
-              <a:t>30 giây. Mỗi rủi ro trong ma trận đều trỏ tới ít nhất 1 test case. Bộ test bao phủ 6 kịch bản tấn công KB1–KB6.</a:t>
-            </a:r>
-            <a:endParaRPr lang="en-US" smtClean="0"/>
+              <a:t>25 GIÂY. 25/25 PASS · 6 luồng bình thường + 19 test tấn công · phủ KB1–KB6.</a:t>
+            </a:r>
+          </a:p>
+          <a:p>
+            <a:r>
+              <a:rPr lang="en-US"/>
+              <a:t/>
+            </a:r>
+          </a:p>
+          <a:p>
+            <a:r>
+              <a:rPr lang="en-US"/>
+              <a:t>Đừng đọc từng dòng trên màn hình — để thầy tự đọc.</a:t>
+            </a:r>
           </a:p>
         </p:txBody>
       </p:sp>
@@ -6339,7 +6621,7 @@
         <p:spPr>
           <a:xfrm rot="0">
             <a:off x="1047750" y="6229350"/>
-            <a:ext cx="10953750" cy="2091690"/>
+            <a:ext cx="10953750" cy="2091333"/>
           </a:xfrm>
           <a:prstGeom prst="rect">
             <a:avLst/>

</xml_diff>

<commit_message>
Doi bo slide sang nen sang cho de nhin tren may chieu
Nen toi bi bet khi chieu trong phong sang, va so do kien truc nen
trang dat tren nen navy nhin nhu to giay dan vao.

Bang mau moi:
  nen      #0F1C2E / #16243A -> #F7F9FC / #EDF1F6
  tieu de  #F4F7FB -> #1B2A3F
  chu      #AAB6C6 -> #3C4A5C
  nhan nho #34465D -> #8A98AA
  bang     nen #192A42 -> #FFFFFF, vien #34465D -> #D4DCE6
  nhan     #2E5C8A giu nguyen (chu trang tren khoi xanh giu nguyen)
  rui ro   #C0392B giu nguyen, do phu 0.18 -> 0.10

Sua loi go trong ghi chu slide 8: NHOT -> NHO.

Co-Authored-By: Claude Opus 5 <noreply@anthropic.com>
</commit_message>
<xml_diff>
--- a/docs/SLIDE.pptx
+++ b/docs/SLIDE.pptx
@@ -3035,7 +3035,7 @@
           <a:p>
             <a:r>
               <a:rPr lang="en-US"/>
-              <a:t>NHỚT TRƯỚC KHI BẤM GIỜ: gv01 và admin đã đăng nhập sẵn, đã chạy docker compose restart app, lệnh dán sẵn trong file text.</a:t>
+              <a:t>NHỚ TRƯỚC KHI BẤM GIỜ: gv01 và admin đã đăng nhập sẵn, đã chạy docker compose restart app, lệnh dán sẵn trong file text.</a:t>
             </a:r>
           </a:p>
         </p:txBody>
@@ -6276,7 +6276,7 @@
     <p:bg>
       <p:bgPr>
         <a:solidFill>
-          <a:srgbClr val="0F1C2E"/>
+          <a:srgbClr val="F7F9FC"/>
         </a:solidFill>
       </p:bgPr>
     </p:bg>
@@ -6410,7 +6410,7 @@
             <a:r>
               <a:rPr lang="en-US" sz="1350">
                 <a:solidFill>
-                  <a:srgbClr val="AAB6C6"/>
+                  <a:srgbClr val="8A98AA"/>
                 </a:solidFill>
                 <a:latin typeface="JetBrains Mono"/>
                 <a:ea typeface="JetBrains Mono"/>
@@ -6473,7 +6473,7 @@
             </a:custGeom>
             <a:solidFill>
               <a:srgbClr val="2E5C8A">
-                <a:alpha val="23922"/>
+                <a:alpha val="9804"/>
               </a:srgbClr>
             </a:solidFill>
             <a:ln cap="sq">
@@ -6540,7 +6540,7 @@
             <a:r>
               <a:rPr lang="en-US" sz="9600" b="true">
                 <a:solidFill>
-                  <a:srgbClr val="F4F7FB"/>
+                  <a:srgbClr val="1B2A3F"/>
                 </a:solidFill>
                 <a:latin typeface="IBM Plex Sans Bold"/>
                 <a:ea typeface="IBM Plex Sans Bold"/>
@@ -6621,7 +6621,7 @@
         <p:spPr>
           <a:xfrm rot="0">
             <a:off x="1047750" y="6229350"/>
-            <a:ext cx="10953750" cy="2091333"/>
+            <a:ext cx="10953750" cy="2091690"/>
           </a:xfrm>
           <a:prstGeom prst="rect">
             <a:avLst/>
@@ -6644,7 +6644,7 @@
             <a:r>
               <a:rPr lang="en-US" sz="1800" strike="noStrike" u="none">
                 <a:solidFill>
-                  <a:srgbClr val="AAB6C6"/>
+                  <a:srgbClr val="3C4A5C"/>
                 </a:solidFill>
                 <a:latin typeface="JetBrains Mono"/>
                 <a:ea typeface="JetBrains Mono"/>
@@ -6666,7 +6666,7 @@
             <a:r>
               <a:rPr lang="en-US" sz="1800" strike="noStrike" u="none">
                 <a:solidFill>
-                  <a:srgbClr val="AAB6C6"/>
+                  <a:srgbClr val="3C4A5C"/>
                 </a:solidFill>
                 <a:latin typeface="JetBrains Mono"/>
                 <a:ea typeface="JetBrains Mono"/>
@@ -6698,7 +6698,7 @@
             <a:r>
               <a:rPr lang="en-US" sz="1800" strike="noStrike" u="none">
                 <a:solidFill>
-                  <a:srgbClr val="AAB6C6"/>
+                  <a:srgbClr val="3C4A5C"/>
                 </a:solidFill>
                 <a:latin typeface="JetBrains Mono"/>
                 <a:ea typeface="JetBrains Mono"/>
@@ -6720,7 +6720,7 @@
             <a:r>
               <a:rPr lang="en-US" sz="1800" strike="noStrike" u="none">
                 <a:solidFill>
-                  <a:srgbClr val="AAB6C6"/>
+                  <a:srgbClr val="3C4A5C"/>
                 </a:solidFill>
                 <a:latin typeface="JetBrains Mono"/>
                 <a:ea typeface="JetBrains Mono"/>
@@ -6742,7 +6742,7 @@
             <a:r>
               <a:rPr lang="en-US" sz="1800" strike="noStrike" u="none">
                 <a:solidFill>
-                  <a:srgbClr val="AAB6C6"/>
+                  <a:srgbClr val="3C4A5C"/>
                 </a:solidFill>
                 <a:latin typeface="JetBrains Mono"/>
                 <a:ea typeface="JetBrains Mono"/>
@@ -6768,7 +6768,7 @@
     <p:bg>
       <p:bgPr>
         <a:solidFill>
-          <a:srgbClr val="16243A"/>
+          <a:srgbClr val="EDF1F6"/>
         </a:solidFill>
       </p:bgPr>
     </p:bg>
@@ -6902,7 +6902,7 @@
             <a:r>
               <a:rPr lang="en-US" sz="1350">
                 <a:solidFill>
-                  <a:srgbClr val="AAB6C6"/>
+                  <a:srgbClr val="8A98AA"/>
                 </a:solidFill>
                 <a:latin typeface="JetBrains Mono"/>
                 <a:ea typeface="JetBrains Mono"/>
@@ -6943,7 +6943,7 @@
             <a:r>
               <a:rPr lang="en-US" sz="4800" b="true">
                 <a:solidFill>
-                  <a:srgbClr val="F4F7FB"/>
+                  <a:srgbClr val="1B2A3F"/>
                 </a:solidFill>
                 <a:latin typeface="IBM Plex Sans Bold"/>
                 <a:ea typeface="IBM Plex Sans Bold"/>
@@ -7019,11 +7019,11 @@
                 </a:pathLst>
               </a:custGeom>
               <a:solidFill>
-                <a:srgbClr val="192A42"/>
+                <a:srgbClr val="FFFFFF"/>
               </a:solidFill>
               <a:ln w="9525" cap="sq">
                 <a:solidFill>
-                  <a:srgbClr val="34465D"/>
+                  <a:srgbClr val="D4DCE6"/>
                 </a:solidFill>
                 <a:prstDash val="solid"/>
                 <a:miter/>
@@ -7074,7 +7074,7 @@
             </a:prstGeom>
             <a:ln cap="flat" w="12700">
               <a:solidFill>
-                <a:srgbClr val="34465D"/>
+                <a:srgbClr val="D4DCE6"/>
               </a:solidFill>
               <a:prstDash val="solid"/>
               <a:headEnd type="none" len="sm" w="sm"/>
@@ -7098,7 +7098,7 @@
             </a:prstGeom>
             <a:ln cap="flat" w="12700">
               <a:solidFill>
-                <a:srgbClr val="34465D"/>
+                <a:srgbClr val="D4DCE6"/>
               </a:solidFill>
               <a:prstDash val="solid"/>
               <a:headEnd type="none" len="sm" w="sm"/>
@@ -7146,7 +7146,7 @@
             </a:prstGeom>
             <a:ln cap="flat" w="12700">
               <a:solidFill>
-                <a:srgbClr val="34465D"/>
+                <a:srgbClr val="D4DCE6"/>
               </a:solidFill>
               <a:prstDash val="solid"/>
               <a:headEnd type="none" len="sm" w="sm"/>
@@ -7170,7 +7170,7 @@
             </a:prstGeom>
             <a:ln cap="flat" w="12700">
               <a:solidFill>
-                <a:srgbClr val="34465D"/>
+                <a:srgbClr val="D4DCE6"/>
               </a:solidFill>
               <a:prstDash val="solid"/>
               <a:headEnd type="none" len="sm" w="sm"/>
@@ -7333,7 +7333,7 @@
               <a:r>
                 <a:rPr lang="en-US" sz="1800" strike="noStrike" u="none">
                   <a:solidFill>
-                    <a:srgbClr val="AAB6C6"/>
+                    <a:srgbClr val="3C4A5C"/>
                   </a:solidFill>
                   <a:latin typeface="IBM Plex Sans"/>
                   <a:ea typeface="IBM Plex Sans"/>
@@ -7377,7 +7377,7 @@
               <a:r>
                 <a:rPr lang="en-US" sz="1800" strike="noStrike" u="none">
                   <a:solidFill>
-                    <a:srgbClr val="AAB6C6"/>
+                    <a:srgbClr val="3C4A5C"/>
                   </a:solidFill>
                   <a:latin typeface="IBM Plex Sans"/>
                   <a:ea typeface="IBM Plex Sans"/>
@@ -7421,7 +7421,7 @@
               <a:r>
                 <a:rPr lang="en-US" sz="1800" strike="noStrike" u="none">
                   <a:solidFill>
-                    <a:srgbClr val="AAB6C6"/>
+                    <a:srgbClr val="3C4A5C"/>
                   </a:solidFill>
                   <a:latin typeface="IBM Plex Sans"/>
                   <a:ea typeface="IBM Plex Sans"/>
@@ -7465,7 +7465,7 @@
               <a:r>
                 <a:rPr lang="en-US" sz="1800" strike="noStrike" u="none">
                   <a:solidFill>
-                    <a:srgbClr val="AAB6C6"/>
+                    <a:srgbClr val="3C4A5C"/>
                   </a:solidFill>
                   <a:latin typeface="IBM Plex Sans"/>
                   <a:ea typeface="IBM Plex Sans"/>
@@ -7509,7 +7509,7 @@
               <a:r>
                 <a:rPr lang="en-US" sz="1800" strike="noStrike" u="none">
                   <a:solidFill>
-                    <a:srgbClr val="AAB6C6"/>
+                    <a:srgbClr val="3C4A5C"/>
                   </a:solidFill>
                   <a:latin typeface="IBM Plex Sans"/>
                   <a:ea typeface="IBM Plex Sans"/>
@@ -7553,7 +7553,7 @@
               <a:r>
                 <a:rPr lang="en-US" sz="1800" strike="noStrike" u="none">
                   <a:solidFill>
-                    <a:srgbClr val="AAB6C6"/>
+                    <a:srgbClr val="3C4A5C"/>
                   </a:solidFill>
                   <a:latin typeface="IBM Plex Sans"/>
                   <a:ea typeface="IBM Plex Sans"/>
@@ -7597,7 +7597,7 @@
               <a:r>
                 <a:rPr lang="en-US" sz="1800" strike="noStrike" u="none">
                   <a:solidFill>
-                    <a:srgbClr val="AAB6C6"/>
+                    <a:srgbClr val="3C4A5C"/>
                   </a:solidFill>
                   <a:latin typeface="IBM Plex Sans"/>
                   <a:ea typeface="IBM Plex Sans"/>
@@ -7641,7 +7641,7 @@
               <a:r>
                 <a:rPr lang="en-US" sz="1800" strike="noStrike" u="none">
                   <a:solidFill>
-                    <a:srgbClr val="AAB6C6"/>
+                    <a:srgbClr val="3C4A5C"/>
                   </a:solidFill>
                   <a:latin typeface="IBM Plex Sans"/>
                   <a:ea typeface="IBM Plex Sans"/>
@@ -7685,7 +7685,7 @@
               <a:r>
                 <a:rPr lang="en-US" sz="1800" strike="noStrike" u="none">
                   <a:solidFill>
-                    <a:srgbClr val="AAB6C6"/>
+                    <a:srgbClr val="3C4A5C"/>
                   </a:solidFill>
                   <a:latin typeface="IBM Plex Sans"/>
                   <a:ea typeface="IBM Plex Sans"/>
@@ -7730,7 +7730,7 @@
             <a:r>
               <a:rPr lang="en-US" b="true" sz="2700" strike="noStrike" u="none">
                 <a:solidFill>
-                  <a:srgbClr val="F4F7FB"/>
+                  <a:srgbClr val="1B2A3F"/>
                 </a:solidFill>
                 <a:latin typeface="JetBrains Mono Bold"/>
                 <a:ea typeface="JetBrains Mono Bold"/>
@@ -7774,7 +7774,7 @@
             <a:r>
               <a:rPr lang="en-US" b="true" sz="2700" strike="noStrike" u="none">
                 <a:solidFill>
-                  <a:srgbClr val="F4F7FB"/>
+                  <a:srgbClr val="1B2A3F"/>
                 </a:solidFill>
                 <a:latin typeface="JetBrains Mono Bold"/>
                 <a:ea typeface="JetBrains Mono Bold"/>
@@ -7818,7 +7818,7 @@
             <a:r>
               <a:rPr lang="en-US" b="true" sz="2700" strike="noStrike" u="none">
                 <a:solidFill>
-                  <a:srgbClr val="F4F7FB"/>
+                  <a:srgbClr val="1B2A3F"/>
                 </a:solidFill>
                 <a:latin typeface="JetBrains Mono Bold"/>
                 <a:ea typeface="JetBrains Mono Bold"/>
@@ -7844,7 +7844,7 @@
     <p:bg>
       <p:bgPr>
         <a:solidFill>
-          <a:srgbClr val="0F1C2E"/>
+          <a:srgbClr val="F7F9FC"/>
         </a:solidFill>
       </p:bgPr>
     </p:bg>
@@ -7978,7 +7978,7 @@
             <a:r>
               <a:rPr lang="en-US" sz="1350">
                 <a:solidFill>
-                  <a:srgbClr val="AAB6C6"/>
+                  <a:srgbClr val="8A98AA"/>
                 </a:solidFill>
                 <a:latin typeface="JetBrains Mono"/>
                 <a:ea typeface="JetBrains Mono"/>
@@ -8019,7 +8019,7 @@
             <a:r>
               <a:rPr lang="en-US" sz="4800" b="true">
                 <a:solidFill>
-                  <a:srgbClr val="F4F7FB"/>
+                  <a:srgbClr val="1B2A3F"/>
                 </a:solidFill>
                 <a:latin typeface="IBM Plex Sans Bold"/>
                 <a:ea typeface="IBM Plex Sans Bold"/>
@@ -8095,11 +8095,11 @@
                 </a:pathLst>
               </a:custGeom>
               <a:solidFill>
-                <a:srgbClr val="192A42"/>
+                <a:srgbClr val="FFFFFF"/>
               </a:solidFill>
               <a:ln w="9525" cap="sq">
                 <a:solidFill>
-                  <a:srgbClr val="34465D"/>
+                  <a:srgbClr val="D4DCE6"/>
                 </a:solidFill>
                 <a:prstDash val="solid"/>
                 <a:miter/>
@@ -8150,7 +8150,7 @@
             </a:prstGeom>
             <a:ln cap="flat" w="12700">
               <a:solidFill>
-                <a:srgbClr val="34465D"/>
+                <a:srgbClr val="D4DCE6"/>
               </a:solidFill>
               <a:prstDash val="solid"/>
               <a:headEnd type="none" len="sm" w="sm"/>
@@ -8198,7 +8198,7 @@
             </a:prstGeom>
             <a:ln cap="flat" w="12700">
               <a:solidFill>
-                <a:srgbClr val="34465D"/>
+                <a:srgbClr val="D4DCE6"/>
               </a:solidFill>
               <a:prstDash val="solid"/>
               <a:headEnd type="none" len="sm" w="sm"/>
@@ -8222,7 +8222,7 @@
             </a:prstGeom>
             <a:ln cap="flat" w="12700">
               <a:solidFill>
-                <a:srgbClr val="34465D"/>
+                <a:srgbClr val="D4DCE6"/>
               </a:solidFill>
               <a:prstDash val="solid"/>
               <a:headEnd type="none" len="sm" w="sm"/>
@@ -8246,7 +8246,7 @@
             </a:prstGeom>
             <a:ln cap="flat" w="12700">
               <a:solidFill>
-                <a:srgbClr val="34465D"/>
+                <a:srgbClr val="D4DCE6"/>
               </a:solidFill>
               <a:prstDash val="solid"/>
               <a:headEnd type="none" len="sm" w="sm"/>
@@ -8270,7 +8270,7 @@
             </a:prstGeom>
             <a:ln cap="flat" w="12700">
               <a:solidFill>
-                <a:srgbClr val="34465D"/>
+                <a:srgbClr val="D4DCE6"/>
               </a:solidFill>
               <a:prstDash val="solid"/>
               <a:headEnd type="none" len="sm" w="sm"/>
@@ -8392,7 +8392,7 @@
               <a:r>
                 <a:rPr lang="en-US" sz="1575" strike="noStrike" u="none">
                   <a:solidFill>
-                    <a:srgbClr val="AAB6C6"/>
+                    <a:srgbClr val="3C4A5C"/>
                   </a:solidFill>
                   <a:latin typeface="IBM Plex Sans"/>
                   <a:ea typeface="IBM Plex Sans"/>
@@ -8436,7 +8436,7 @@
               <a:r>
                 <a:rPr lang="en-US" sz="1575" strike="noStrike" u="none">
                   <a:solidFill>
-                    <a:srgbClr val="AAB6C6"/>
+                    <a:srgbClr val="3C4A5C"/>
                   </a:solidFill>
                   <a:latin typeface="IBM Plex Sans"/>
                   <a:ea typeface="IBM Plex Sans"/>
@@ -8480,7 +8480,7 @@
               <a:r>
                 <a:rPr lang="en-US" sz="1575" strike="noStrike" u="none">
                   <a:solidFill>
-                    <a:srgbClr val="AAB6C6"/>
+                    <a:srgbClr val="3C4A5C"/>
                   </a:solidFill>
                   <a:latin typeface="IBM Plex Sans"/>
                   <a:ea typeface="IBM Plex Sans"/>
@@ -8524,7 +8524,7 @@
               <a:r>
                 <a:rPr lang="en-US" sz="1575" strike="noStrike" u="none">
                   <a:solidFill>
-                    <a:srgbClr val="AAB6C6"/>
+                    <a:srgbClr val="3C4A5C"/>
                   </a:solidFill>
                   <a:latin typeface="IBM Plex Sans"/>
                   <a:ea typeface="IBM Plex Sans"/>
@@ -8568,7 +8568,7 @@
               <a:r>
                 <a:rPr lang="en-US" sz="1575" strike="noStrike" u="none">
                   <a:solidFill>
-                    <a:srgbClr val="AAB6C6"/>
+                    <a:srgbClr val="3C4A5C"/>
                   </a:solidFill>
                   <a:latin typeface="IBM Plex Sans"/>
                   <a:ea typeface="IBM Plex Sans"/>
@@ -8612,7 +8612,7 @@
               <a:r>
                 <a:rPr lang="en-US" sz="1575" strike="noStrike" u="none">
                   <a:solidFill>
-                    <a:srgbClr val="AAB6C6"/>
+                    <a:srgbClr val="3C4A5C"/>
                   </a:solidFill>
                   <a:latin typeface="IBM Plex Sans"/>
                   <a:ea typeface="IBM Plex Sans"/>
@@ -8656,7 +8656,7 @@
               <a:r>
                 <a:rPr lang="en-US" sz="1575" strike="noStrike" u="none">
                   <a:solidFill>
-                    <a:srgbClr val="AAB6C6"/>
+                    <a:srgbClr val="3C4A5C"/>
                   </a:solidFill>
                   <a:latin typeface="IBM Plex Sans"/>
                   <a:ea typeface="IBM Plex Sans"/>
@@ -8700,7 +8700,7 @@
               <a:r>
                 <a:rPr lang="en-US" sz="1575" strike="noStrike" u="none">
                   <a:solidFill>
-                    <a:srgbClr val="AAB6C6"/>
+                    <a:srgbClr val="3C4A5C"/>
                   </a:solidFill>
                   <a:latin typeface="IBM Plex Sans"/>
                   <a:ea typeface="IBM Plex Sans"/>
@@ -8744,7 +8744,7 @@
               <a:r>
                 <a:rPr lang="en-US" sz="1575" strike="noStrike" u="none">
                   <a:solidFill>
-                    <a:srgbClr val="AAB6C6"/>
+                    <a:srgbClr val="3C4A5C"/>
                   </a:solidFill>
                   <a:latin typeface="IBM Plex Sans"/>
                   <a:ea typeface="IBM Plex Sans"/>
@@ -8788,7 +8788,7 @@
               <a:r>
                 <a:rPr lang="en-US" sz="1575" strike="noStrike" u="none">
                   <a:solidFill>
-                    <a:srgbClr val="AAB6C6"/>
+                    <a:srgbClr val="3C4A5C"/>
                   </a:solidFill>
                   <a:latin typeface="IBM Plex Sans"/>
                   <a:ea typeface="IBM Plex Sans"/>
@@ -8815,7 +8815,7 @@
     <p:bg>
       <p:bgPr>
         <a:solidFill>
-          <a:srgbClr val="16243A"/>
+          <a:srgbClr val="EDF1F6"/>
         </a:solidFill>
       </p:bgPr>
     </p:bg>
@@ -8949,7 +8949,7 @@
             <a:r>
               <a:rPr lang="en-US" sz="1350">
                 <a:solidFill>
-                  <a:srgbClr val="AAB6C6"/>
+                  <a:srgbClr val="8A98AA"/>
                 </a:solidFill>
                 <a:latin typeface="JetBrains Mono"/>
                 <a:ea typeface="JetBrains Mono"/>
@@ -8990,7 +8990,7 @@
             <a:r>
               <a:rPr lang="en-US" sz="4800" b="true">
                 <a:solidFill>
-                  <a:srgbClr val="F4F7FB"/>
+                  <a:srgbClr val="1B2A3F"/>
                 </a:solidFill>
                 <a:latin typeface="IBM Plex Sans Bold"/>
                 <a:ea typeface="IBM Plex Sans Bold"/>
@@ -9075,7 +9075,7 @@
             <a:r>
               <a:rPr lang="en-US" b="true" sz="2250" strike="noStrike" u="none">
                 <a:solidFill>
-                  <a:srgbClr val="F4F7FB"/>
+                  <a:srgbClr val="1B2A3F"/>
                 </a:solidFill>
                 <a:latin typeface="IBM Plex Sans Bold"/>
                 <a:ea typeface="IBM Plex Sans Bold"/>
@@ -9160,7 +9160,7 @@
             <a:r>
               <a:rPr lang="en-US" b="true" sz="2250" strike="noStrike" u="none">
                 <a:solidFill>
-                  <a:srgbClr val="F4F7FB"/>
+                  <a:srgbClr val="1B2A3F"/>
                 </a:solidFill>
                 <a:latin typeface="IBM Plex Sans Bold"/>
                 <a:ea typeface="IBM Plex Sans Bold"/>
@@ -9245,7 +9245,7 @@
             <a:r>
               <a:rPr lang="en-US" b="true" sz="2250" strike="noStrike" u="none">
                 <a:solidFill>
-                  <a:srgbClr val="F4F7FB"/>
+                  <a:srgbClr val="1B2A3F"/>
                 </a:solidFill>
                 <a:latin typeface="IBM Plex Sans Bold"/>
                 <a:ea typeface="IBM Plex Sans Bold"/>
@@ -9330,7 +9330,7 @@
             <a:r>
               <a:rPr lang="en-US" b="true" sz="2250" strike="noStrike" u="none">
                 <a:solidFill>
-                  <a:srgbClr val="F4F7FB"/>
+                  <a:srgbClr val="1B2A3F"/>
                 </a:solidFill>
                 <a:latin typeface="IBM Plex Sans Bold"/>
                 <a:ea typeface="IBM Plex Sans Bold"/>
@@ -9374,7 +9374,7 @@
             <a:r>
               <a:rPr lang="en-US" sz="1650" strike="noStrike" u="none">
                 <a:solidFill>
-                  <a:srgbClr val="AAB6C6"/>
+                  <a:srgbClr val="3C4A5C"/>
                 </a:solidFill>
                 <a:latin typeface="IBM Plex Sans"/>
                 <a:ea typeface="IBM Plex Sans"/>
@@ -9400,7 +9400,7 @@
     <p:bg>
       <p:bgPr>
         <a:solidFill>
-          <a:srgbClr val="16243A"/>
+          <a:srgbClr val="EDF1F6"/>
         </a:solidFill>
       </p:bgPr>
     </p:bg>
@@ -9534,7 +9534,7 @@
             <a:r>
               <a:rPr lang="en-US" sz="1350">
                 <a:solidFill>
-                  <a:srgbClr val="AAB6C6"/>
+                  <a:srgbClr val="8A98AA"/>
                 </a:solidFill>
                 <a:latin typeface="JetBrains Mono"/>
                 <a:ea typeface="JetBrains Mono"/>
@@ -9575,7 +9575,7 @@
             <a:r>
               <a:rPr lang="en-US" sz="5400" b="true">
                 <a:solidFill>
-                  <a:srgbClr val="F4F7FB"/>
+                  <a:srgbClr val="1B2A3F"/>
                 </a:solidFill>
                 <a:latin typeface="IBM Plex Sans Bold"/>
                 <a:ea typeface="IBM Plex Sans Bold"/>
@@ -9594,7 +9594,7 @@
             <a:r>
               <a:rPr lang="en-US" sz="5400" b="true">
                 <a:solidFill>
-                  <a:srgbClr val="F4F7FB"/>
+                  <a:srgbClr val="1B2A3F"/>
                 </a:solidFill>
                 <a:latin typeface="IBM Plex Sans Bold"/>
                 <a:ea typeface="IBM Plex Sans Bold"/>
@@ -9638,7 +9638,7 @@
             <a:r>
               <a:rPr lang="en-US" sz="2100" strike="noStrike" u="none">
                 <a:solidFill>
-                  <a:srgbClr val="AAB6C6"/>
+                  <a:srgbClr val="3C4A5C"/>
                 </a:solidFill>
                 <a:latin typeface="IBM Plex Sans"/>
                 <a:ea typeface="IBM Plex Sans"/>
@@ -9670,7 +9670,7 @@
             <a:r>
               <a:rPr lang="en-US" sz="2100" strike="noStrike" u="none">
                 <a:solidFill>
-                  <a:srgbClr val="AAB6C6"/>
+                  <a:srgbClr val="3C4A5C"/>
                 </a:solidFill>
                 <a:latin typeface="IBM Plex Sans"/>
                 <a:ea typeface="IBM Plex Sans"/>
@@ -9801,7 +9801,7 @@
             <a:r>
               <a:rPr lang="en-US" b="true" sz="3900" strike="noStrike" u="none">
                 <a:solidFill>
-                  <a:srgbClr val="F4F7FB"/>
+                  <a:srgbClr val="1B2A3F"/>
                 </a:solidFill>
                 <a:latin typeface="IBM Plex Sans Bold"/>
                 <a:ea typeface="IBM Plex Sans Bold"/>
@@ -9827,7 +9827,7 @@
     <p:bg>
       <p:bgPr>
         <a:solidFill>
-          <a:srgbClr val="0F1C2E"/>
+          <a:srgbClr val="F7F9FC"/>
         </a:solidFill>
       </p:bgPr>
     </p:bg>
@@ -9961,7 +9961,7 @@
             <a:r>
               <a:rPr lang="en-US" sz="1350">
                 <a:solidFill>
-                  <a:srgbClr val="AAB6C6"/>
+                  <a:srgbClr val="8A98AA"/>
                 </a:solidFill>
                 <a:latin typeface="JetBrains Mono"/>
                 <a:ea typeface="JetBrains Mono"/>
@@ -10002,7 +10002,7 @@
             <a:r>
               <a:rPr lang="en-US" sz="4800" b="true">
                 <a:solidFill>
-                  <a:srgbClr val="F4F7FB"/>
+                  <a:srgbClr val="1B2A3F"/>
                 </a:solidFill>
                 <a:latin typeface="IBM Plex Sans Bold"/>
                 <a:ea typeface="IBM Plex Sans Bold"/>
@@ -10078,11 +10078,11 @@
                 </a:pathLst>
               </a:custGeom>
               <a:solidFill>
-                <a:srgbClr val="192A42"/>
+                <a:srgbClr val="FFFFFF"/>
               </a:solidFill>
               <a:ln w="9525" cap="sq">
                 <a:solidFill>
-                  <a:srgbClr val="34465D"/>
+                  <a:srgbClr val="D4DCE6"/>
                 </a:solidFill>
                 <a:prstDash val="solid"/>
                 <a:miter/>
@@ -10133,7 +10133,7 @@
             </a:prstGeom>
             <a:ln cap="flat" w="12700">
               <a:solidFill>
-                <a:srgbClr val="34465D"/>
+                <a:srgbClr val="D4DCE6"/>
               </a:solidFill>
               <a:prstDash val="solid"/>
               <a:headEnd type="none" len="sm" w="sm"/>
@@ -10181,7 +10181,7 @@
             </a:prstGeom>
             <a:ln cap="flat" w="12700">
               <a:solidFill>
-                <a:srgbClr val="34465D"/>
+                <a:srgbClr val="D4DCE6"/>
               </a:solidFill>
               <a:prstDash val="solid"/>
               <a:headEnd type="none" len="sm" w="sm"/>
@@ -10205,7 +10205,7 @@
             </a:prstGeom>
             <a:ln cap="flat" w="12700">
               <a:solidFill>
-                <a:srgbClr val="34465D"/>
+                <a:srgbClr val="D4DCE6"/>
               </a:solidFill>
               <a:prstDash val="solid"/>
               <a:headEnd type="none" len="sm" w="sm"/>
@@ -10229,7 +10229,7 @@
             </a:prstGeom>
             <a:ln cap="flat" w="12700">
               <a:solidFill>
-                <a:srgbClr val="34465D"/>
+                <a:srgbClr val="D4DCE6"/>
               </a:solidFill>
               <a:prstDash val="solid"/>
               <a:headEnd type="none" len="sm" w="sm"/>
@@ -10351,7 +10351,7 @@
               <a:r>
                 <a:rPr lang="en-US" sz="1800" strike="noStrike" u="none">
                   <a:solidFill>
-                    <a:srgbClr val="AAB6C6"/>
+                    <a:srgbClr val="3C4A5C"/>
                   </a:solidFill>
                   <a:latin typeface="IBM Plex Sans"/>
                   <a:ea typeface="IBM Plex Sans"/>
@@ -10395,7 +10395,7 @@
               <a:r>
                 <a:rPr lang="en-US" sz="1800" strike="noStrike" u="none">
                   <a:solidFill>
-                    <a:srgbClr val="AAB6C6"/>
+                    <a:srgbClr val="3C4A5C"/>
                   </a:solidFill>
                   <a:latin typeface="IBM Plex Sans"/>
                   <a:ea typeface="IBM Plex Sans"/>
@@ -10439,7 +10439,7 @@
               <a:r>
                 <a:rPr lang="en-US" sz="1800" strike="noStrike" u="none">
                   <a:solidFill>
-                    <a:srgbClr val="AAB6C6"/>
+                    <a:srgbClr val="3C4A5C"/>
                   </a:solidFill>
                   <a:latin typeface="IBM Plex Sans"/>
                   <a:ea typeface="IBM Plex Sans"/>
@@ -10483,7 +10483,7 @@
               <a:r>
                 <a:rPr lang="en-US" sz="1800" strike="noStrike" u="none">
                   <a:solidFill>
-                    <a:srgbClr val="AAB6C6"/>
+                    <a:srgbClr val="3C4A5C"/>
                   </a:solidFill>
                   <a:latin typeface="IBM Plex Sans"/>
                   <a:ea typeface="IBM Plex Sans"/>
@@ -10527,7 +10527,7 @@
               <a:r>
                 <a:rPr lang="en-US" sz="1800" strike="noStrike" u="none">
                   <a:solidFill>
-                    <a:srgbClr val="AAB6C6"/>
+                    <a:srgbClr val="3C4A5C"/>
                   </a:solidFill>
                   <a:latin typeface="IBM Plex Sans"/>
                   <a:ea typeface="IBM Plex Sans"/>
@@ -10571,7 +10571,7 @@
               <a:r>
                 <a:rPr lang="en-US" sz="1800" strike="noStrike" u="none">
                   <a:solidFill>
-                    <a:srgbClr val="AAB6C6"/>
+                    <a:srgbClr val="3C4A5C"/>
                   </a:solidFill>
                   <a:latin typeface="IBM Plex Sans"/>
                   <a:ea typeface="IBM Plex Sans"/>
@@ -10615,7 +10615,7 @@
               <a:r>
                 <a:rPr lang="en-US" sz="1800" strike="noStrike" u="none">
                   <a:solidFill>
-                    <a:srgbClr val="AAB6C6"/>
+                    <a:srgbClr val="3C4A5C"/>
                   </a:solidFill>
                   <a:latin typeface="IBM Plex Sans"/>
                   <a:ea typeface="IBM Plex Sans"/>
@@ -10659,7 +10659,7 @@
               <a:r>
                 <a:rPr lang="en-US" sz="1800" strike="noStrike" u="none">
                   <a:solidFill>
-                    <a:srgbClr val="AAB6C6"/>
+                    <a:srgbClr val="3C4A5C"/>
                   </a:solidFill>
                   <a:latin typeface="IBM Plex Sans"/>
                   <a:ea typeface="IBM Plex Sans"/>
@@ -10704,7 +10704,7 @@
             <a:r>
               <a:rPr lang="en-US" sz="1800" strike="noStrike" u="none">
                 <a:solidFill>
-                  <a:srgbClr val="AAB6C6"/>
+                  <a:srgbClr val="3C4A5C"/>
                 </a:solidFill>
                 <a:latin typeface="IBM Plex Sans"/>
                 <a:ea typeface="IBM Plex Sans"/>
@@ -10774,7 +10774,7 @@
     <p:bg>
       <p:bgPr>
         <a:solidFill>
-          <a:srgbClr val="16243A"/>
+          <a:srgbClr val="EDF1F6"/>
         </a:solidFill>
       </p:bgPr>
     </p:bg>
@@ -10908,7 +10908,7 @@
             <a:r>
               <a:rPr lang="en-US" sz="1350">
                 <a:solidFill>
-                  <a:srgbClr val="AAB6C6"/>
+                  <a:srgbClr val="8A98AA"/>
                 </a:solidFill>
                 <a:latin typeface="JetBrains Mono"/>
                 <a:ea typeface="JetBrains Mono"/>
@@ -10949,7 +10949,7 @@
             <a:r>
               <a:rPr lang="en-US" sz="4800" b="true">
                 <a:solidFill>
-                  <a:srgbClr val="F4F7FB"/>
+                  <a:srgbClr val="1B2A3F"/>
                 </a:solidFill>
                 <a:latin typeface="IBM Plex Sans Bold"/>
                 <a:ea typeface="IBM Plex Sans Bold"/>
@@ -10968,7 +10968,7 @@
             <a:r>
               <a:rPr lang="en-US" sz="4800" b="true">
                 <a:solidFill>
-                  <a:srgbClr val="F4F7FB"/>
+                  <a:srgbClr val="1B2A3F"/>
                 </a:solidFill>
                 <a:latin typeface="IBM Plex Sans Bold"/>
                 <a:ea typeface="IBM Plex Sans Bold"/>
@@ -11012,7 +11012,7 @@
             <a:r>
               <a:rPr lang="en-US" sz="1800" strike="noStrike" u="none">
                 <a:solidFill>
-                  <a:srgbClr val="F4F7FB"/>
+                  <a:srgbClr val="3C4A5C"/>
                 </a:solidFill>
                 <a:latin typeface="JetBrains Mono"/>
                 <a:ea typeface="JetBrains Mono"/>
@@ -11034,7 +11034,7 @@
             <a:r>
               <a:rPr lang="en-US" sz="1800" strike="noStrike" u="none">
                 <a:solidFill>
-                  <a:srgbClr val="F4F7FB"/>
+                  <a:srgbClr val="3C4A5C"/>
                 </a:solidFill>
                 <a:latin typeface="JetBrains Mono"/>
                 <a:ea typeface="JetBrains Mono"/>
@@ -11056,7 +11056,7 @@
             <a:r>
               <a:rPr lang="en-US" sz="1800" strike="noStrike" u="none">
                 <a:solidFill>
-                  <a:srgbClr val="F4F7FB"/>
+                  <a:srgbClr val="3C4A5C"/>
                 </a:solidFill>
                 <a:latin typeface="JetBrains Mono"/>
                 <a:ea typeface="JetBrains Mono"/>
@@ -11088,7 +11088,7 @@
             <a:r>
               <a:rPr lang="en-US" sz="1800" strike="noStrike" u="none">
                 <a:solidFill>
-                  <a:srgbClr val="F4F7FB"/>
+                  <a:srgbClr val="3C4A5C"/>
                 </a:solidFill>
                 <a:latin typeface="JetBrains Mono"/>
                 <a:ea typeface="JetBrains Mono"/>
@@ -11110,7 +11110,7 @@
             <a:r>
               <a:rPr lang="en-US" sz="1800" strike="noStrike" u="none">
                 <a:solidFill>
-                  <a:srgbClr val="F4F7FB"/>
+                  <a:srgbClr val="3C4A5C"/>
                 </a:solidFill>
                 <a:latin typeface="JetBrains Mono"/>
                 <a:ea typeface="JetBrains Mono"/>
@@ -11132,7 +11132,7 @@
             <a:r>
               <a:rPr lang="en-US" sz="1800" strike="noStrike" u="none">
                 <a:solidFill>
-                  <a:srgbClr val="F4F7FB"/>
+                  <a:srgbClr val="3C4A5C"/>
                 </a:solidFill>
                 <a:latin typeface="JetBrains Mono"/>
                 <a:ea typeface="JetBrains Mono"/>
@@ -11194,11 +11194,11 @@
               </a:pathLst>
             </a:custGeom>
             <a:solidFill>
-              <a:srgbClr val="16243A"/>
+              <a:srgbClr val="FFFFFF"/>
             </a:solidFill>
             <a:ln w="9525" cap="sq">
               <a:solidFill>
-                <a:srgbClr val="34465D"/>
+                <a:srgbClr val="D4DCE6"/>
               </a:solidFill>
               <a:prstDash val="lgDash"/>
               <a:miter/>
@@ -11265,7 +11265,7 @@
             <a:r>
               <a:rPr lang="en-US" sz="1575" strike="noStrike" u="none">
                 <a:solidFill>
-                  <a:srgbClr val="AAB6C6"/>
+                  <a:srgbClr val="3C4A5C"/>
                 </a:solidFill>
                 <a:latin typeface="JetBrains Mono"/>
                 <a:ea typeface="JetBrains Mono"/>
@@ -11337,7 +11337,7 @@
     <p:bg>
       <p:bgPr>
         <a:solidFill>
-          <a:srgbClr val="0F1C2E"/>
+          <a:srgbClr val="F7F9FC"/>
         </a:solidFill>
       </p:bgPr>
     </p:bg>
@@ -11471,7 +11471,7 @@
             <a:r>
               <a:rPr lang="en-US" sz="1350">
                 <a:solidFill>
-                  <a:srgbClr val="AAB6C6"/>
+                  <a:srgbClr val="8A98AA"/>
                 </a:solidFill>
                 <a:latin typeface="JetBrains Mono"/>
                 <a:ea typeface="JetBrains Mono"/>
@@ -11512,7 +11512,7 @@
             <a:r>
               <a:rPr lang="en-US" sz="4800" b="true">
                 <a:solidFill>
-                  <a:srgbClr val="F4F7FB"/>
+                  <a:srgbClr val="1B2A3F"/>
                 </a:solidFill>
                 <a:latin typeface="IBM Plex Sans Bold"/>
                 <a:ea typeface="IBM Plex Sans Bold"/>
@@ -11588,11 +11588,11 @@
                 </a:pathLst>
               </a:custGeom>
               <a:solidFill>
-                <a:srgbClr val="192A42"/>
+                <a:srgbClr val="FFFFFF"/>
               </a:solidFill>
               <a:ln w="9525" cap="sq">
                 <a:solidFill>
-                  <a:srgbClr val="34465D"/>
+                  <a:srgbClr val="D4DCE6"/>
                 </a:solidFill>
                 <a:prstDash val="solid"/>
                 <a:miter/>
@@ -11643,7 +11643,7 @@
             </a:prstGeom>
             <a:ln cap="flat" w="12700">
               <a:solidFill>
-                <a:srgbClr val="34465D"/>
+                <a:srgbClr val="D4DCE6"/>
               </a:solidFill>
               <a:prstDash val="solid"/>
               <a:headEnd type="none" len="sm" w="sm"/>
@@ -11691,7 +11691,7 @@
             </a:prstGeom>
             <a:ln cap="flat" w="12700">
               <a:solidFill>
-                <a:srgbClr val="34465D"/>
+                <a:srgbClr val="D4DCE6"/>
               </a:solidFill>
               <a:prstDash val="solid"/>
               <a:headEnd type="none" len="sm" w="sm"/>
@@ -11715,7 +11715,7 @@
             </a:prstGeom>
             <a:ln cap="flat" w="12700">
               <a:solidFill>
-                <a:srgbClr val="34465D"/>
+                <a:srgbClr val="D4DCE6"/>
               </a:solidFill>
               <a:prstDash val="solid"/>
               <a:headEnd type="none" len="sm" w="sm"/>
@@ -11739,7 +11739,7 @@
             </a:prstGeom>
             <a:ln cap="flat" w="12700">
               <a:solidFill>
-                <a:srgbClr val="34465D"/>
+                <a:srgbClr val="D4DCE6"/>
               </a:solidFill>
               <a:prstDash val="solid"/>
               <a:headEnd type="none" len="sm" w="sm"/>
@@ -11763,7 +11763,7 @@
             </a:prstGeom>
             <a:ln cap="flat" w="12700">
               <a:solidFill>
-                <a:srgbClr val="34465D"/>
+                <a:srgbClr val="D4DCE6"/>
               </a:solidFill>
               <a:prstDash val="solid"/>
               <a:headEnd type="none" len="sm" w="sm"/>
@@ -11822,7 +11822,7 @@
               </a:custGeom>
               <a:solidFill>
                 <a:srgbClr val="C0392B">
-                  <a:alpha val="17647"/>
+                  <a:alpha val="9804"/>
                 </a:srgbClr>
               </a:solidFill>
               <a:ln cap="sq">
@@ -11974,7 +11974,7 @@
               <a:r>
                 <a:rPr lang="en-US" sz="1575" strike="noStrike" u="none">
                   <a:solidFill>
-                    <a:srgbClr val="AAB6C6"/>
+                    <a:srgbClr val="3C4A5C"/>
                   </a:solidFill>
                   <a:latin typeface="IBM Plex Sans"/>
                   <a:ea typeface="IBM Plex Sans"/>
@@ -12018,7 +12018,7 @@
               <a:r>
                 <a:rPr lang="en-US" sz="1575" strike="noStrike" u="none">
                   <a:solidFill>
-                    <a:srgbClr val="AAB6C6"/>
+                    <a:srgbClr val="3C4A5C"/>
                   </a:solidFill>
                   <a:latin typeface="JetBrains Mono"/>
                   <a:ea typeface="JetBrains Mono"/>
@@ -12062,7 +12062,7 @@
               <a:r>
                 <a:rPr lang="en-US" sz="1575" strike="noStrike" u="none">
                   <a:solidFill>
-                    <a:srgbClr val="AAB6C6"/>
+                    <a:srgbClr val="3C4A5C"/>
                   </a:solidFill>
                   <a:latin typeface="IBM Plex Sans"/>
                   <a:ea typeface="IBM Plex Sans"/>
@@ -12106,7 +12106,7 @@
               <a:r>
                 <a:rPr lang="en-US" sz="1575" strike="noStrike" u="none">
                   <a:solidFill>
-                    <a:srgbClr val="AAB6C6"/>
+                    <a:srgbClr val="3C4A5C"/>
                   </a:solidFill>
                   <a:latin typeface="JetBrains Mono"/>
                   <a:ea typeface="JetBrains Mono"/>
@@ -12150,7 +12150,7 @@
               <a:r>
                 <a:rPr lang="en-US" sz="1575" strike="noStrike" u="none">
                   <a:solidFill>
-                    <a:srgbClr val="AAB6C6"/>
+                    <a:srgbClr val="3C4A5C"/>
                   </a:solidFill>
                   <a:latin typeface="IBM Plex Sans"/>
                   <a:ea typeface="IBM Plex Sans"/>
@@ -12194,7 +12194,7 @@
               <a:r>
                 <a:rPr lang="en-US" sz="1575" strike="noStrike" u="none">
                   <a:solidFill>
-                    <a:srgbClr val="AAB6C6"/>
+                    <a:srgbClr val="3C4A5C"/>
                   </a:solidFill>
                   <a:latin typeface="JetBrains Mono"/>
                   <a:ea typeface="JetBrains Mono"/>
@@ -12238,7 +12238,7 @@
               <a:r>
                 <a:rPr lang="en-US" sz="1575" strike="noStrike" u="none">
                   <a:solidFill>
-                    <a:srgbClr val="AAB6C6"/>
+                    <a:srgbClr val="3C4A5C"/>
                   </a:solidFill>
                   <a:latin typeface="IBM Plex Sans"/>
                   <a:ea typeface="IBM Plex Sans"/>
@@ -12282,7 +12282,7 @@
               <a:r>
                 <a:rPr lang="en-US" sz="1575" strike="noStrike" u="none">
                   <a:solidFill>
-                    <a:srgbClr val="AAB6C6"/>
+                    <a:srgbClr val="3C4A5C"/>
                   </a:solidFill>
                   <a:latin typeface="JetBrains Mono"/>
                   <a:ea typeface="JetBrains Mono"/>
@@ -12326,7 +12326,7 @@
               <a:r>
                 <a:rPr lang="en-US" b="true" sz="1575" strike="noStrike" u="none">
                   <a:solidFill>
-                    <a:srgbClr val="F4F7FB"/>
+                    <a:srgbClr val="1B2A3F"/>
                   </a:solidFill>
                   <a:latin typeface="IBM Plex Sans Bold"/>
                   <a:ea typeface="IBM Plex Sans Bold"/>
@@ -12370,7 +12370,7 @@
               <a:r>
                 <a:rPr lang="en-US" b="true" sz="1575" strike="noStrike" u="none">
                   <a:solidFill>
-                    <a:srgbClr val="F4F7FB"/>
+                    <a:srgbClr val="1B2A3F"/>
                   </a:solidFill>
                   <a:latin typeface="JetBrains Mono Bold"/>
                   <a:ea typeface="JetBrains Mono Bold"/>
@@ -12438,7 +12438,7 @@
     <p:bg>
       <p:bgPr>
         <a:solidFill>
-          <a:srgbClr val="16243A"/>
+          <a:srgbClr val="EDF1F6"/>
         </a:solidFill>
       </p:bgPr>
     </p:bg>
@@ -12572,7 +12572,7 @@
             <a:r>
               <a:rPr lang="en-US" sz="1350">
                 <a:solidFill>
-                  <a:srgbClr val="AAB6C6"/>
+                  <a:srgbClr val="8A98AA"/>
                 </a:solidFill>
                 <a:latin typeface="JetBrains Mono"/>
                 <a:ea typeface="JetBrains Mono"/>
@@ -12613,7 +12613,7 @@
             <a:r>
               <a:rPr lang="en-US" sz="4800" b="true">
                 <a:solidFill>
-                  <a:srgbClr val="F4F7FB"/>
+                  <a:srgbClr val="1B2A3F"/>
                 </a:solidFill>
                 <a:latin typeface="IBM Plex Sans Bold"/>
                 <a:ea typeface="IBM Plex Sans Bold"/>
@@ -12689,11 +12689,11 @@
                 </a:pathLst>
               </a:custGeom>
               <a:solidFill>
-                <a:srgbClr val="192A42"/>
+                <a:srgbClr val="FFFFFF"/>
               </a:solidFill>
               <a:ln w="9525" cap="sq">
                 <a:solidFill>
-                  <a:srgbClr val="34465D"/>
+                  <a:srgbClr val="D4DCE6"/>
                 </a:solidFill>
                 <a:prstDash val="solid"/>
                 <a:miter/>
@@ -12730,7 +12730,7 @@
                 <a:r>
                   <a:rPr lang="en-US" sz="1425" strike="noStrike" u="none">
                     <a:solidFill>
-                      <a:srgbClr val="F4F7FB"/>
+                      <a:srgbClr val="1B2A3F"/>
                     </a:solidFill>
                     <a:latin typeface="IBM Plex Sans"/>
                     <a:ea typeface="IBM Plex Sans"/>
@@ -12817,11 +12817,11 @@
                 </a:pathLst>
               </a:custGeom>
               <a:solidFill>
-                <a:srgbClr val="192A42"/>
+                <a:srgbClr val="FFFFFF"/>
               </a:solidFill>
               <a:ln w="9525" cap="sq">
                 <a:solidFill>
-                  <a:srgbClr val="34465D"/>
+                  <a:srgbClr val="D4DCE6"/>
                 </a:solidFill>
                 <a:prstDash val="solid"/>
                 <a:miter/>
@@ -12858,7 +12858,7 @@
                 <a:r>
                   <a:rPr lang="en-US" sz="1425" strike="noStrike" u="none">
                     <a:solidFill>
-                      <a:srgbClr val="F4F7FB"/>
+                      <a:srgbClr val="1B2A3F"/>
                     </a:solidFill>
                     <a:latin typeface="IBM Plex Sans"/>
                     <a:ea typeface="IBM Plex Sans"/>
@@ -12945,11 +12945,11 @@
                 </a:pathLst>
               </a:custGeom>
               <a:solidFill>
-                <a:srgbClr val="192A42"/>
+                <a:srgbClr val="FFFFFF"/>
               </a:solidFill>
               <a:ln w="9525" cap="sq">
                 <a:solidFill>
-                  <a:srgbClr val="34465D"/>
+                  <a:srgbClr val="D4DCE6"/>
                 </a:solidFill>
                 <a:prstDash val="solid"/>
                 <a:miter/>
@@ -12986,7 +12986,7 @@
                 <a:r>
                   <a:rPr lang="en-US" sz="1425" strike="noStrike" u="none">
                     <a:solidFill>
-                      <a:srgbClr val="F4F7FB"/>
+                      <a:srgbClr val="1B2A3F"/>
                     </a:solidFill>
                     <a:latin typeface="IBM Plex Sans"/>
                     <a:ea typeface="IBM Plex Sans"/>
@@ -13073,11 +13073,11 @@
                 </a:pathLst>
               </a:custGeom>
               <a:solidFill>
-                <a:srgbClr val="192A42"/>
+                <a:srgbClr val="FFFFFF"/>
               </a:solidFill>
               <a:ln w="9525" cap="sq">
                 <a:solidFill>
-                  <a:srgbClr val="34465D"/>
+                  <a:srgbClr val="D4DCE6"/>
                 </a:solidFill>
                 <a:prstDash val="solid"/>
                 <a:miter/>
@@ -13114,7 +13114,7 @@
                 <a:r>
                   <a:rPr lang="en-US" sz="1425" strike="noStrike" u="none">
                     <a:solidFill>
-                      <a:srgbClr val="F4F7FB"/>
+                      <a:srgbClr val="1B2A3F"/>
                     </a:solidFill>
                     <a:latin typeface="IBM Plex Sans"/>
                     <a:ea typeface="IBM Plex Sans"/>
@@ -13136,7 +13136,7 @@
                 <a:r>
                   <a:rPr lang="en-US" sz="1425" strike="noStrike" u="none">
                     <a:solidFill>
-                      <a:srgbClr val="F4F7FB"/>
+                      <a:srgbClr val="1B2A3F"/>
                     </a:solidFill>
                     <a:latin typeface="IBM Plex Sans"/>
                     <a:ea typeface="IBM Plex Sans"/>
@@ -13351,11 +13351,11 @@
                 </a:pathLst>
               </a:custGeom>
               <a:solidFill>
-                <a:srgbClr val="192A42"/>
+                <a:srgbClr val="FFFFFF"/>
               </a:solidFill>
               <a:ln w="9525" cap="sq">
                 <a:solidFill>
-                  <a:srgbClr val="34465D"/>
+                  <a:srgbClr val="D4DCE6"/>
                 </a:solidFill>
                 <a:prstDash val="solid"/>
                 <a:miter/>
@@ -13392,7 +13392,7 @@
                 <a:r>
                   <a:rPr lang="en-US" sz="1425" strike="noStrike" u="none">
                     <a:solidFill>
-                      <a:srgbClr val="F4F7FB"/>
+                      <a:srgbClr val="1B2A3F"/>
                     </a:solidFill>
                     <a:latin typeface="IBM Plex Sans"/>
                     <a:ea typeface="IBM Plex Sans"/>
@@ -13455,11 +13455,11 @@
                 </a:pathLst>
               </a:custGeom>
               <a:solidFill>
-                <a:srgbClr val="192A42"/>
+                <a:srgbClr val="FFFFFF"/>
               </a:solidFill>
               <a:ln w="9525" cap="sq">
                 <a:solidFill>
-                  <a:srgbClr val="34465D"/>
+                  <a:srgbClr val="D4DCE6"/>
                 </a:solidFill>
                 <a:prstDash val="solid"/>
                 <a:miter/>
@@ -13496,7 +13496,7 @@
                 <a:r>
                   <a:rPr lang="en-US" sz="1425" strike="noStrike" u="none">
                     <a:solidFill>
-                      <a:srgbClr val="F4F7FB"/>
+                      <a:srgbClr val="1B2A3F"/>
                     </a:solidFill>
                     <a:latin typeface="IBM Plex Sans"/>
                     <a:ea typeface="IBM Plex Sans"/>
@@ -13711,11 +13711,11 @@
                 </a:pathLst>
               </a:custGeom>
               <a:solidFill>
-                <a:srgbClr val="192A42"/>
+                <a:srgbClr val="FFFFFF"/>
               </a:solidFill>
               <a:ln w="9525" cap="sq">
                 <a:solidFill>
-                  <a:srgbClr val="34465D"/>
+                  <a:srgbClr val="D4DCE6"/>
                 </a:solidFill>
                 <a:prstDash val="solid"/>
                 <a:miter/>
@@ -13752,7 +13752,7 @@
                 <a:r>
                   <a:rPr lang="en-US" sz="1425" strike="noStrike" u="none">
                     <a:solidFill>
-                      <a:srgbClr val="F4F7FB"/>
+                      <a:srgbClr val="1B2A3F"/>
                     </a:solidFill>
                     <a:latin typeface="IBM Plex Sans"/>
                     <a:ea typeface="IBM Plex Sans"/>
@@ -13967,11 +13967,11 @@
                 </a:pathLst>
               </a:custGeom>
               <a:solidFill>
-                <a:srgbClr val="192A42"/>
+                <a:srgbClr val="FFFFFF"/>
               </a:solidFill>
               <a:ln w="9525" cap="sq">
                 <a:solidFill>
-                  <a:srgbClr val="34465D"/>
+                  <a:srgbClr val="D4DCE6"/>
                 </a:solidFill>
                 <a:prstDash val="solid"/>
                 <a:miter/>
@@ -14008,7 +14008,7 @@
                 <a:r>
                   <a:rPr lang="en-US" sz="1425" strike="noStrike" u="none">
                     <a:solidFill>
-                      <a:srgbClr val="F4F7FB"/>
+                      <a:srgbClr val="1B2A3F"/>
                     </a:solidFill>
                     <a:latin typeface="JetBrains Mono"/>
                     <a:ea typeface="JetBrains Mono"/>
@@ -14030,7 +14030,7 @@
                 <a:r>
                   <a:rPr lang="en-US" sz="1425" strike="noStrike" u="none">
                     <a:solidFill>
-                      <a:srgbClr val="F4F7FB"/>
+                      <a:srgbClr val="1B2A3F"/>
                     </a:solidFill>
                     <a:latin typeface="JetBrains Mono"/>
                     <a:ea typeface="JetBrains Mono"/>
@@ -14244,11 +14244,11 @@
               </a:pathLst>
             </a:custGeom>
             <a:solidFill>
-              <a:srgbClr val="16243A"/>
+              <a:srgbClr val="FFFFFF"/>
             </a:solidFill>
             <a:ln w="9525" cap="sq">
               <a:solidFill>
-                <a:srgbClr val="34465D"/>
+                <a:srgbClr val="D4DCE6"/>
               </a:solidFill>
               <a:prstDash val="lgDash"/>
               <a:miter/>
@@ -14315,7 +14315,7 @@
             <a:r>
               <a:rPr lang="en-US" sz="2250" strike="noStrike" u="none">
                 <a:solidFill>
-                  <a:srgbClr val="F4F7FB"/>
+                  <a:srgbClr val="3C4A5C"/>
                 </a:solidFill>
                 <a:latin typeface="JetBrains Mono"/>
                 <a:ea typeface="JetBrains Mono"/>
@@ -14347,7 +14347,7 @@
             <a:r>
               <a:rPr lang="en-US" sz="2250" strike="noStrike" u="none">
                 <a:solidFill>
-                  <a:srgbClr val="F4F7FB"/>
+                  <a:srgbClr val="3C4A5C"/>
                 </a:solidFill>
                 <a:latin typeface="JetBrains Mono"/>
                 <a:ea typeface="JetBrains Mono"/>
@@ -14373,7 +14373,7 @@
     <p:bg>
       <p:bgPr>
         <a:solidFill>
-          <a:srgbClr val="0F1C2E"/>
+          <a:srgbClr val="F7F9FC"/>
         </a:solidFill>
       </p:bgPr>
     </p:bg>
@@ -14507,7 +14507,7 @@
             <a:r>
               <a:rPr lang="en-US" sz="1350">
                 <a:solidFill>
-                  <a:srgbClr val="AAB6C6"/>
+                  <a:srgbClr val="8A98AA"/>
                 </a:solidFill>
                 <a:latin typeface="JetBrains Mono"/>
                 <a:ea typeface="JetBrains Mono"/>
@@ -14548,7 +14548,7 @@
             <a:r>
               <a:rPr lang="en-US" sz="4800" b="true">
                 <a:solidFill>
-                  <a:srgbClr val="F4F7FB"/>
+                  <a:srgbClr val="1B2A3F"/>
                 </a:solidFill>
                 <a:latin typeface="IBM Plex Sans Bold"/>
                 <a:ea typeface="IBM Plex Sans Bold"/>
@@ -14624,11 +14624,11 @@
                 </a:pathLst>
               </a:custGeom>
               <a:solidFill>
-                <a:srgbClr val="192A42"/>
+                <a:srgbClr val="FFFFFF"/>
               </a:solidFill>
               <a:ln w="9525" cap="sq">
                 <a:solidFill>
-                  <a:srgbClr val="34465D"/>
+                  <a:srgbClr val="D4DCE6"/>
                 </a:solidFill>
                 <a:prstDash val="solid"/>
                 <a:miter/>
@@ -14679,7 +14679,7 @@
             </a:prstGeom>
             <a:ln cap="flat" w="12700">
               <a:solidFill>
-                <a:srgbClr val="34465D"/>
+                <a:srgbClr val="D4DCE6"/>
               </a:solidFill>
               <a:prstDash val="solid"/>
               <a:headEnd type="none" len="sm" w="sm"/>
@@ -14703,7 +14703,7 @@
             </a:prstGeom>
             <a:ln cap="flat" w="12700">
               <a:solidFill>
-                <a:srgbClr val="34465D"/>
+                <a:srgbClr val="D4DCE6"/>
               </a:solidFill>
               <a:prstDash val="solid"/>
               <a:headEnd type="none" len="sm" w="sm"/>
@@ -14727,7 +14727,7 @@
             </a:prstGeom>
             <a:ln cap="flat" w="12700">
               <a:solidFill>
-                <a:srgbClr val="34465D"/>
+                <a:srgbClr val="D4DCE6"/>
               </a:solidFill>
               <a:prstDash val="solid"/>
               <a:headEnd type="none" len="sm" w="sm"/>
@@ -14751,7 +14751,7 @@
             </a:prstGeom>
             <a:ln cap="flat" w="12700">
               <a:solidFill>
-                <a:srgbClr val="34465D"/>
+                <a:srgbClr val="D4DCE6"/>
               </a:solidFill>
               <a:prstDash val="solid"/>
               <a:headEnd type="none" len="sm" w="sm"/>
@@ -14799,7 +14799,7 @@
             </a:prstGeom>
             <a:ln cap="flat" w="12700">
               <a:solidFill>
-                <a:srgbClr val="34465D"/>
+                <a:srgbClr val="D4DCE6"/>
               </a:solidFill>
               <a:prstDash val="solid"/>
               <a:headEnd type="none" len="sm" w="sm"/>
@@ -14823,7 +14823,7 @@
             </a:prstGeom>
             <a:ln cap="flat" w="12700">
               <a:solidFill>
-                <a:srgbClr val="34465D"/>
+                <a:srgbClr val="D4DCE6"/>
               </a:solidFill>
               <a:prstDash val="solid"/>
               <a:headEnd type="none" len="sm" w="sm"/>
@@ -14847,7 +14847,7 @@
             </a:prstGeom>
             <a:ln cap="flat" w="12700">
               <a:solidFill>
-                <a:srgbClr val="34465D"/>
+                <a:srgbClr val="D4DCE6"/>
               </a:solidFill>
               <a:prstDash val="solid"/>
               <a:headEnd type="none" len="sm" w="sm"/>
@@ -14871,7 +14871,7 @@
             </a:prstGeom>
             <a:ln cap="flat" w="12700">
               <a:solidFill>
-                <a:srgbClr val="34465D"/>
+                <a:srgbClr val="D4DCE6"/>
               </a:solidFill>
               <a:prstDash val="solid"/>
               <a:headEnd type="none" len="sm" w="sm"/>
@@ -14930,7 +14930,7 @@
               </a:custGeom>
               <a:solidFill>
                 <a:srgbClr val="C0392B">
-                  <a:alpha val="17647"/>
+                  <a:alpha val="9804"/>
                 </a:srgbClr>
               </a:solidFill>
               <a:ln cap="sq">
@@ -15205,7 +15205,7 @@
               <a:r>
                 <a:rPr lang="en-US" sz="1575" strike="noStrike" u="none">
                   <a:solidFill>
-                    <a:srgbClr val="AAB6C6"/>
+                    <a:srgbClr val="3C4A5C"/>
                   </a:solidFill>
                   <a:latin typeface="JetBrains Mono"/>
                   <a:ea typeface="JetBrains Mono"/>
@@ -15249,7 +15249,7 @@
               <a:r>
                 <a:rPr lang="en-US" sz="1575" strike="noStrike" u="none">
                   <a:solidFill>
-                    <a:srgbClr val="AAB6C6"/>
+                    <a:srgbClr val="3C4A5C"/>
                   </a:solidFill>
                   <a:latin typeface="IBM Plex Sans"/>
                   <a:ea typeface="IBM Plex Sans"/>
@@ -15293,7 +15293,7 @@
               <a:r>
                 <a:rPr lang="en-US" sz="1575" strike="noStrike" u="none">
                   <a:solidFill>
-                    <a:srgbClr val="AAB6C6"/>
+                    <a:srgbClr val="3C4A5C"/>
                   </a:solidFill>
                   <a:latin typeface="IBM Plex Sans"/>
                   <a:ea typeface="IBM Plex Sans"/>
@@ -15337,7 +15337,7 @@
               <a:r>
                 <a:rPr lang="en-US" sz="1575" strike="noStrike" u="none">
                   <a:solidFill>
-                    <a:srgbClr val="AAB6C6"/>
+                    <a:srgbClr val="3C4A5C"/>
                   </a:solidFill>
                   <a:latin typeface="JetBrains Mono"/>
                   <a:ea typeface="JetBrains Mono"/>
@@ -15381,7 +15381,7 @@
               <a:r>
                 <a:rPr lang="en-US" sz="1575" strike="noStrike" u="none">
                   <a:solidFill>
-                    <a:srgbClr val="AAB6C6"/>
+                    <a:srgbClr val="3C4A5C"/>
                   </a:solidFill>
                   <a:latin typeface="JetBrains Mono"/>
                   <a:ea typeface="JetBrains Mono"/>
@@ -15425,7 +15425,7 @@
               <a:r>
                 <a:rPr lang="en-US" sz="1575" strike="noStrike" u="none">
                   <a:solidFill>
-                    <a:srgbClr val="AAB6C6"/>
+                    <a:srgbClr val="3C4A5C"/>
                   </a:solidFill>
                   <a:latin typeface="JetBrains Mono"/>
                   <a:ea typeface="JetBrains Mono"/>
@@ -15469,7 +15469,7 @@
               <a:r>
                 <a:rPr lang="en-US" sz="1575" strike="noStrike" u="none">
                   <a:solidFill>
-                    <a:srgbClr val="AAB6C6"/>
+                    <a:srgbClr val="3C4A5C"/>
                   </a:solidFill>
                   <a:latin typeface="IBM Plex Sans"/>
                   <a:ea typeface="IBM Plex Sans"/>
@@ -15513,7 +15513,7 @@
               <a:r>
                 <a:rPr lang="en-US" sz="1575" strike="noStrike" u="none">
                   <a:solidFill>
-                    <a:srgbClr val="AAB6C6"/>
+                    <a:srgbClr val="3C4A5C"/>
                   </a:solidFill>
                   <a:latin typeface="IBM Plex Sans"/>
                   <a:ea typeface="IBM Plex Sans"/>
@@ -15557,7 +15557,7 @@
               <a:r>
                 <a:rPr lang="en-US" sz="1575" strike="noStrike" u="none">
                   <a:solidFill>
-                    <a:srgbClr val="AAB6C6"/>
+                    <a:srgbClr val="3C4A5C"/>
                   </a:solidFill>
                   <a:latin typeface="JetBrains Mono"/>
                   <a:ea typeface="JetBrains Mono"/>
@@ -15601,7 +15601,7 @@
               <a:r>
                 <a:rPr lang="en-US" sz="1575" strike="noStrike" u="none">
                   <a:solidFill>
-                    <a:srgbClr val="AAB6C6"/>
+                    <a:srgbClr val="3C4A5C"/>
                   </a:solidFill>
                   <a:latin typeface="JetBrains Mono"/>
                   <a:ea typeface="JetBrains Mono"/>
@@ -15645,7 +15645,7 @@
               <a:r>
                 <a:rPr lang="en-US" sz="1575" strike="noStrike" u="none">
                   <a:solidFill>
-                    <a:srgbClr val="AAB6C6"/>
+                    <a:srgbClr val="3C4A5C"/>
                   </a:solidFill>
                   <a:latin typeface="JetBrains Mono"/>
                   <a:ea typeface="JetBrains Mono"/>
@@ -15689,7 +15689,7 @@
               <a:r>
                 <a:rPr lang="en-US" sz="1575" strike="noStrike" u="none">
                   <a:solidFill>
-                    <a:srgbClr val="AAB6C6"/>
+                    <a:srgbClr val="3C4A5C"/>
                   </a:solidFill>
                   <a:latin typeface="IBM Plex Sans"/>
                   <a:ea typeface="IBM Plex Sans"/>
@@ -15733,7 +15733,7 @@
               <a:r>
                 <a:rPr lang="en-US" sz="1575" strike="noStrike" u="none">
                   <a:solidFill>
-                    <a:srgbClr val="AAB6C6"/>
+                    <a:srgbClr val="3C4A5C"/>
                   </a:solidFill>
                   <a:latin typeface="IBM Plex Sans"/>
                   <a:ea typeface="IBM Plex Sans"/>
@@ -15777,7 +15777,7 @@
               <a:r>
                 <a:rPr lang="en-US" sz="1575" strike="noStrike" u="none">
                   <a:solidFill>
-                    <a:srgbClr val="AAB6C6"/>
+                    <a:srgbClr val="3C4A5C"/>
                   </a:solidFill>
                   <a:latin typeface="JetBrains Mono"/>
                   <a:ea typeface="JetBrains Mono"/>
@@ -15821,7 +15821,7 @@
               <a:r>
                 <a:rPr lang="en-US" sz="1575" strike="noStrike" u="none">
                   <a:solidFill>
-                    <a:srgbClr val="AAB6C6"/>
+                    <a:srgbClr val="3C4A5C"/>
                   </a:solidFill>
                   <a:latin typeface="JetBrains Mono"/>
                   <a:ea typeface="JetBrains Mono"/>
@@ -15865,7 +15865,7 @@
               <a:r>
                 <a:rPr lang="en-US" sz="1575" strike="noStrike" u="none">
                   <a:solidFill>
-                    <a:srgbClr val="AAB6C6"/>
+                    <a:srgbClr val="3C4A5C"/>
                   </a:solidFill>
                   <a:latin typeface="JetBrains Mono"/>
                   <a:ea typeface="JetBrains Mono"/>
@@ -15909,7 +15909,7 @@
               <a:r>
                 <a:rPr lang="en-US" sz="1575" strike="noStrike" u="none">
                   <a:solidFill>
-                    <a:srgbClr val="AAB6C6"/>
+                    <a:srgbClr val="3C4A5C"/>
                   </a:solidFill>
                   <a:latin typeface="IBM Plex Sans"/>
                   <a:ea typeface="IBM Plex Sans"/>
@@ -15953,7 +15953,7 @@
               <a:r>
                 <a:rPr lang="en-US" sz="1575" strike="noStrike" u="none">
                   <a:solidFill>
-                    <a:srgbClr val="AAB6C6"/>
+                    <a:srgbClr val="3C4A5C"/>
                   </a:solidFill>
                   <a:latin typeface="IBM Plex Sans"/>
                   <a:ea typeface="IBM Plex Sans"/>
@@ -15997,7 +15997,7 @@
               <a:r>
                 <a:rPr lang="en-US" sz="1575" strike="noStrike" u="none">
                   <a:solidFill>
-                    <a:srgbClr val="AAB6C6"/>
+                    <a:srgbClr val="3C4A5C"/>
                   </a:solidFill>
                   <a:latin typeface="JetBrains Mono"/>
                   <a:ea typeface="JetBrains Mono"/>
@@ -16041,7 +16041,7 @@
               <a:r>
                 <a:rPr lang="en-US" sz="1575" strike="noStrike" u="none">
                   <a:solidFill>
-                    <a:srgbClr val="AAB6C6"/>
+                    <a:srgbClr val="3C4A5C"/>
                   </a:solidFill>
                   <a:latin typeface="JetBrains Mono"/>
                   <a:ea typeface="JetBrains Mono"/>
@@ -16085,7 +16085,7 @@
               <a:r>
                 <a:rPr lang="en-US" b="true" sz="1575" strike="noStrike" u="none">
                   <a:solidFill>
-                    <a:srgbClr val="F4F7FB"/>
+                    <a:srgbClr val="1B2A3F"/>
                   </a:solidFill>
                   <a:latin typeface="JetBrains Mono Bold"/>
                   <a:ea typeface="JetBrains Mono Bold"/>
@@ -16129,7 +16129,7 @@
               <a:r>
                 <a:rPr lang="en-US" b="true" sz="1575" strike="noStrike" u="none">
                   <a:solidFill>
-                    <a:srgbClr val="F4F7FB"/>
+                    <a:srgbClr val="1B2A3F"/>
                   </a:solidFill>
                   <a:latin typeface="IBM Plex Sans Bold"/>
                   <a:ea typeface="IBM Plex Sans Bold"/>
@@ -16173,7 +16173,7 @@
               <a:r>
                 <a:rPr lang="en-US" b="true" sz="1575" strike="noStrike" u="none">
                   <a:solidFill>
-                    <a:srgbClr val="F4F7FB"/>
+                    <a:srgbClr val="1B2A3F"/>
                   </a:solidFill>
                   <a:latin typeface="IBM Plex Sans Bold"/>
                   <a:ea typeface="IBM Plex Sans Bold"/>
@@ -16217,7 +16217,7 @@
               <a:r>
                 <a:rPr lang="en-US" b="true" sz="1575" strike="noStrike" u="none">
                   <a:solidFill>
-                    <a:srgbClr val="F4F7FB"/>
+                    <a:srgbClr val="1B2A3F"/>
                   </a:solidFill>
                   <a:latin typeface="JetBrains Mono Bold"/>
                   <a:ea typeface="JetBrains Mono Bold"/>
@@ -16261,7 +16261,7 @@
               <a:r>
                 <a:rPr lang="en-US" b="true" sz="1575" strike="noStrike" u="none">
                   <a:solidFill>
-                    <a:srgbClr val="F4F7FB"/>
+                    <a:srgbClr val="1B2A3F"/>
                   </a:solidFill>
                   <a:latin typeface="JetBrains Mono Bold"/>
                   <a:ea typeface="JetBrains Mono Bold"/>
@@ -16288,7 +16288,7 @@
     <p:bg>
       <p:bgPr>
         <a:solidFill>
-          <a:srgbClr val="16243A"/>
+          <a:srgbClr val="EDF1F6"/>
         </a:solidFill>
       </p:bgPr>
     </p:bg>
@@ -16422,7 +16422,7 @@
             <a:r>
               <a:rPr lang="en-US" sz="1350">
                 <a:solidFill>
-                  <a:srgbClr val="AAB6C6"/>
+                  <a:srgbClr val="8A98AA"/>
                 </a:solidFill>
                 <a:latin typeface="JetBrains Mono"/>
                 <a:ea typeface="JetBrains Mono"/>
@@ -16463,7 +16463,7 @@
             <a:r>
               <a:rPr lang="en-US" b="true" sz="15750" spc="1260">
                 <a:solidFill>
-                  <a:srgbClr val="F4F7FB"/>
+                  <a:srgbClr val="1B2A3F"/>
                 </a:solidFill>
                 <a:latin typeface="IBM Plex Sans Bold"/>
                 <a:ea typeface="IBM Plex Sans Bold"/>
@@ -16620,7 +16620,7 @@
     <p:bg>
       <p:bgPr>
         <a:solidFill>
-          <a:srgbClr val="0F1C2E"/>
+          <a:srgbClr val="F7F9FC"/>
         </a:solidFill>
       </p:bgPr>
     </p:bg>
@@ -16754,7 +16754,7 @@
             <a:r>
               <a:rPr lang="en-US" sz="1350">
                 <a:solidFill>
-                  <a:srgbClr val="AAB6C6"/>
+                  <a:srgbClr val="8A98AA"/>
                 </a:solidFill>
                 <a:latin typeface="JetBrains Mono"/>
                 <a:ea typeface="JetBrains Mono"/>
@@ -16795,7 +16795,7 @@
             <a:r>
               <a:rPr lang="en-US" sz="4800" b="true">
                 <a:solidFill>
-                  <a:srgbClr val="F4F7FB"/>
+                  <a:srgbClr val="1B2A3F"/>
                 </a:solidFill>
                 <a:latin typeface="IBM Plex Sans Bold"/>
                 <a:ea typeface="IBM Plex Sans Bold"/>
@@ -16836,7 +16836,7 @@
             <a:r>
               <a:rPr lang="en-US" sz="12750" b="true">
                 <a:solidFill>
-                  <a:srgbClr val="F4F7FB"/>
+                  <a:srgbClr val="1B2A3F"/>
                 </a:solidFill>
                 <a:latin typeface="JetBrains Mono Bold"/>
                 <a:ea typeface="JetBrains Mono Bold"/>
@@ -16986,11 +16986,11 @@
               </a:pathLst>
             </a:custGeom>
             <a:solidFill>
-              <a:srgbClr val="0F1C2E"/>
+              <a:srgbClr val="FFFFFF"/>
             </a:solidFill>
             <a:ln w="9525" cap="sq">
               <a:solidFill>
-                <a:srgbClr val="34465D"/>
+                <a:srgbClr val="D4DCE6"/>
               </a:solidFill>
               <a:prstDash val="lgDash"/>
               <a:miter/>
@@ -17057,7 +17057,7 @@
             <a:r>
               <a:rPr lang="en-US" sz="1650" strike="noStrike" u="none">
                 <a:solidFill>
-                  <a:srgbClr val="34465D"/>
+                  <a:srgbClr val="8A98AA"/>
                 </a:solidFill>
                 <a:latin typeface="JetBrains Mono"/>
                 <a:ea typeface="JetBrains Mono"/>
@@ -17098,7 +17098,7 @@
             <a:r>
               <a:rPr lang="en-US" sz="1425">
                 <a:solidFill>
-                  <a:srgbClr val="AAB6C6"/>
+                  <a:srgbClr val="3C4A5C"/>
                 </a:solidFill>
                 <a:latin typeface="Arimo"/>
                 <a:ea typeface="Arimo"/>
@@ -17124,7 +17124,7 @@
             <a:r>
               <a:rPr lang="en-US" sz="1425">
                 <a:solidFill>
-                  <a:srgbClr val="AAB6C6"/>
+                  <a:srgbClr val="3C4A5C"/>
                 </a:solidFill>
                 <a:latin typeface="Arimo"/>
                 <a:ea typeface="Arimo"/>
@@ -17143,7 +17143,7 @@
             <a:r>
               <a:rPr lang="en-US" sz="1425">
                 <a:solidFill>
-                  <a:srgbClr val="AAB6C6"/>
+                  <a:srgbClr val="3C4A5C"/>
                 </a:solidFill>
                 <a:latin typeface="Arimo"/>
                 <a:ea typeface="Arimo"/>
@@ -17162,7 +17162,7 @@
             <a:r>
               <a:rPr lang="en-US" sz="1425">
                 <a:solidFill>
-                  <a:srgbClr val="AAB6C6"/>
+                  <a:srgbClr val="3C4A5C"/>
                 </a:solidFill>
                 <a:latin typeface="Arimo"/>
                 <a:ea typeface="Arimo"/>
@@ -17181,7 +17181,7 @@
             <a:r>
               <a:rPr lang="en-US" sz="1425">
                 <a:solidFill>
-                  <a:srgbClr val="AAB6C6"/>
+                  <a:srgbClr val="3C4A5C"/>
                 </a:solidFill>
                 <a:latin typeface="Arimo"/>
                 <a:ea typeface="Arimo"/>
@@ -17200,7 +17200,7 @@
             <a:r>
               <a:rPr lang="en-US" sz="1425">
                 <a:solidFill>
-                  <a:srgbClr val="AAB6C6"/>
+                  <a:srgbClr val="3C4A5C"/>
                 </a:solidFill>
                 <a:latin typeface="Arimo"/>
                 <a:ea typeface="Arimo"/>
@@ -17219,7 +17219,7 @@
             <a:r>
               <a:rPr lang="en-US" sz="1425">
                 <a:solidFill>
-                  <a:srgbClr val="AAB6C6"/>
+                  <a:srgbClr val="3C4A5C"/>
                 </a:solidFill>
                 <a:latin typeface="Arimo"/>
                 <a:ea typeface="Arimo"/>
@@ -17238,7 +17238,7 @@
             <a:r>
               <a:rPr lang="en-US" sz="1425">
                 <a:solidFill>
-                  <a:srgbClr val="AAB6C6"/>
+                  <a:srgbClr val="3C4A5C"/>
                 </a:solidFill>
                 <a:latin typeface="Arimo"/>
                 <a:ea typeface="Arimo"/>
@@ -17257,7 +17257,7 @@
             <a:r>
               <a:rPr lang="en-US" sz="1425">
                 <a:solidFill>
-                  <a:srgbClr val="AAB6C6"/>
+                  <a:srgbClr val="3C4A5C"/>
                 </a:solidFill>
                 <a:latin typeface="Arimo"/>
                 <a:ea typeface="Arimo"/>
@@ -17276,7 +17276,7 @@
             <a:r>
               <a:rPr lang="en-US" sz="1425">
                 <a:solidFill>
-                  <a:srgbClr val="AAB6C6"/>
+                  <a:srgbClr val="3C4A5C"/>
                 </a:solidFill>
                 <a:latin typeface="Arimo"/>
                 <a:ea typeface="Arimo"/>
@@ -17295,7 +17295,7 @@
             <a:r>
               <a:rPr lang="en-US" sz="1425">
                 <a:solidFill>
-                  <a:srgbClr val="AAB6C6"/>
+                  <a:srgbClr val="3C4A5C"/>
                 </a:solidFill>
                 <a:latin typeface="Arimo"/>
                 <a:ea typeface="Arimo"/>
@@ -17314,7 +17314,7 @@
             <a:r>
               <a:rPr lang="en-US" sz="1425">
                 <a:solidFill>
-                  <a:srgbClr val="AAB6C6"/>
+                  <a:srgbClr val="3C4A5C"/>
                 </a:solidFill>
                 <a:latin typeface="Arimo"/>
                 <a:ea typeface="Arimo"/>
@@ -17340,7 +17340,7 @@
             <a:r>
               <a:rPr lang="en-US" sz="1425">
                 <a:solidFill>
-                  <a:srgbClr val="AAB6C6"/>
+                  <a:srgbClr val="3C4A5C"/>
                 </a:solidFill>
                 <a:latin typeface="Arimo"/>
                 <a:ea typeface="Arimo"/>

</xml_diff>

<commit_message>
Slide 8: ghi chu va phu de theo demo 2 canh
Ghi chu nguoi noi slide 8 van ghi lich demo 4 canh cu (D1-D4). Doi sang
lich 2 canh ~3 phut kem checklist truoc khi bam gio. Phu de tren slide
ghi "KB1 -> KB6" trong khi demo chi chay KB2 va KB6, sua cho khop.

Co-Authored-By: Claude Opus 5.5 <noreply@anthropic.com>
</commit_message>
<xml_diff>
--- a/docs/SLIDE.pptx
+++ b/docs/SLIDE.pptx
@@ -2981,7 +2981,7 @@
           <a:p>
             <a:r>
               <a:rPr lang="en-US"/>
-              <a:t>5 GIÂY. "Chuyển sang màn hình live."</a:t>
+              <a:t>5 GIÂY. "Em xin chuyển sang demo trực tiếp."</a:t>
             </a:r>
           </a:p>
           <a:p>
@@ -2993,31 +2993,31 @@
           <a:p>
             <a:r>
               <a:rPr lang="en-US"/>
-              <a:t>DEMO 4 PHÚT theo docs/KICH_BAN_7P.md:</a:t>
+              <a:t>DEMO ~3 PHÚT, 2 CẢNH (docs/KICH_BAN_7P.md, lệnh ở docs/LENH_DEMO.txt):</a:t>
             </a:r>
           </a:p>
           <a:p>
             <a:r>
               <a:rPr lang="en-US"/>
-              <a:t>  D1 0:00–0:25  phân vùng (2 lệnh)</a:t>
+              <a:t>  Cảnh 0  0:00–0:15  docker compose ps — chỉ waf có "-&gt;"</a:t>
             </a:r>
           </a:p>
           <a:p>
             <a:r>
               <a:rPr lang="en-US"/>
-              <a:t>  D2 0:25–1:10  sửa điểm hợp lệ + step-up OTP</a:t>
+              <a:t>  Cảnh 1  0:15–1:15  KB2 cookie: curl.exe với $c → SESSION_CONTEXT_MISMATCH → gv01 bị đá ra → CRITICAL</a:t>
             </a:r>
           </a:p>
           <a:p>
             <a:r>
               <a:rPr lang="en-US"/>
-              <a:t>  D3 1:10–2:20  KB2 đánh cắp cookie</a:t>
+              <a:t>  Cảnh 2  1:15–2:35  KB6: toàn vẹn sạch → UPDATE DB → DB=10 / log=8.5 → DELETE bị permission denied</a:t>
             </a:r>
           </a:p>
           <a:p>
             <a:r>
               <a:rPr lang="en-US"/>
-              <a:t>  D4 2:20–3:45  KB6 insider sửa DB</a:t>
+              <a:t>  Cảnh 3  2:35–2:50  "25/25 PASS, bốn kịch bản còn lại chạy được ngay"</a:t>
             </a:r>
           </a:p>
           <a:p>
@@ -3029,13 +3029,37 @@
           <a:p>
             <a:r>
               <a:rPr lang="en-US"/>
-              <a:t>KB1 / KB3 / KB4 / KB5 để dành cho hỏi đáp.</a:t>
+              <a:t>NHỚ TRƯỚC KHI BẤM GIỜ:</a:t>
             </a:r>
           </a:p>
           <a:p>
             <a:r>
               <a:rPr lang="en-US"/>
-              <a:t>NHỚ TRƯỚC KHI BẤM GIỜ: gv01 và admin đã đăng nhập sẵn, đã chạy docker compose restart app, lệnh dán sẵn trong file text.</a:t>
+              <a:t>  - đã chạy node scripts/reset-demo.mjs</a:t>
+            </a:r>
+          </a:p>
+          <a:p>
+            <a:r>
+              <a:rPr lang="en-US"/>
+              <a:t>  - admin ở cửa sổ ẨN DANH, gv01 ở cửa sổ THƯỜNG</a:t>
+            </a:r>
+          </a:p>
+          <a:p>
+            <a:r>
+              <a:rPr lang="en-US"/>
+              <a:t>  - cookie gv01 đã cất vào $c, chạy cảnh 1 trong 15 phút</a:t>
+            </a:r>
+          </a:p>
+          <a:p>
+            <a:r>
+              <a:rPr lang="en-US"/>
+              <a:t/>
+            </a:r>
+          </a:p>
+          <a:p>
+            <a:r>
+              <a:rPr lang="en-US"/>
+              <a:t>cls trước mỗi lệnh. Ra kết quả thì DỪNG 3 GIÂY rồi mới nói.</a:t>
             </a:r>
           </a:p>
         </p:txBody>
@@ -6620,8 +6644,8 @@
         </p:nvSpPr>
         <p:spPr>
           <a:xfrm rot="0">
-            <a:off x="1047750" y="6229350"/>
-            <a:ext cx="10953750" cy="2091690"/>
+            <a:off x="1047750" y="5347212"/>
+            <a:ext cx="10953750" cy="3493036"/>
           </a:xfrm>
           <a:prstGeom prst="rect">
             <a:avLst/>
@@ -6635,14 +6659,14 @@
           <a:p>
             <a:pPr algn="l" marL="0" indent="0" lvl="0">
               <a:lnSpc>
-                <a:spcPts val="2790"/>
+                <a:spcPts val="3099"/>
               </a:lnSpc>
               <a:spcBef>
                 <a:spcPct val="0"/>
               </a:spcBef>
             </a:pPr>
             <a:r>
-              <a:rPr lang="en-US" sz="1800" strike="noStrike" u="none">
+              <a:rPr lang="en-US" sz="1999" strike="noStrike" u="none">
                 <a:solidFill>
                   <a:srgbClr val="3C4A5C"/>
                 </a:solidFill>
@@ -6657,14 +6681,14 @@
           <a:p>
             <a:pPr algn="l" marL="0" indent="0" lvl="0">
               <a:lnSpc>
-                <a:spcPts val="2790"/>
+                <a:spcPts val="3099"/>
               </a:lnSpc>
               <a:spcBef>
                 <a:spcPct val="0"/>
               </a:spcBef>
             </a:pPr>
             <a:r>
-              <a:rPr lang="en-US" sz="1800" strike="noStrike" u="none">
+              <a:rPr lang="en-US" sz="1999" strike="noStrike" u="none">
                 <a:solidFill>
                   <a:srgbClr val="3C4A5C"/>
                 </a:solidFill>
@@ -6679,7 +6703,7 @@
           <a:p>
             <a:pPr algn="l" marL="0" indent="0" lvl="0">
               <a:lnSpc>
-                <a:spcPts val="2790"/>
+                <a:spcPts val="3099"/>
               </a:lnSpc>
               <a:spcBef>
                 <a:spcPct val="0"/>
@@ -6689,14 +6713,14 @@
           <a:p>
             <a:pPr algn="l" marL="0" indent="0" lvl="0">
               <a:lnSpc>
-                <a:spcPts val="2790"/>
+                <a:spcPts val="3099"/>
               </a:lnSpc>
               <a:spcBef>
                 <a:spcPct val="0"/>
               </a:spcBef>
             </a:pPr>
             <a:r>
-              <a:rPr lang="en-US" sz="1800" strike="noStrike" u="none">
+              <a:rPr lang="en-US" sz="1999" strike="noStrike" u="none">
                 <a:solidFill>
                   <a:srgbClr val="3C4A5C"/>
                 </a:solidFill>
@@ -6705,20 +6729,20 @@
                 <a:cs typeface="JetBrains Mono"/>
                 <a:sym typeface="JetBrains Mono"/>
               </a:rPr>
-              <a:t>Nhóm: ____________________</a:t>
+              <a:t>Nhóm: 5</a:t>
             </a:r>
           </a:p>
           <a:p>
             <a:pPr algn="l" marL="0" indent="0" lvl="0">
               <a:lnSpc>
-                <a:spcPts val="2790"/>
+                <a:spcPts val="3099"/>
               </a:lnSpc>
               <a:spcBef>
                 <a:spcPct val="0"/>
               </a:spcBef>
             </a:pPr>
             <a:r>
-              <a:rPr lang="en-US" sz="1800" strike="noStrike" u="none">
+              <a:rPr lang="en-US" sz="1999" strike="noStrike" u="none">
                 <a:solidFill>
                   <a:srgbClr val="3C4A5C"/>
                 </a:solidFill>
@@ -6727,20 +6751,20 @@
                 <a:cs typeface="JetBrains Mono"/>
                 <a:sym typeface="JetBrains Mono"/>
               </a:rPr>
-              <a:t>Thành viên: ____________________</a:t>
+              <a:t>Thành viên: Trần Trung Hiếu    1150080052</a:t>
             </a:r>
           </a:p>
           <a:p>
             <a:pPr algn="l" marL="0" indent="0" lvl="0">
               <a:lnSpc>
-                <a:spcPts val="2790"/>
+                <a:spcPts val="3099"/>
               </a:lnSpc>
               <a:spcBef>
                 <a:spcPct val="0"/>
               </a:spcBef>
             </a:pPr>
             <a:r>
-              <a:rPr lang="en-US" sz="1800" strike="noStrike" u="none">
+              <a:rPr lang="en-US" sz="1999" strike="noStrike" u="none">
                 <a:solidFill>
                   <a:srgbClr val="3C4A5C"/>
                 </a:solidFill>
@@ -6749,7 +6773,73 @@
                 <a:cs typeface="JetBrains Mono"/>
                 <a:sym typeface="JetBrains Mono"/>
               </a:rPr>
-              <a:t>GVHD: ____________________</a:t>
+              <a:t>            Lưu Gia Luân       1150080060</a:t>
+            </a:r>
+          </a:p>
+          <a:p>
+            <a:pPr algn="l" marL="0" indent="0" lvl="0">
+              <a:lnSpc>
+                <a:spcPts val="3099"/>
+              </a:lnSpc>
+              <a:spcBef>
+                <a:spcPct val="0"/>
+              </a:spcBef>
+            </a:pPr>
+            <a:r>
+              <a:rPr lang="en-US" sz="1999" strike="noStrike" u="none">
+                <a:solidFill>
+                  <a:srgbClr val="3C4A5C"/>
+                </a:solidFill>
+                <a:latin typeface="JetBrains Mono"/>
+                <a:ea typeface="JetBrains Mono"/>
+                <a:cs typeface="JetBrains Mono"/>
+                <a:sym typeface="JetBrains Mono"/>
+              </a:rPr>
+              <a:t>            Lương Hào Minh     1150080066</a:t>
+            </a:r>
+          </a:p>
+          <a:p>
+            <a:pPr algn="l" marL="0" indent="0" lvl="0">
+              <a:lnSpc>
+                <a:spcPts val="3099"/>
+              </a:lnSpc>
+              <a:spcBef>
+                <a:spcPct val="0"/>
+              </a:spcBef>
+            </a:pPr>
+            <a:r>
+              <a:rPr lang="en-US" sz="1999" strike="noStrike" u="none">
+                <a:solidFill>
+                  <a:srgbClr val="3C4A5C"/>
+                </a:solidFill>
+                <a:latin typeface="JetBrains Mono"/>
+                <a:ea typeface="JetBrains Mono"/>
+                <a:cs typeface="JetBrains Mono"/>
+                <a:sym typeface="JetBrains Mono"/>
+              </a:rPr>
+              <a:t>            Trần Hồ Quang Vinh 1150080082</a:t>
+            </a:r>
+          </a:p>
+          <a:p>
+            <a:pPr algn="l" marL="0" indent="0" lvl="0">
+              <a:lnSpc>
+                <a:spcPts val="3099"/>
+              </a:lnSpc>
+              <a:spcBef>
+                <a:spcPct val="0"/>
+              </a:spcBef>
+            </a:pPr>
+            <a:r>
+              <a:rPr lang="en-US" sz="1999" strike="noStrike" u="none">
+                <a:solidFill>
+                  <a:srgbClr val="3C4A5C"/>
+                </a:solidFill>
+                <a:latin typeface="JetBrains Mono"/>
+                <a:ea typeface="JetBrains Mono"/>
+                <a:cs typeface="JetBrains Mono"/>
+                <a:sym typeface="JetBrains Mono"/>
+              </a:rPr>
+              <a:t>GVHD: Th.S Hà Châu Hoàng</a:t>
             </a:r>
           </a:p>
         </p:txBody>
@@ -9822,7 +9912,7 @@
 </file>
 
 <file path=ppt/slides/slide3.xml><?xml version="1.0" encoding="utf-8"?>
-<p:sld xmlns:p="http://schemas.openxmlformats.org/presentationml/2006/main" xmlns:a="http://schemas.openxmlformats.org/drawingml/2006/main">
+<p:sld xmlns:p="http://schemas.openxmlformats.org/presentationml/2006/main" xmlns:a="http://schemas.openxmlformats.org/drawingml/2006/main" show="false">
   <p:cSld>
     <p:bg>
       <p:bgPr>
@@ -12433,7 +12523,7 @@
 </file>
 
 <file path=ppt/slides/slide6.xml><?xml version="1.0" encoding="utf-8"?>
-<p:sld xmlns:p="http://schemas.openxmlformats.org/presentationml/2006/main" xmlns:a="http://schemas.openxmlformats.org/drawingml/2006/main">
+<p:sld xmlns:p="http://schemas.openxmlformats.org/presentationml/2006/main" xmlns:a="http://schemas.openxmlformats.org/drawingml/2006/main" show="false">
   <p:cSld>
     <p:bg>
       <p:bgPr>
@@ -16601,7 +16691,7 @@
                 <a:cs typeface="JetBrains Mono"/>
                 <a:sym typeface="JetBrains Mono"/>
               </a:rPr>
-              <a:t>Chuyển sang màn hình live  ·  KB1 → KB6 trên hệ thống đang chạy</a:t>
+              <a:t>Màn hình live  ·  KB2 đánh cắp cookie  ·  KB6 insider sửa DB</a:t>
             </a:r>
           </a:p>
         </p:txBody>

</xml_diff>

<commit_message>
Them trang muc luc vao slide 2, danh so lai cac slide sau
- SLIDE.pptx (Canva): trang "Noi dung" 7 muc ngay sau trang bia; dong
  Demo to do de thay biet cho co phan trinh dien. So trang tren cac slide
  sau doi tu 02-12 thanh 03-13. Ghi chu nguoi noi dang nhac "slide 3/5/6
  da an" doi sang so moi. Tong gio phan noi 5:55 -> 6:05.
- Lan nay xuat lay luon thong tin nhom ma nhom da dien tren Canva.
- Tai lieu: moi cho ghi "slide N" (N >= 2) tang len mot; "an slide 3 va 6"
  thanh "an slide 4 va 7"; them dong muc luc vao bang thoi gian va phan
  loi noi.

Co-Authored-By: Claude Opus 5.5 <noreply@anthropic.com>
</commit_message>
<xml_diff>
--- a/docs/SLIDE.pptx
+++ b/docs/SLIDE.pptx
@@ -5,7 +5,7 @@
     <p:sldMasterId id="2147483648" r:id="rId1"/>
   </p:sldMasterIdLst>
   <p:notesMasterIdLst>
-    <p:notesMasterId r:id="rId18"/>
+    <p:notesMasterId r:id="rId19"/>
   </p:notesMasterIdLst>
   <p:sldIdLst>
     <p:sldId id="256" r:id="rId6"/>
@@ -20,33 +20,34 @@
     <p:sldId id="265" r:id="rId15"/>
     <p:sldId id="266" r:id="rId16"/>
     <p:sldId id="267" r:id="rId17"/>
+    <p:sldId id="268" r:id="rId18"/>
   </p:sldIdLst>
   <p:sldSz cx="18288000" cy="10287000"/>
   <p:notesSz cx="6858000" cy="9144000"/>
   <p:embeddedFontLst>
     <p:embeddedFont>
       <p:font typeface="JetBrains Mono" charset="1" panose="02010509020102050004"/>
-      <p:regular r:id="rId21"/>
+      <p:regular r:id="rId22"/>
     </p:embeddedFont>
     <p:embeddedFont>
       <p:font typeface="IBM Plex Sans Bold" charset="1" panose="020B0803050203000203"/>
-      <p:regular r:id="rId22"/>
+      <p:regular r:id="rId23"/>
     </p:embeddedFont>
     <p:embeddedFont>
       <p:font typeface="IBM Plex Sans" charset="1" panose="020B0503050203000203"/>
-      <p:regular r:id="rId23"/>
+      <p:regular r:id="rId24"/>
     </p:embeddedFont>
     <p:embeddedFont>
-      <p:font typeface="JetBrains Mono Bold" charset="1" panose="02010809030102050004"/>
+      <p:font typeface="Arimo" charset="1" panose="020B0604020202020204"/>
       <p:regular r:id="rId26"/>
     </p:embeddedFont>
     <p:embeddedFont>
       <p:font typeface="Arimo Bold" charset="1" panose="020B0704020202020204"/>
-      <p:regular r:id="rId29"/>
+      <p:regular r:id="rId27"/>
     </p:embeddedFont>
     <p:embeddedFont>
-      <p:font typeface="Arimo" charset="1" panose="020B0604020202020204"/>
-      <p:regular r:id="rId34"/>
+      <p:font typeface="JetBrains Mono Bold" charset="1" panose="02010809030102050004"/>
+      <p:regular r:id="rId30"/>
     </p:embeddedFont>
   </p:embeddedFontLst>
   <p:defaultTextStyle>
@@ -857,7 +858,7 @@
           <a:p>
             <a:r>
               <a:rPr lang="en-US"/>
-              <a:t>50 GIÂY. SLIDE GHI ĐIỂM.</a:t>
+              <a:t>25 GIÂY. 25/25 PASS · 6 luồng bình thường + 19 test tấn công · phủ KB1–KB6.</a:t>
             </a:r>
           </a:p>
           <a:p>
@@ -869,37 +870,7 @@
           <a:p>
             <a:r>
               <a:rPr lang="en-US"/>
-              <a:t>Chỉ đọc ba con số:</a:t>
-            </a:r>
-          </a:p>
-          <a:p>
-            <a:r>
-              <a:rPr lang="en-US"/>
-              <a:t>  1 sửa / 30 giây</a:t>
-            </a:r>
-          </a:p>
-          <a:p>
-            <a:r>
-              <a:rPr lang="en-US"/>
-              <a:t>  PL1 chặn oan 0/15</a:t>
-            </a:r>
-          </a:p>
-          <a:p>
-            <a:r>
-              <a:rPr lang="en-US"/>
-              <a:t>  RTO 5–6 giây</a:t>
-            </a:r>
-          </a:p>
-          <a:p>
-            <a:r>
-              <a:rPr lang="en-US"/>
-              <a:t/>
-            </a:r>
-          </a:p>
-          <a:p>
-            <a:r>
-              <a:rPr lang="en-US"/>
-              <a:t>DỄ VỠ NGÂN SÁCH: đừng kể quá trình đo, chỉ đọc kết quả.</a:t>
+              <a:t>Đừng đọc từng dòng trên màn hình — để thầy tự đọc.</a:t>
             </a:r>
           </a:p>
         </p:txBody>
@@ -1111,19 +1082,7 @@
           <a:p>
             <a:r>
               <a:rPr lang="en-US"/>
-              <a:t>25 GIÂY. Đọc nhanh đúng 2 dòng:</a:t>
-            </a:r>
-          </a:p>
-          <a:p>
-            <a:r>
-              <a:rPr lang="en-US"/>
-              <a:t>  TOTP không chống AiTM → Passkey/WebAuthn</a:t>
-            </a:r>
-          </a:p>
-          <a:p>
-            <a:r>
-              <a:rPr lang="en-US"/>
-              <a:t>  Superuser DB vẫn tính lại được hash-chain → SIEM + WORM</a:t>
+              <a:t>50 GIÂY. SLIDE GHI ĐIỂM.</a:t>
             </a:r>
           </a:p>
           <a:p>
@@ -1135,13 +1094,37 @@
           <a:p>
             <a:r>
               <a:rPr lang="en-US"/>
-              <a:t>DỄ VỠ NGÂN SÁCH: đừng xin lỗi dài dòng.</a:t>
+              <a:t>Chỉ đọc ba con số:</a:t>
             </a:r>
           </a:p>
           <a:p>
             <a:r>
               <a:rPr lang="en-US"/>
-              <a:t>Nếu phần nói đã quá 6:30 thì cắt slide này còn 15 giây.</a:t>
+              <a:t>  1 sửa / 30 giây</a:t>
+            </a:r>
+          </a:p>
+          <a:p>
+            <a:r>
+              <a:rPr lang="en-US"/>
+              <a:t>  PL1 chặn oan 0/15</a:t>
+            </a:r>
+          </a:p>
+          <a:p>
+            <a:r>
+              <a:rPr lang="en-US"/>
+              <a:t>  RTO 5–6 giây</a:t>
+            </a:r>
+          </a:p>
+          <a:p>
+            <a:r>
+              <a:rPr lang="en-US"/>
+              <a:t/>
+            </a:r>
+          </a:p>
+          <a:p>
+            <a:r>
+              <a:rPr lang="en-US"/>
+              <a:t>DỄ VỠ NGÂN SÁCH: đừng kể quá trình đo, chỉ đọc kết quả.</a:t>
             </a:r>
           </a:p>
         </p:txBody>
@@ -1353,7 +1336,19 @@
           <a:p>
             <a:r>
               <a:rPr lang="en-US"/>
-              <a:t>30 GIÂY. Bốn câu, đọc chậm, dừng lại sau câu 3. Rồi mời hỏi đáp.</a:t>
+              <a:t>25 GIÂY. Đọc nhanh đúng 2 dòng:</a:t>
+            </a:r>
+          </a:p>
+          <a:p>
+            <a:r>
+              <a:rPr lang="en-US"/>
+              <a:t>  TOTP không chống AiTM → Passkey/WebAuthn</a:t>
+            </a:r>
+          </a:p>
+          <a:p>
+            <a:r>
+              <a:rPr lang="en-US"/>
+              <a:t>  Superuser DB vẫn tính lại được hash-chain → SIEM + WORM</a:t>
             </a:r>
           </a:p>
           <a:p>
@@ -1365,7 +1360,237 @@
           <a:p>
             <a:r>
               <a:rPr lang="en-US"/>
-              <a:t>TỔNG PHẦN NÓI: 5 phút 55 — dư 65 giây so với khung 7 phút.</a:t>
+              <a:t>DỄ VỠ NGÂN SÁCH: đừng xin lỗi dài dòng.</a:t>
+            </a:r>
+          </a:p>
+          <a:p>
+            <a:r>
+              <a:rPr lang="en-US"/>
+              <a:t>Nếu phần nói đã quá 6:30 thì cắt slide này còn 15 giây.</a:t>
+            </a:r>
+          </a:p>
+        </p:txBody>
+      </p:sp>
+      <p:sp>
+        <p:nvSpPr>
+          <p:cNvPr id="6" name="Footer Placeholder 5"/>
+          <p:cNvSpPr>
+            <a:spLocks noGrp="1"/>
+          </p:cNvSpPr>
+          <p:nvPr>
+            <p:ph type="ftr" sz="quarter" idx="4"/>
+          </p:nvPr>
+        </p:nvSpPr>
+        <p:spPr>
+          <a:xfrm>
+            <a:off x="0" y="6502400"/>
+            <a:ext cx="3962400" cy="341313"/>
+          </a:xfrm>
+          <a:prstGeom prst="rect">
+            <a:avLst/>
+          </a:prstGeom>
+        </p:spPr>
+        <p:txBody>
+          <a:bodyPr vert="horz" lIns="91440" tIns="45720" rIns="91440" bIns="45720" rtlCol="0" anchor="b"/>
+          <a:lstStyle>
+            <a:lvl1pPr algn="l">
+              <a:defRPr sz="1200"/>
+            </a:lvl1pPr>
+          </a:lstStyle>
+          <a:p/>
+        </p:txBody>
+      </p:sp>
+      <p:sp>
+        <p:nvSpPr>
+          <p:cNvPr id="7" name="Slide Number Placeholder 6"/>
+          <p:cNvSpPr>
+            <a:spLocks noGrp="1"/>
+          </p:cNvSpPr>
+          <p:nvPr>
+            <p:ph type="sldNum" sz="quarter" idx="5"/>
+          </p:nvPr>
+        </p:nvSpPr>
+        <p:spPr>
+          <a:xfrm>
+            <a:off x="5180013" y="6502400"/>
+            <a:ext cx="3962400" cy="341313"/>
+          </a:xfrm>
+          <a:prstGeom prst="rect">
+            <a:avLst/>
+          </a:prstGeom>
+        </p:spPr>
+        <p:txBody>
+          <a:bodyPr vert="horz" lIns="91440" tIns="45720" rIns="91440" bIns="45720" rtlCol="0" anchor="b"/>
+          <a:lstStyle>
+            <a:lvl1pPr algn="r">
+              <a:defRPr sz="1200"/>
+            </a:lvl1pPr>
+          </a:lstStyle>
+          <a:p>
+            <a:r id="{871B2431-D351-4C6E-A3CF-9DFAC0E3E050}" type="slidenum">
+              <a:rPr lang="cs-CZ" smtClean="0"/>
+              <a:t>‹#›</a:t>
+            </a:r>
+          </a:p>
+        </p:txBody>
+      </p:sp>
+    </p:spTree>
+  </p:cSld>
+  <p:clrMapOvr>
+    <a:masterClrMapping/>
+  </p:clrMapOvr>
+</p:notes>
+</file>
+
+<file path=ppt/notesSlides/notesSlide13.xml><?xml version="1.0" encoding="utf-8"?>
+<p:notes xmlns:p="http://schemas.openxmlformats.org/presentationml/2006/main" xmlns:a="http://schemas.openxmlformats.org/drawingml/2006/main">
+  <p:cSld>
+    <p:spTree xmlns:r="http://schemas.openxmlformats.org/officeDocument/2006/relationships">
+      <p:nvGrpSpPr>
+        <p:cNvPr id="1" name=""/>
+        <p:cNvGrpSpPr/>
+        <p:nvPr/>
+      </p:nvGrpSpPr>
+      <p:grpSpPr>
+        <a:xfrm>
+          <a:off x="0" y="0"/>
+          <a:ext cx="0" cy="0"/>
+          <a:chOff x="0" y="0"/>
+          <a:chExt cx="0" cy="0"/>
+        </a:xfrm>
+      </p:grpSpPr>
+      <p:sp>
+        <p:nvSpPr>
+          <p:cNvPr id="2" name="Header Placeholder 1"/>
+          <p:cNvSpPr>
+            <a:spLocks noGrp="1"/>
+          </p:cNvSpPr>
+          <p:nvPr>
+            <p:ph type="hdr" sz="quarter"/>
+          </p:nvPr>
+        </p:nvSpPr>
+        <p:spPr>
+          <a:xfrm>
+            <a:off x="0" y="0"/>
+            <a:ext cx="3962400" cy="342900"/>
+          </a:xfrm>
+          <a:prstGeom prst="rect">
+            <a:avLst/>
+          </a:prstGeom>
+        </p:spPr>
+        <p:txBody>
+          <a:bodyPr vert="horz" lIns="91440" tIns="45720" rIns="91440" bIns="45720" rtlCol="0"/>
+          <a:lstStyle>
+            <a:lvl1pPr algn="l">
+              <a:defRPr sz="1200"/>
+            </a:lvl1pPr>
+          </a:lstStyle>
+          <a:p/>
+        </p:txBody>
+      </p:sp>
+      <p:sp>
+        <p:nvSpPr>
+          <p:cNvPr id="3" name="Date Placeholder 2"/>
+          <p:cNvSpPr>
+            <a:spLocks noGrp="1"/>
+          </p:cNvSpPr>
+          <p:nvPr>
+            <p:ph type="dt" idx="1"/>
+          </p:nvPr>
+        </p:nvSpPr>
+        <p:spPr>
+          <a:xfrm>
+            <a:off x="5180013" y="0"/>
+            <a:ext cx="3962400" cy="342900"/>
+          </a:xfrm>
+          <a:prstGeom prst="rect">
+            <a:avLst/>
+          </a:prstGeom>
+        </p:spPr>
+        <p:txBody>
+          <a:bodyPr vert="horz" lIns="91440" tIns="45720" rIns="91440" bIns="45720" rtlCol="0"/>
+          <a:lstStyle>
+            <a:lvl1pPr algn="r">
+              <a:defRPr sz="1200"/>
+            </a:lvl1pPr>
+          </a:lstStyle>
+          <a:p>
+            <a:r id="{B7268E1E-0E44-426D-905E-8AD9B19D2182}" type="datetimeFigureOut">
+              <a:rPr lang="cs-CZ" smtClean="0"/>
+              <a:t>1.7.2013</a:t>
+            </a:r>
+          </a:p>
+        </p:txBody>
+      </p:sp>
+      <p:sp>
+        <p:nvSpPr>
+          <p:cNvPr id="4" name="Slide Image Placeholder 3"/>
+          <p:cNvSpPr>
+            <a:spLocks noGrp="1" noRot="1" noChangeAspect="1"/>
+          </p:cNvSpPr>
+          <p:nvPr>
+            <p:ph type="sldImg" idx="2"/>
+          </p:nvPr>
+        </p:nvSpPr>
+        <p:spPr>
+          <a:xfrm>
+            <a:off x="2857500" y="512763"/>
+            <a:ext cx="3429000" cy="2566987"/>
+          </a:xfrm>
+          <a:prstGeom prst="rect">
+            <a:avLst/>
+          </a:prstGeom>
+          <a:noFill/>
+          <a:ln w="12700">
+            <a:solidFill>
+              <a:prstClr val="black"/>
+            </a:solidFill>
+          </a:ln>
+        </p:spPr>
+        <p:txBody>
+          <a:bodyPr vert="horz" lIns="91440" tIns="45720" rIns="91440" bIns="45720" rtlCol="0" anchor="ctr"/>
+          <a:lstStyle/>
+          <a:p/>
+        </p:txBody>
+      </p:sp>
+      <p:sp>
+        <p:nvSpPr>
+          <p:cNvPr id="5" name="Notes Placeholder 4"/>
+          <p:cNvSpPr>
+            <a:spLocks noGrp="1"/>
+          </p:cNvSpPr>
+          <p:nvPr>
+            <p:ph type="body" sz="quarter" idx="3"/>
+          </p:nvPr>
+        </p:nvSpPr>
+        <p:spPr>
+          <a:xfrm>
+            <a:off x="914400" y="3251200"/>
+            <a:ext cx="7315200" cy="3081338"/>
+          </a:xfrm>
+          <a:prstGeom prst="rect">
+            <a:avLst/>
+          </a:prstGeom>
+        </p:spPr>
+        <p:txBody>
+          <a:bodyPr vert="horz" lIns="91440" tIns="45720" rIns="91440" bIns="45720" rtlCol="0"/>
+          <a:lstStyle/>
+          <a:p>
+            <a:r>
+              <a:rPr lang="en-US"/>
+              <a:t>30 GIÂY. Bốn câu, đọc chậm, dừng lại sau câu 3. Rồi mời hỏi đáp.</a:t>
+            </a:r>
+          </a:p>
+          <a:p>
+            <a:r>
+              <a:rPr lang="en-US"/>
+              <a:t/>
+            </a:r>
+          </a:p>
+          <a:p>
+            <a:r>
+              <a:rPr lang="en-US"/>
+              <a:t>TỔNG PHẦN NÓI: 6 phút 05 — dư 55 giây so với khung 7 phút.</a:t>
             </a:r>
           </a:p>
         </p:txBody>
@@ -1577,7 +1802,7 @@
           <a:p>
             <a:r>
               <a:rPr lang="en-US"/>
-              <a:t>45 GIÂY. Điểm là tài sản toàn vẹn → cổng vào duy nhất là tài khoản GV → dừng ở câu hỏi lớn.</a:t>
+              <a:t>10 GIÂY. Đừng đọc từng dòng.</a:t>
             </a:r>
           </a:p>
           <a:p>
@@ -1589,7 +1814,7 @@
           <a:p>
             <a:r>
               <a:rPr lang="en-US"/>
-              <a:t>THÊM MỘT CÂU (vì slide 3 đã ẩn): "tác nhân nguy hiểm nhất là insider có quyền DB — phần lớn đồ án bỏ qua."</a:t>
+              <a:t>"Bài của nhóm em đi từ bài toán, qua thiết kế, rồi chứng minh bằng demo trực tiếp và bộ test, cuối cùng là hạn chế và kết luận."</a:t>
             </a:r>
           </a:p>
           <a:p>
@@ -1601,7 +1826,7 @@
           <a:p>
             <a:r>
               <a:rPr lang="en-US"/>
-              <a:t>Đây là cái móc của cả bài: đừng vội nói về kỹ thuật.</a:t>
+              <a:t>Chỉ tay vào dòng 05 màu đỏ: đây là phần demo.</a:t>
             </a:r>
           </a:p>
         </p:txBody>
@@ -1813,13 +2038,7 @@
           <a:p>
             <a:r>
               <a:rPr lang="en-US"/>
-              <a:t>ẨN SLIDE NÀY khi trình bày.</a:t>
-            </a:r>
-          </a:p>
-          <a:p>
-            <a:r>
-              <a:rPr lang="en-US"/>
-              <a:t>PowerPoint: chuột phải vào slide ở khung bên trái → Hide Slide.</a:t>
+              <a:t>45 GIÂY. Điểm là tài sản toàn vẹn → cổng vào duy nhất là tài khoản GV → dừng ở câu hỏi lớn.</a:t>
             </a:r>
           </a:p>
           <a:p>
@@ -1831,7 +2050,19 @@
           <a:p>
             <a:r>
               <a:rPr lang="en-US"/>
-              <a:t>Chỉ mở khi thầy hỏi "tài sản nào quan trọng nhất". Nội dung đã gộp một câu vào slide 2.</a:t>
+              <a:t>THÊM MỘT CÂU (vì slide 4 đã ẩn): "tác nhân nguy hiểm nhất là insider có quyền DB — phần lớn đồ án bỏ qua."</a:t>
+            </a:r>
+          </a:p>
+          <a:p>
+            <a:r>
+              <a:rPr lang="en-US"/>
+              <a:t/>
+            </a:r>
+          </a:p>
+          <a:p>
+            <a:r>
+              <a:rPr lang="en-US"/>
+              <a:t>Đây là cái móc của cả bài: đừng vội nói về kỹ thuật.</a:t>
             </a:r>
           </a:p>
         </p:txBody>
@@ -2043,7 +2274,13 @@
           <a:p>
             <a:r>
               <a:rPr lang="en-US"/>
-              <a:t>50 GIÂY. 3 zone · chỉ WAF có port.</a:t>
+              <a:t>ẨN SLIDE NÀY khi trình bày.</a:t>
+            </a:r>
+          </a:p>
+          <a:p>
+            <a:r>
+              <a:rPr lang="en-US"/>
+              <a:t>PowerPoint: chuột phải vào slide ở khung bên trái → Hide Slide.</a:t>
             </a:r>
           </a:p>
           <a:p>
@@ -2055,19 +2292,7 @@
           <a:p>
             <a:r>
               <a:rPr lang="en-US"/>
-              <a:t>NHẤN D4: app không gọi được ra Internet, nên có RCE trong app cũng không exfiltrate được dữ liệu.</a:t>
-            </a:r>
-          </a:p>
-          <a:p>
-            <a:r>
-              <a:rPr lang="en-US"/>
-              <a:t/>
-            </a:r>
-          </a:p>
-          <a:p>
-            <a:r>
-              <a:rPr lang="en-US"/>
-              <a:t>Đừng đọc hết 5 luồng bị chặn.</a:t>
+              <a:t>Chỉ mở khi thầy hỏi "tài sản nào quan trọng nhất". Nội dung đã gộp một câu vào slide 3.</a:t>
             </a:r>
           </a:p>
         </p:txBody>
@@ -2279,7 +2504,7 @@
           <a:p>
             <a:r>
               <a:rPr lang="en-US"/>
-              <a:t>70 GIÂY — slide dài nhất, bấm giờ riêng khi tổng duyệt.</a:t>
+              <a:t>50 GIÂY. 3 zone · chỉ WAF có port.</a:t>
             </a:r>
           </a:p>
           <a:p>
@@ -2291,7 +2516,7 @@
           <a:p>
             <a:r>
               <a:rPr lang="en-US"/>
-              <a:t>Đọc 5 dòng bảng, dừng lại ở dòng cuối (không tin cả DB của mình).</a:t>
+              <a:t>NHẤN D4: app không gọi được ra Internet, nên có RCE trong app cũng không exfiltrate được dữ liệu.</a:t>
             </a:r>
           </a:p>
           <a:p>
@@ -2303,19 +2528,7 @@
           <a:p>
             <a:r>
               <a:rPr lang="en-US"/>
-              <a:t>THÊM MỘT CÂU (vì slide 6 đã ẩn): "cụ thể hoá thành 12 lớp kiểm chứng, một request sửa điểm phải qua hết."</a:t>
-            </a:r>
-          </a:p>
-          <a:p>
-            <a:r>
-              <a:rPr lang="en-US"/>
-              <a:t/>
-            </a:r>
-          </a:p>
-          <a:p>
-            <a:r>
-              <a:rPr lang="en-US"/>
-              <a:t>DỄ VỠ NGÂN SÁCH: đừng giải thích từng dòng.</a:t>
+              <a:t>Đừng đọc hết 5 luồng bị chặn.</a:t>
             </a:r>
           </a:p>
         </p:txBody>
@@ -2527,13 +2740,7 @@
           <a:p>
             <a:r>
               <a:rPr lang="en-US"/>
-              <a:t>ẨN SLIDE NÀY khi trình bày.</a:t>
-            </a:r>
-          </a:p>
-          <a:p>
-            <a:r>
-              <a:rPr lang="en-US"/>
-              <a:t>PowerPoint: chuột phải vào slide ở khung bên trái → Hide Slide.</a:t>
+              <a:t>70 GIÂY — slide dài nhất, bấm giờ riêng khi tổng duyệt.</a:t>
             </a:r>
           </a:p>
           <a:p>
@@ -2545,7 +2752,31 @@
           <a:p>
             <a:r>
               <a:rPr lang="en-US"/>
-              <a:t>Chỉ mở khi thầy hỏi "12 lớp là những lớp nào". Đã nói bằng một câu ở slide 5.</a:t>
+              <a:t>Đọc 5 dòng bảng, dừng lại ở dòng cuối (không tin cả DB của mình).</a:t>
+            </a:r>
+          </a:p>
+          <a:p>
+            <a:r>
+              <a:rPr lang="en-US"/>
+              <a:t/>
+            </a:r>
+          </a:p>
+          <a:p>
+            <a:r>
+              <a:rPr lang="en-US"/>
+              <a:t>THÊM MỘT CÂU (vì slide 7 đã ẩn): "cụ thể hoá thành 12 lớp kiểm chứng, một request sửa điểm phải qua hết."</a:t>
+            </a:r>
+          </a:p>
+          <a:p>
+            <a:r>
+              <a:rPr lang="en-US"/>
+              <a:t/>
+            </a:r>
+          </a:p>
+          <a:p>
+            <a:r>
+              <a:rPr lang="en-US"/>
+              <a:t>DỄ VỠ NGÂN SÁCH: đừng giải thích từng dòng.</a:t>
             </a:r>
           </a:p>
         </p:txBody>
@@ -2757,7 +2988,13 @@
           <a:p>
             <a:r>
               <a:rPr lang="en-US"/>
-              <a:t>40 GIÂY. Lướt nhanh 4 dòng đầu.</a:t>
+              <a:t>ẨN SLIDE NÀY khi trình bày.</a:t>
+            </a:r>
+          </a:p>
+          <a:p>
+            <a:r>
+              <a:rPr lang="en-US"/>
+              <a:t>PowerPoint: chuột phải vào slide ở khung bên trái → Hide Slide.</a:t>
             </a:r>
           </a:p>
           <a:p>
@@ -2769,7 +3006,7 @@
           <a:p>
             <a:r>
               <a:rPr lang="en-US"/>
-              <a:t>DỮNG Ở R08: insider sửa DB, audit_log append-only, hash-chain, TC22–TC24. Đây là dòng phân biệt đồ án này với đồ án khác.</a:t>
+              <a:t>Chỉ mở khi thầy hỏi "12 lớp là những lớp nào". Đã nói bằng một câu ở slide 6.</a:t>
             </a:r>
           </a:p>
         </p:txBody>
@@ -2981,7 +3218,7 @@
           <a:p>
             <a:r>
               <a:rPr lang="en-US"/>
-              <a:t>5 GIÂY. "Em xin chuyển sang demo trực tiếp."</a:t>
+              <a:t>40 GIÂY. Lướt nhanh 4 dòng đầu.</a:t>
             </a:r>
           </a:p>
           <a:p>
@@ -2993,73 +3230,7 @@
           <a:p>
             <a:r>
               <a:rPr lang="en-US"/>
-              <a:t>DEMO ~3 PHÚT, 2 CẢNH (docs/KICH_BAN_7P.md, lệnh ở docs/LENH_DEMO.txt):</a:t>
-            </a:r>
-          </a:p>
-          <a:p>
-            <a:r>
-              <a:rPr lang="en-US"/>
-              <a:t>  Cảnh 0  0:00–0:15  docker compose ps — chỉ waf có "-&gt;"</a:t>
-            </a:r>
-          </a:p>
-          <a:p>
-            <a:r>
-              <a:rPr lang="en-US"/>
-              <a:t>  Cảnh 1  0:15–1:15  KB2 cookie: curl.exe với $c → SESSION_CONTEXT_MISMATCH → gv01 bị đá ra → CRITICAL</a:t>
-            </a:r>
-          </a:p>
-          <a:p>
-            <a:r>
-              <a:rPr lang="en-US"/>
-              <a:t>  Cảnh 2  1:15–2:35  KB6: toàn vẹn sạch → UPDATE DB → DB=10 / log=8.5 → DELETE bị permission denied</a:t>
-            </a:r>
-          </a:p>
-          <a:p>
-            <a:r>
-              <a:rPr lang="en-US"/>
-              <a:t>  Cảnh 3  2:35–2:50  "25/25 PASS, bốn kịch bản còn lại chạy được ngay"</a:t>
-            </a:r>
-          </a:p>
-          <a:p>
-            <a:r>
-              <a:rPr lang="en-US"/>
-              <a:t/>
-            </a:r>
-          </a:p>
-          <a:p>
-            <a:r>
-              <a:rPr lang="en-US"/>
-              <a:t>NHỚ TRƯỚC KHI BẤM GIỜ:</a:t>
-            </a:r>
-          </a:p>
-          <a:p>
-            <a:r>
-              <a:rPr lang="en-US"/>
-              <a:t>  - đã chạy node scripts/reset-demo.mjs</a:t>
-            </a:r>
-          </a:p>
-          <a:p>
-            <a:r>
-              <a:rPr lang="en-US"/>
-              <a:t>  - admin ở cửa sổ ẨN DANH, gv01 ở cửa sổ THƯỜNG</a:t>
-            </a:r>
-          </a:p>
-          <a:p>
-            <a:r>
-              <a:rPr lang="en-US"/>
-              <a:t>  - cookie gv01 đã cất vào $c, chạy cảnh 1 trong 15 phút</a:t>
-            </a:r>
-          </a:p>
-          <a:p>
-            <a:r>
-              <a:rPr lang="en-US"/>
-              <a:t/>
-            </a:r>
-          </a:p>
-          <a:p>
-            <a:r>
-              <a:rPr lang="en-US"/>
-              <a:t>cls trước mỗi lệnh. Ra kết quả thì DỪNG 3 GIÂY rồi mới nói.</a:t>
+              <a:t>DỮNG Ở R08: insider sửa DB, audit_log append-only, hash-chain, TC22–TC24. Đây là dòng phân biệt đồ án này với đồ án khác.</a:t>
             </a:r>
           </a:p>
         </p:txBody>
@@ -3271,7 +3442,7 @@
           <a:p>
             <a:r>
               <a:rPr lang="en-US"/>
-              <a:t>25 GIÂY. 25/25 PASS · 6 luồng bình thường + 19 test tấn công · phủ KB1–KB6.</a:t>
+              <a:t>5 GIÂY. "Em xin chuyển sang demo trực tiếp."</a:t>
             </a:r>
           </a:p>
           <a:p>
@@ -3283,7 +3454,73 @@
           <a:p>
             <a:r>
               <a:rPr lang="en-US"/>
-              <a:t>Đừng đọc từng dòng trên màn hình — để thầy tự đọc.</a:t>
+              <a:t>DEMO ~3 PHÚT, 2 CẢNH (docs/KICH_BAN_7P.md, lệnh ở docs/LENH_DEMO.txt):</a:t>
+            </a:r>
+          </a:p>
+          <a:p>
+            <a:r>
+              <a:rPr lang="en-US"/>
+              <a:t>  Cảnh 0  0:00–0:15  docker compose ps — chỉ waf có "-&gt;"</a:t>
+            </a:r>
+          </a:p>
+          <a:p>
+            <a:r>
+              <a:rPr lang="en-US"/>
+              <a:t>  Cảnh 1  0:15–1:15  KB2 cookie: curl.exe với $c → SESSION_CONTEXT_MISMATCH → gv01 bị đá ra → CRITICAL</a:t>
+            </a:r>
+          </a:p>
+          <a:p>
+            <a:r>
+              <a:rPr lang="en-US"/>
+              <a:t>  Cảnh 2  1:15–2:35  KB6: toàn vẹn sạch → UPDATE DB → DB=10 / log=8.5 → DELETE bị permission denied</a:t>
+            </a:r>
+          </a:p>
+          <a:p>
+            <a:r>
+              <a:rPr lang="en-US"/>
+              <a:t>  Cảnh 3  2:35–2:50  "25/25 PASS, bốn kịch bản còn lại chạy được ngay"</a:t>
+            </a:r>
+          </a:p>
+          <a:p>
+            <a:r>
+              <a:rPr lang="en-US"/>
+              <a:t/>
+            </a:r>
+          </a:p>
+          <a:p>
+            <a:r>
+              <a:rPr lang="en-US"/>
+              <a:t>NHỚ TRƯỚC KHI BẤM GIỜ:</a:t>
+            </a:r>
+          </a:p>
+          <a:p>
+            <a:r>
+              <a:rPr lang="en-US"/>
+              <a:t>  - đã chạy node scripts/reset-demo.mjs</a:t>
+            </a:r>
+          </a:p>
+          <a:p>
+            <a:r>
+              <a:rPr lang="en-US"/>
+              <a:t>  - admin ở cửa sổ ẨN DANH, gv01 ở cửa sổ THƯỜNG</a:t>
+            </a:r>
+          </a:p>
+          <a:p>
+            <a:r>
+              <a:rPr lang="en-US"/>
+              <a:t>  - cookie gv01 đã cất vào $c, chạy cảnh 1 trong 15 phút</a:t>
+            </a:r>
+          </a:p>
+          <a:p>
+            <a:r>
+              <a:rPr lang="en-US"/>
+              <a:t/>
+            </a:r>
+          </a:p>
+          <a:p>
+            <a:r>
+              <a:rPr lang="en-US"/>
+              <a:t>cls trước mỗi lệnh. Ra kết quả thì DỪNG 3 GIÂY rồi mới nói.</a:t>
             </a:r>
           </a:p>
         </p:txBody>
@@ -6858,7 +7095,7 @@
     <p:bg>
       <p:bgPr>
         <a:solidFill>
-          <a:srgbClr val="EDF1F6"/>
+          <a:srgbClr val="F7F9FC"/>
         </a:solidFill>
       </p:bgPr>
     </p:bg>
@@ -6984,13 +7221,16 @@
           </a:bodyPr>
           <a:lstStyle/>
           <a:p>
-            <a:pPr algn="r">
+            <a:pPr algn="r" marL="0" indent="0" lvl="0">
               <a:lnSpc>
                 <a:spcPts val="1889"/>
               </a:lnSpc>
+              <a:spcBef>
+                <a:spcPct val="0"/>
+              </a:spcBef>
             </a:pPr>
             <a:r>
-              <a:rPr lang="en-US" sz="1350">
+              <a:rPr lang="en-US" sz="1350" strike="noStrike" u="none">
                 <a:solidFill>
                   <a:srgbClr val="8A98AA"/>
                 </a:solidFill>
@@ -7000,6 +7240,755 @@
                 <a:sym typeface="JetBrains Mono"/>
               </a:rPr>
               <a:t>10</a:t>
+            </a:r>
+          </a:p>
+        </p:txBody>
+      </p:sp>
+      <p:sp>
+        <p:nvSpPr>
+          <p:cNvPr name="TextBox 6" id="6"/>
+          <p:cNvSpPr txBox="true"/>
+          <p:nvPr/>
+        </p:nvSpPr>
+        <p:spPr>
+          <a:xfrm rot="0">
+            <a:off x="1047750" y="1304925"/>
+            <a:ext cx="8572500" cy="663702"/>
+          </a:xfrm>
+          <a:prstGeom prst="rect">
+            <a:avLst/>
+          </a:prstGeom>
+        </p:spPr>
+        <p:txBody>
+          <a:bodyPr anchor="t" rtlCol="false" tIns="0" lIns="0" bIns="0" rIns="0">
+            <a:spAutoFit/>
+          </a:bodyPr>
+          <a:lstStyle/>
+          <a:p>
+            <a:pPr algn="l">
+              <a:lnSpc>
+                <a:spcPts val="5184"/>
+              </a:lnSpc>
+            </a:pPr>
+            <a:r>
+              <a:rPr lang="en-US" sz="4800" b="true">
+                <a:solidFill>
+                  <a:srgbClr val="1B2A3F"/>
+                </a:solidFill>
+                <a:latin typeface="IBM Plex Sans Bold"/>
+                <a:ea typeface="IBM Plex Sans Bold"/>
+                <a:cs typeface="IBM Plex Sans Bold"/>
+                <a:sym typeface="IBM Plex Sans Bold"/>
+              </a:rPr>
+              <a:t>Kết quả kiểm thử</a:t>
+            </a:r>
+          </a:p>
+        </p:txBody>
+      </p:sp>
+      <p:sp>
+        <p:nvSpPr>
+          <p:cNvPr name="TextBox 7" id="7"/>
+          <p:cNvSpPr txBox="true"/>
+          <p:nvPr/>
+        </p:nvSpPr>
+        <p:spPr>
+          <a:xfrm rot="0">
+            <a:off x="1047750" y="3181350"/>
+            <a:ext cx="6572250" cy="2181225"/>
+          </a:xfrm>
+          <a:prstGeom prst="rect">
+            <a:avLst/>
+          </a:prstGeom>
+        </p:spPr>
+        <p:txBody>
+          <a:bodyPr anchor="t" rtlCol="false" tIns="0" lIns="0" bIns="0" rIns="0">
+            <a:spAutoFit/>
+          </a:bodyPr>
+          <a:lstStyle/>
+          <a:p>
+            <a:pPr algn="l">
+              <a:lnSpc>
+                <a:spcPts val="17850"/>
+              </a:lnSpc>
+            </a:pPr>
+            <a:r>
+              <a:rPr lang="en-US" sz="12750" b="true">
+                <a:solidFill>
+                  <a:srgbClr val="1B2A3F"/>
+                </a:solidFill>
+                <a:latin typeface="JetBrains Mono Bold"/>
+                <a:ea typeface="JetBrains Mono Bold"/>
+                <a:cs typeface="JetBrains Mono Bold"/>
+                <a:sym typeface="JetBrains Mono Bold"/>
+              </a:rPr>
+              <a:t>25/25</a:t>
+            </a:r>
+          </a:p>
+        </p:txBody>
+      </p:sp>
+      <p:sp>
+        <p:nvSpPr>
+          <p:cNvPr name="TextBox 8" id="8"/>
+          <p:cNvSpPr txBox="true"/>
+          <p:nvPr/>
+        </p:nvSpPr>
+        <p:spPr>
+          <a:xfrm rot="0">
+            <a:off x="1047750" y="5543550"/>
+            <a:ext cx="4953000" cy="1128713"/>
+          </a:xfrm>
+          <a:prstGeom prst="rect">
+            <a:avLst/>
+          </a:prstGeom>
+        </p:spPr>
+        <p:txBody>
+          <a:bodyPr anchor="t" rtlCol="false" tIns="0" lIns="0" bIns="0" rIns="0">
+            <a:spAutoFit/>
+          </a:bodyPr>
+          <a:lstStyle/>
+          <a:p>
+            <a:pPr algn="l" marL="0" indent="0" lvl="0">
+              <a:lnSpc>
+                <a:spcPts val="3037"/>
+              </a:lnSpc>
+              <a:spcBef>
+                <a:spcPct val="0"/>
+              </a:spcBef>
+            </a:pPr>
+            <a:r>
+              <a:rPr lang="en-US" sz="2250" strike="noStrike" u="none">
+                <a:solidFill>
+                  <a:srgbClr val="2E5C8A"/>
+                </a:solidFill>
+                <a:latin typeface="IBM Plex Sans"/>
+                <a:ea typeface="IBM Plex Sans"/>
+                <a:cs typeface="IBM Plex Sans"/>
+                <a:sym typeface="IBM Plex Sans"/>
+              </a:rPr>
+              <a:t>test case PASS</a:t>
+            </a:r>
+          </a:p>
+          <a:p>
+            <a:pPr algn="l" marL="0" indent="0" lvl="0">
+              <a:lnSpc>
+                <a:spcPts val="3037"/>
+              </a:lnSpc>
+              <a:spcBef>
+                <a:spcPct val="0"/>
+              </a:spcBef>
+            </a:pPr>
+            <a:r>
+              <a:rPr lang="en-US" sz="2250" strike="noStrike" u="none">
+                <a:solidFill>
+                  <a:srgbClr val="2E5C8A"/>
+                </a:solidFill>
+                <a:latin typeface="IBM Plex Sans"/>
+                <a:ea typeface="IBM Plex Sans"/>
+                <a:cs typeface="IBM Plex Sans"/>
+                <a:sym typeface="IBM Plex Sans"/>
+              </a:rPr>
+              <a:t>6 luồng bình thường</a:t>
+            </a:r>
+          </a:p>
+          <a:p>
+            <a:pPr algn="l" marL="0" indent="0" lvl="0">
+              <a:lnSpc>
+                <a:spcPts val="3037"/>
+              </a:lnSpc>
+              <a:spcBef>
+                <a:spcPct val="0"/>
+              </a:spcBef>
+            </a:pPr>
+            <a:r>
+              <a:rPr lang="en-US" sz="2250" strike="noStrike" u="none">
+                <a:solidFill>
+                  <a:srgbClr val="2E5C8A"/>
+                </a:solidFill>
+                <a:latin typeface="IBM Plex Sans"/>
+                <a:ea typeface="IBM Plex Sans"/>
+                <a:cs typeface="IBM Plex Sans"/>
+                <a:sym typeface="IBM Plex Sans"/>
+              </a:rPr>
+              <a:t>+ 19 test tấn công</a:t>
+            </a:r>
+          </a:p>
+        </p:txBody>
+      </p:sp>
+      <p:grpSp>
+        <p:nvGrpSpPr>
+          <p:cNvPr name="Group 9" id="9"/>
+          <p:cNvGrpSpPr/>
+          <p:nvPr/>
+        </p:nvGrpSpPr>
+        <p:grpSpPr>
+          <a:xfrm rot="0">
+            <a:off x="7620000" y="2190750"/>
+            <a:ext cx="9429750" cy="5905500"/>
+            <a:chOff x="0" y="0"/>
+            <a:chExt cx="12573000" cy="7874000"/>
+          </a:xfrm>
+        </p:grpSpPr>
+        <p:sp>
+          <p:nvSpPr>
+            <p:cNvPr name="Freeform 10" id="10"/>
+            <p:cNvSpPr/>
+            <p:nvPr/>
+          </p:nvSpPr>
+          <p:spPr>
+            <a:xfrm flipH="false" flipV="false" rot="0">
+              <a:off x="0" y="0"/>
+              <a:ext cx="12573000" cy="7874000"/>
+            </a:xfrm>
+            <a:custGeom>
+              <a:avLst/>
+              <a:gdLst/>
+              <a:ahLst/>
+              <a:cxnLst/>
+              <a:rect r="r" b="b" t="t" l="l"/>
+              <a:pathLst>
+                <a:path h="7874000" w="12573000">
+                  <a:moveTo>
+                    <a:pt x="0" y="0"/>
+                  </a:moveTo>
+                  <a:lnTo>
+                    <a:pt x="12573000" y="0"/>
+                  </a:lnTo>
+                  <a:lnTo>
+                    <a:pt x="12573000" y="7874000"/>
+                  </a:lnTo>
+                  <a:lnTo>
+                    <a:pt x="0" y="7874000"/>
+                  </a:lnTo>
+                  <a:close/>
+                </a:path>
+              </a:pathLst>
+            </a:custGeom>
+            <a:solidFill>
+              <a:srgbClr val="FFFFFF"/>
+            </a:solidFill>
+            <a:ln w="9525" cap="sq">
+              <a:solidFill>
+                <a:srgbClr val="D4DCE6"/>
+              </a:solidFill>
+              <a:prstDash val="lgDash"/>
+              <a:miter/>
+            </a:ln>
+          </p:spPr>
+        </p:sp>
+        <p:sp>
+          <p:nvSpPr>
+            <p:cNvPr name="TextBox 11" id="11"/>
+            <p:cNvSpPr txBox="true"/>
+            <p:nvPr/>
+          </p:nvSpPr>
+          <p:spPr>
+            <a:xfrm>
+              <a:off x="0" y="-38100"/>
+              <a:ext cx="12573000" cy="7912100"/>
+            </a:xfrm>
+            <a:prstGeom prst="rect">
+              <a:avLst/>
+            </a:prstGeom>
+          </p:spPr>
+          <p:txBody>
+            <a:bodyPr anchor="ctr" rtlCol="false" tIns="50800" lIns="50800" bIns="50800" rIns="50800"/>
+            <a:lstStyle/>
+            <a:p>
+              <a:pPr algn="l">
+                <a:lnSpc>
+                  <a:spcPts val="1679"/>
+                </a:lnSpc>
+              </a:pPr>
+            </a:p>
+          </p:txBody>
+        </p:sp>
+      </p:grpSp>
+      <p:sp>
+        <p:nvSpPr>
+          <p:cNvPr name="TextBox 12" id="12"/>
+          <p:cNvSpPr txBox="true"/>
+          <p:nvPr/>
+        </p:nvSpPr>
+        <p:spPr>
+          <a:xfrm rot="0">
+            <a:off x="8477250" y="8391525"/>
+            <a:ext cx="7620000" cy="567690"/>
+          </a:xfrm>
+          <a:prstGeom prst="rect">
+            <a:avLst/>
+          </a:prstGeom>
+        </p:spPr>
+        <p:txBody>
+          <a:bodyPr anchor="t" rtlCol="false" tIns="0" lIns="0" bIns="0" rIns="0">
+            <a:spAutoFit/>
+          </a:bodyPr>
+          <a:lstStyle/>
+          <a:p>
+            <a:pPr algn="ctr" marL="0" indent="0" lvl="0">
+              <a:lnSpc>
+                <a:spcPts val="2310"/>
+              </a:lnSpc>
+              <a:spcBef>
+                <a:spcPct val="0"/>
+              </a:spcBef>
+            </a:pPr>
+            <a:r>
+              <a:rPr lang="en-US" sz="1650" strike="noStrike" u="none">
+                <a:solidFill>
+                  <a:srgbClr val="8A98AA"/>
+                </a:solidFill>
+                <a:latin typeface="JetBrains Mono"/>
+                <a:ea typeface="JetBrains Mono"/>
+                <a:cs typeface="JetBrains Mono"/>
+                <a:sym typeface="JetBrains Mono"/>
+              </a:rPr>
+              <a:t>Trích kết quả thực tế — docs/evidence/07-run-tests-output.txt</a:t>
+            </a:r>
+          </a:p>
+        </p:txBody>
+      </p:sp>
+      <p:sp>
+        <p:nvSpPr>
+          <p:cNvPr name="TextBox 13" id="13"/>
+          <p:cNvSpPr txBox="true"/>
+          <p:nvPr/>
+        </p:nvSpPr>
+        <p:spPr>
+          <a:xfrm rot="0">
+            <a:off x="7953375" y="2466975"/>
+            <a:ext cx="8763000" cy="4003358"/>
+          </a:xfrm>
+          <a:prstGeom prst="rect">
+            <a:avLst/>
+          </a:prstGeom>
+        </p:spPr>
+        <p:txBody>
+          <a:bodyPr anchor="t" rtlCol="false" tIns="0" lIns="0" bIns="0" rIns="0">
+            <a:spAutoFit/>
+          </a:bodyPr>
+          <a:lstStyle/>
+          <a:p>
+            <a:pPr algn="l">
+              <a:lnSpc>
+                <a:spcPts val="2137"/>
+              </a:lnSpc>
+            </a:pPr>
+            <a:r>
+              <a:rPr lang="en-US" sz="1425">
+                <a:solidFill>
+                  <a:srgbClr val="3C4A5C"/>
+                </a:solidFill>
+                <a:latin typeface="Arimo"/>
+                <a:ea typeface="Arimo"/>
+                <a:cs typeface="Arimo"/>
+                <a:sym typeface="Arimo"/>
+              </a:rPr>
+              <a:t>$ node tests/run-tests.mjs</a:t>
+            </a:r>
+          </a:p>
+          <a:p>
+            <a:pPr algn="l">
+              <a:lnSpc>
+                <a:spcPts val="2137"/>
+              </a:lnSpc>
+            </a:pPr>
+          </a:p>
+          <a:p>
+            <a:pPr algn="l">
+              <a:lnSpc>
+                <a:spcPts val="2137"/>
+              </a:lnSpc>
+            </a:pPr>
+            <a:r>
+              <a:rPr lang="en-US" sz="1425">
+                <a:solidFill>
+                  <a:srgbClr val="3C4A5C"/>
+                </a:solidFill>
+                <a:latin typeface="Arimo"/>
+                <a:ea typeface="Arimo"/>
+                <a:cs typeface="Arimo"/>
+                <a:sym typeface="Arimo"/>
+              </a:rPr>
+              <a:t> TC01   PASS   bat buoc MFA lan dau</a:t>
+            </a:r>
+          </a:p>
+          <a:p>
+            <a:pPr algn="l">
+              <a:lnSpc>
+                <a:spcPts val="2137"/>
+              </a:lnSpc>
+            </a:pPr>
+            <a:r>
+              <a:rPr lang="en-US" sz="1425">
+                <a:solidFill>
+                  <a:srgbClr val="3C4A5C"/>
+                </a:solidFill>
+                <a:latin typeface="Arimo"/>
+                <a:ea typeface="Arimo"/>
+                <a:cs typeface="Arimo"/>
+                <a:sym typeface="Arimo"/>
+              </a:rPr>
+              <a:t> TC11   PASS   sua payload JWT</a:t>
+            </a:r>
+          </a:p>
+          <a:p>
+            <a:pPr algn="l">
+              <a:lnSpc>
+                <a:spcPts val="2137"/>
+              </a:lnSpc>
+            </a:pPr>
+            <a:r>
+              <a:rPr lang="en-US" sz="1425">
+                <a:solidFill>
+                  <a:srgbClr val="3C4A5C"/>
+                </a:solidFill>
+                <a:latin typeface="Arimo"/>
+                <a:ea typeface="Arimo"/>
+                <a:cs typeface="Arimo"/>
+                <a:sym typeface="Arimo"/>
+              </a:rPr>
+              <a:t> TC12   PASS   JWT alg=none</a:t>
+            </a:r>
+          </a:p>
+          <a:p>
+            <a:pPr algn="l">
+              <a:lnSpc>
+                <a:spcPts val="2137"/>
+              </a:lnSpc>
+            </a:pPr>
+            <a:r>
+              <a:rPr lang="en-US" sz="1425">
+                <a:solidFill>
+                  <a:srgbClr val="3C4A5C"/>
+                </a:solidFill>
+                <a:latin typeface="Arimo"/>
+                <a:ea typeface="Arimo"/>
+                <a:cs typeface="Arimo"/>
+                <a:sym typeface="Arimo"/>
+              </a:rPr>
+              <a:t> TC05   PASS   chuoi hash 268 dong, khong vi pham</a:t>
+            </a:r>
+          </a:p>
+          <a:p>
+            <a:pPr algn="l">
+              <a:lnSpc>
+                <a:spcPts val="2137"/>
+              </a:lnSpc>
+            </a:pPr>
+            <a:r>
+              <a:rPr lang="en-US" sz="1425">
+                <a:solidFill>
+                  <a:srgbClr val="3C4A5C"/>
+                </a:solidFill>
+                <a:latin typeface="Arimo"/>
+                <a:ea typeface="Arimo"/>
+                <a:cs typeface="Arimo"/>
+                <a:sym typeface="Arimo"/>
+              </a:rPr>
+              <a:t> TC22   PASS   sua diem thang trong DB -&gt; phat hien lech</a:t>
+            </a:r>
+          </a:p>
+          <a:p>
+            <a:pPr algn="l">
+              <a:lnSpc>
+                <a:spcPts val="2137"/>
+              </a:lnSpc>
+            </a:pPr>
+            <a:r>
+              <a:rPr lang="en-US" sz="1425">
+                <a:solidFill>
+                  <a:srgbClr val="3C4A5C"/>
+                </a:solidFill>
+                <a:latin typeface="Arimo"/>
+                <a:ea typeface="Arimo"/>
+                <a:cs typeface="Arimo"/>
+                <a:sym typeface="Arimo"/>
+              </a:rPr>
+              <a:t> TC24   PASS   sua audit id 3 -&gt; dut chuoi hash</a:t>
+            </a:r>
+          </a:p>
+          <a:p>
+            <a:pPr algn="l">
+              <a:lnSpc>
+                <a:spcPts val="2137"/>
+              </a:lnSpc>
+            </a:pPr>
+            <a:r>
+              <a:rPr lang="en-US" sz="1425">
+                <a:solidFill>
+                  <a:srgbClr val="3C4A5C"/>
+                </a:solidFill>
+                <a:latin typeface="Arimo"/>
+                <a:ea typeface="Arimo"/>
+                <a:cs typeface="Arimo"/>
+                <a:sym typeface="Arimo"/>
+              </a:rPr>
+              <a:t> TC23   PASS   app_user bi tu choi 4 lenh pha hoai</a:t>
+            </a:r>
+          </a:p>
+          <a:p>
+            <a:pPr algn="l">
+              <a:lnSpc>
+                <a:spcPts val="2137"/>
+              </a:lnSpc>
+            </a:pPr>
+            <a:r>
+              <a:rPr lang="en-US" sz="1425">
+                <a:solidFill>
+                  <a:srgbClr val="3C4A5C"/>
+                </a:solidFill>
+                <a:latin typeface="Arimo"/>
+                <a:ea typeface="Arimo"/>
+                <a:cs typeface="Arimo"/>
+                <a:sym typeface="Arimo"/>
+              </a:rPr>
+              <a:t> TC19   PASS   SQLi qua WAF -&gt; 403</a:t>
+            </a:r>
+          </a:p>
+          <a:p>
+            <a:pPr algn="l">
+              <a:lnSpc>
+                <a:spcPts val="2137"/>
+              </a:lnSpc>
+            </a:pPr>
+            <a:r>
+              <a:rPr lang="en-US" sz="1425">
+                <a:solidFill>
+                  <a:srgbClr val="3C4A5C"/>
+                </a:solidFill>
+                <a:latin typeface="Arimo"/>
+                <a:ea typeface="Arimo"/>
+                <a:cs typeface="Arimo"/>
+                <a:sym typeface="Arimo"/>
+              </a:rPr>
+              <a:t> TC21   PASS   chi waf anh xa port ra host</a:t>
+            </a:r>
+          </a:p>
+          <a:p>
+            <a:pPr algn="l">
+              <a:lnSpc>
+                <a:spcPts val="2137"/>
+              </a:lnSpc>
+            </a:pPr>
+            <a:r>
+              <a:rPr lang="en-US" sz="1425">
+                <a:solidFill>
+                  <a:srgbClr val="3C4A5C"/>
+                </a:solidFill>
+                <a:latin typeface="Arimo"/>
+                <a:ea typeface="Arimo"/>
+                <a:cs typeface="Arimo"/>
+                <a:sym typeface="Arimo"/>
+              </a:rPr>
+              <a:t> TC09   PASS   3 lan OTP sai -&gt; khoa, canh bao HIGH</a:t>
+            </a:r>
+          </a:p>
+          <a:p>
+            <a:pPr algn="l">
+              <a:lnSpc>
+                <a:spcPts val="2137"/>
+              </a:lnSpc>
+            </a:pPr>
+            <a:r>
+              <a:rPr lang="en-US" sz="1425">
+                <a:solidFill>
+                  <a:srgbClr val="3C4A5C"/>
+                </a:solidFill>
+                <a:latin typeface="Arimo"/>
+                <a:ea typeface="Arimo"/>
+                <a:cs typeface="Arimo"/>
+                <a:sym typeface="Arimo"/>
+              </a:rPr>
+              <a:t> ...</a:t>
+            </a:r>
+          </a:p>
+          <a:p>
+            <a:pPr algn="l">
+              <a:lnSpc>
+                <a:spcPts val="2137"/>
+              </a:lnSpc>
+            </a:pPr>
+          </a:p>
+          <a:p>
+            <a:pPr algn="l">
+              <a:lnSpc>
+                <a:spcPts val="2137"/>
+              </a:lnSpc>
+            </a:pPr>
+            <a:r>
+              <a:rPr lang="en-US" sz="1425">
+                <a:solidFill>
+                  <a:srgbClr val="3C4A5C"/>
+                </a:solidFill>
+                <a:latin typeface="Arimo"/>
+                <a:ea typeface="Arimo"/>
+                <a:cs typeface="Arimo"/>
+                <a:sym typeface="Arimo"/>
+              </a:rPr>
+              <a:t>25/25 PASS</a:t>
+            </a:r>
+          </a:p>
+        </p:txBody>
+      </p:sp>
+    </p:spTree>
+  </p:cSld>
+  <p:clrMapOvr>
+    <a:masterClrMapping/>
+  </p:clrMapOvr>
+</p:sld>
+</file>
+
+<file path=ppt/slides/slide11.xml><?xml version="1.0" encoding="utf-8"?>
+<p:sld xmlns:p="http://schemas.openxmlformats.org/presentationml/2006/main" xmlns:a="http://schemas.openxmlformats.org/drawingml/2006/main">
+  <p:cSld>
+    <p:bg>
+      <p:bgPr>
+        <a:solidFill>
+          <a:srgbClr val="EDF1F6"/>
+        </a:solidFill>
+      </p:bgPr>
+    </p:bg>
+    <p:spTree>
+      <p:nvGrpSpPr>
+        <p:cNvPr id="1" name=""/>
+        <p:cNvGrpSpPr/>
+        <p:nvPr/>
+      </p:nvGrpSpPr>
+      <p:grpSpPr>
+        <a:xfrm>
+          <a:off x="0" y="0"/>
+          <a:ext cx="0" cy="0"/>
+          <a:chOff x="0" y="0"/>
+          <a:chExt cx="0" cy="0"/>
+        </a:xfrm>
+      </p:grpSpPr>
+      <p:grpSp>
+        <p:nvGrpSpPr>
+          <p:cNvPr name="Group 2" id="2"/>
+          <p:cNvGrpSpPr/>
+          <p:nvPr/>
+        </p:nvGrpSpPr>
+        <p:grpSpPr>
+          <a:xfrm rot="0">
+            <a:off x="1047750" y="819150"/>
+            <a:ext cx="876300" cy="47625"/>
+            <a:chOff x="0" y="0"/>
+            <a:chExt cx="1168400" cy="63500"/>
+          </a:xfrm>
+        </p:grpSpPr>
+        <p:sp>
+          <p:nvSpPr>
+            <p:cNvPr name="Freeform 3" id="3"/>
+            <p:cNvSpPr/>
+            <p:nvPr/>
+          </p:nvSpPr>
+          <p:spPr>
+            <a:xfrm flipH="false" flipV="false" rot="0">
+              <a:off x="0" y="0"/>
+              <a:ext cx="1168400" cy="63500"/>
+            </a:xfrm>
+            <a:custGeom>
+              <a:avLst/>
+              <a:gdLst/>
+              <a:ahLst/>
+              <a:cxnLst/>
+              <a:rect r="r" b="b" t="t" l="l"/>
+              <a:pathLst>
+                <a:path h="63500" w="1168400">
+                  <a:moveTo>
+                    <a:pt x="0" y="0"/>
+                  </a:moveTo>
+                  <a:lnTo>
+                    <a:pt x="1168400" y="0"/>
+                  </a:lnTo>
+                  <a:lnTo>
+                    <a:pt x="1168400" y="63500"/>
+                  </a:lnTo>
+                  <a:lnTo>
+                    <a:pt x="0" y="63500"/>
+                  </a:lnTo>
+                  <a:close/>
+                </a:path>
+              </a:pathLst>
+            </a:custGeom>
+            <a:solidFill>
+              <a:srgbClr val="2E5C8A"/>
+            </a:solidFill>
+            <a:ln cap="sq">
+              <a:noFill/>
+              <a:prstDash val="solid"/>
+              <a:miter/>
+            </a:ln>
+          </p:spPr>
+        </p:sp>
+        <p:sp>
+          <p:nvSpPr>
+            <p:cNvPr name="TextBox 4" id="4"/>
+            <p:cNvSpPr txBox="true"/>
+            <p:nvPr/>
+          </p:nvSpPr>
+          <p:spPr>
+            <a:xfrm>
+              <a:off x="0" y="-38100"/>
+              <a:ext cx="1168400" cy="101600"/>
+            </a:xfrm>
+            <a:prstGeom prst="rect">
+              <a:avLst/>
+            </a:prstGeom>
+          </p:spPr>
+          <p:txBody>
+            <a:bodyPr anchor="ctr" rtlCol="false" tIns="50800" lIns="50800" bIns="50800" rIns="50800"/>
+            <a:lstStyle/>
+            <a:p>
+              <a:pPr algn="l">
+                <a:lnSpc>
+                  <a:spcPts val="1679"/>
+                </a:lnSpc>
+              </a:pPr>
+            </a:p>
+          </p:txBody>
+        </p:sp>
+      </p:grpSp>
+      <p:sp>
+        <p:nvSpPr>
+          <p:cNvPr name="TextBox 5" id="5"/>
+          <p:cNvSpPr txBox="true"/>
+          <p:nvPr/>
+        </p:nvSpPr>
+        <p:spPr>
+          <a:xfrm rot="0">
+            <a:off x="16764000" y="666750"/>
+            <a:ext cx="476250" cy="222885"/>
+          </a:xfrm>
+          <a:prstGeom prst="rect">
+            <a:avLst/>
+          </a:prstGeom>
+        </p:spPr>
+        <p:txBody>
+          <a:bodyPr anchor="t" rtlCol="false" tIns="0" lIns="0" bIns="0" rIns="0">
+            <a:spAutoFit/>
+          </a:bodyPr>
+          <a:lstStyle/>
+          <a:p>
+            <a:pPr algn="r" marL="0" indent="0" lvl="0">
+              <a:lnSpc>
+                <a:spcPts val="1889"/>
+              </a:lnSpc>
+              <a:spcBef>
+                <a:spcPct val="0"/>
+              </a:spcBef>
+            </a:pPr>
+            <a:r>
+              <a:rPr lang="en-US" sz="1350" strike="noStrike" u="none">
+                <a:solidFill>
+                  <a:srgbClr val="8A98AA"/>
+                </a:solidFill>
+                <a:latin typeface="JetBrains Mono"/>
+                <a:ea typeface="JetBrains Mono"/>
+                <a:cs typeface="JetBrains Mono"/>
+                <a:sym typeface="JetBrains Mono"/>
+              </a:rPr>
+              <a:t>11</a:t>
             </a:r>
           </a:p>
         </p:txBody>
@@ -7928,7 +8917,7 @@
 </p:sld>
 </file>
 
-<file path=ppt/slides/slide11.xml><?xml version="1.0" encoding="utf-8"?>
+<file path=ppt/slides/slide12.xml><?xml version="1.0" encoding="utf-8"?>
 <p:sld xmlns:p="http://schemas.openxmlformats.org/presentationml/2006/main" xmlns:a="http://schemas.openxmlformats.org/drawingml/2006/main">
   <p:cSld>
     <p:bg>
@@ -8060,13 +9049,16 @@
           </a:bodyPr>
           <a:lstStyle/>
           <a:p>
-            <a:pPr algn="r">
+            <a:pPr algn="r" marL="0" indent="0" lvl="0">
               <a:lnSpc>
                 <a:spcPts val="1889"/>
               </a:lnSpc>
+              <a:spcBef>
+                <a:spcPct val="0"/>
+              </a:spcBef>
             </a:pPr>
             <a:r>
-              <a:rPr lang="en-US" sz="1350">
+              <a:rPr lang="en-US" sz="1350" strike="noStrike" u="none">
                 <a:solidFill>
                   <a:srgbClr val="8A98AA"/>
                 </a:solidFill>
@@ -8075,7 +9067,7 @@
                 <a:cs typeface="JetBrains Mono"/>
                 <a:sym typeface="JetBrains Mono"/>
               </a:rPr>
-              <a:t>11</a:t>
+              <a:t>12</a:t>
             </a:r>
           </a:p>
         </p:txBody>
@@ -8899,7 +9891,7 @@
 </p:sld>
 </file>
 
-<file path=ppt/slides/slide12.xml><?xml version="1.0" encoding="utf-8"?>
+<file path=ppt/slides/slide13.xml><?xml version="1.0" encoding="utf-8"?>
 <p:sld xmlns:p="http://schemas.openxmlformats.org/presentationml/2006/main" xmlns:a="http://schemas.openxmlformats.org/drawingml/2006/main">
   <p:cSld>
     <p:bg>
@@ -9031,13 +10023,16 @@
           </a:bodyPr>
           <a:lstStyle/>
           <a:p>
-            <a:pPr algn="r">
+            <a:pPr algn="r" marL="0" indent="0" lvl="0">
               <a:lnSpc>
                 <a:spcPts val="1889"/>
               </a:lnSpc>
+              <a:spcBef>
+                <a:spcPct val="0"/>
+              </a:spcBef>
             </a:pPr>
             <a:r>
-              <a:rPr lang="en-US" sz="1350">
+              <a:rPr lang="en-US" sz="1350" strike="noStrike" u="none">
                 <a:solidFill>
                   <a:srgbClr val="8A98AA"/>
                 </a:solidFill>
@@ -9046,7 +10041,7 @@
                 <a:cs typeface="JetBrains Mono"/>
                 <a:sym typeface="JetBrains Mono"/>
               </a:rPr>
-              <a:t>12</a:t>
+              <a:t>13</a:t>
             </a:r>
           </a:p>
         </p:txBody>
@@ -9485,6 +10480,817 @@
 </file>
 
 <file path=ppt/slides/slide2.xml><?xml version="1.0" encoding="utf-8"?>
+<p:sld xmlns:p="http://schemas.openxmlformats.org/presentationml/2006/main" xmlns:a="http://schemas.openxmlformats.org/drawingml/2006/main">
+  <p:cSld>
+    <p:bg>
+      <p:bgPr>
+        <a:solidFill>
+          <a:srgbClr val="EDF1F6"/>
+        </a:solidFill>
+      </p:bgPr>
+    </p:bg>
+    <p:spTree>
+      <p:nvGrpSpPr>
+        <p:cNvPr id="1" name=""/>
+        <p:cNvGrpSpPr/>
+        <p:nvPr/>
+      </p:nvGrpSpPr>
+      <p:grpSpPr>
+        <a:xfrm>
+          <a:off x="0" y="0"/>
+          <a:ext cx="0" cy="0"/>
+          <a:chOff x="0" y="0"/>
+          <a:chExt cx="0" cy="0"/>
+        </a:xfrm>
+      </p:grpSpPr>
+      <p:grpSp>
+        <p:nvGrpSpPr>
+          <p:cNvPr name="Group 2" id="2"/>
+          <p:cNvGrpSpPr/>
+          <p:nvPr/>
+        </p:nvGrpSpPr>
+        <p:grpSpPr>
+          <a:xfrm rot="0">
+            <a:off x="1047750" y="819150"/>
+            <a:ext cx="876300" cy="47625"/>
+            <a:chOff x="0" y="0"/>
+            <a:chExt cx="1168400" cy="63500"/>
+          </a:xfrm>
+        </p:grpSpPr>
+        <p:sp>
+          <p:nvSpPr>
+            <p:cNvPr name="Freeform 3" id="3"/>
+            <p:cNvSpPr/>
+            <p:nvPr/>
+          </p:nvSpPr>
+          <p:spPr>
+            <a:xfrm flipH="false" flipV="false" rot="0">
+              <a:off x="0" y="0"/>
+              <a:ext cx="1168400" cy="63500"/>
+            </a:xfrm>
+            <a:custGeom>
+              <a:avLst/>
+              <a:gdLst/>
+              <a:ahLst/>
+              <a:cxnLst/>
+              <a:rect r="r" b="b" t="t" l="l"/>
+              <a:pathLst>
+                <a:path h="63500" w="1168400">
+                  <a:moveTo>
+                    <a:pt x="0" y="0"/>
+                  </a:moveTo>
+                  <a:lnTo>
+                    <a:pt x="1168400" y="0"/>
+                  </a:lnTo>
+                  <a:lnTo>
+                    <a:pt x="1168400" y="63500"/>
+                  </a:lnTo>
+                  <a:lnTo>
+                    <a:pt x="0" y="63500"/>
+                  </a:lnTo>
+                  <a:close/>
+                </a:path>
+              </a:pathLst>
+            </a:custGeom>
+            <a:solidFill>
+              <a:srgbClr val="2E5C8A"/>
+            </a:solidFill>
+          </p:spPr>
+        </p:sp>
+        <p:sp>
+          <p:nvSpPr>
+            <p:cNvPr name="TextBox 4" id="4"/>
+            <p:cNvSpPr txBox="true"/>
+            <p:nvPr/>
+          </p:nvSpPr>
+          <p:spPr>
+            <a:xfrm>
+              <a:off x="0" y="-38100"/>
+              <a:ext cx="1168400" cy="101600"/>
+            </a:xfrm>
+            <a:prstGeom prst="rect">
+              <a:avLst/>
+            </a:prstGeom>
+          </p:spPr>
+          <p:txBody>
+            <a:bodyPr anchor="ctr" rtlCol="false" tIns="50800" lIns="50800" bIns="50800" rIns="50800"/>
+            <a:lstStyle/>
+            <a:p>
+              <a:pPr algn="l">
+                <a:lnSpc>
+                  <a:spcPts val="1679"/>
+                </a:lnSpc>
+              </a:pPr>
+            </a:p>
+          </p:txBody>
+        </p:sp>
+      </p:grpSp>
+      <p:sp>
+        <p:nvSpPr>
+          <p:cNvPr name="TextBox 5" id="5"/>
+          <p:cNvSpPr txBox="true"/>
+          <p:nvPr/>
+        </p:nvSpPr>
+        <p:spPr>
+          <a:xfrm rot="0">
+            <a:off x="16764000" y="647700"/>
+            <a:ext cx="476250" cy="241935"/>
+          </a:xfrm>
+          <a:prstGeom prst="rect">
+            <a:avLst/>
+          </a:prstGeom>
+        </p:spPr>
+        <p:txBody>
+          <a:bodyPr anchor="t" rtlCol="false" tIns="0" lIns="0" bIns="0" rIns="0">
+            <a:spAutoFit/>
+          </a:bodyPr>
+          <a:lstStyle/>
+          <a:p>
+            <a:pPr algn="r">
+              <a:lnSpc>
+                <a:spcPts val="1889"/>
+              </a:lnSpc>
+            </a:pPr>
+            <a:r>
+              <a:rPr lang="en-US" sz="1350">
+                <a:solidFill>
+                  <a:srgbClr val="8A98AA"/>
+                </a:solidFill>
+                <a:latin typeface="Arimo"/>
+                <a:ea typeface="Arimo"/>
+                <a:cs typeface="Arimo"/>
+                <a:sym typeface="Arimo"/>
+              </a:rPr>
+              <a:t>02</a:t>
+            </a:r>
+          </a:p>
+        </p:txBody>
+      </p:sp>
+      <p:sp>
+        <p:nvSpPr>
+          <p:cNvPr name="TextBox 6" id="6"/>
+          <p:cNvSpPr txBox="true"/>
+          <p:nvPr/>
+        </p:nvSpPr>
+        <p:spPr>
+          <a:xfrm rot="0">
+            <a:off x="1047750" y="1181100"/>
+            <a:ext cx="11430000" cy="692277"/>
+          </a:xfrm>
+          <a:prstGeom prst="rect">
+            <a:avLst/>
+          </a:prstGeom>
+        </p:spPr>
+        <p:txBody>
+          <a:bodyPr anchor="t" rtlCol="false" tIns="0" lIns="0" bIns="0" rIns="0">
+            <a:spAutoFit/>
+          </a:bodyPr>
+          <a:lstStyle/>
+          <a:p>
+            <a:pPr algn="l">
+              <a:lnSpc>
+                <a:spcPts val="5184"/>
+              </a:lnSpc>
+            </a:pPr>
+            <a:r>
+              <a:rPr lang="en-US" sz="4800" b="true">
+                <a:solidFill>
+                  <a:srgbClr val="1B2A3F"/>
+                </a:solidFill>
+                <a:latin typeface="Arimo Bold"/>
+                <a:ea typeface="Arimo Bold"/>
+                <a:cs typeface="Arimo Bold"/>
+                <a:sym typeface="Arimo Bold"/>
+              </a:rPr>
+              <a:t>Nội dung</a:t>
+            </a:r>
+          </a:p>
+        </p:txBody>
+      </p:sp>
+      <p:sp>
+        <p:nvSpPr>
+          <p:cNvPr name="TextBox 7" id="7"/>
+          <p:cNvSpPr txBox="true"/>
+          <p:nvPr/>
+        </p:nvSpPr>
+        <p:spPr>
+          <a:xfrm rot="0">
+            <a:off x="1047750" y="1962150"/>
+            <a:ext cx="11430000" cy="350520"/>
+          </a:xfrm>
+          <a:prstGeom prst="rect">
+            <a:avLst/>
+          </a:prstGeom>
+        </p:spPr>
+        <p:txBody>
+          <a:bodyPr anchor="t" rtlCol="false" tIns="0" lIns="0" bIns="0" rIns="0">
+            <a:spAutoFit/>
+          </a:bodyPr>
+          <a:lstStyle/>
+          <a:p>
+            <a:pPr algn="l">
+              <a:lnSpc>
+                <a:spcPts val="2729"/>
+              </a:lnSpc>
+            </a:pPr>
+            <a:r>
+              <a:rPr lang="en-US" sz="1950">
+                <a:solidFill>
+                  <a:srgbClr val="3C4A5C"/>
+                </a:solidFill>
+                <a:latin typeface="Arimo"/>
+                <a:ea typeface="Arimo"/>
+                <a:cs typeface="Arimo"/>
+                <a:sym typeface="Arimo"/>
+              </a:rPr>
+              <a:t>Bài trình bày gồm bảy phần</a:t>
+            </a:r>
+          </a:p>
+        </p:txBody>
+      </p:sp>
+      <p:sp>
+        <p:nvSpPr>
+          <p:cNvPr name="TextBox 8" id="8"/>
+          <p:cNvSpPr txBox="true"/>
+          <p:nvPr/>
+        </p:nvSpPr>
+        <p:spPr>
+          <a:xfrm rot="0">
+            <a:off x="1047750" y="2924175"/>
+            <a:ext cx="857250" cy="365760"/>
+          </a:xfrm>
+          <a:prstGeom prst="rect">
+            <a:avLst/>
+          </a:prstGeom>
+        </p:spPr>
+        <p:txBody>
+          <a:bodyPr anchor="t" rtlCol="false" tIns="0" lIns="0" bIns="0" rIns="0">
+            <a:spAutoFit/>
+          </a:bodyPr>
+          <a:lstStyle/>
+          <a:p>
+            <a:pPr algn="l">
+              <a:lnSpc>
+                <a:spcPts val="2940"/>
+              </a:lnSpc>
+            </a:pPr>
+            <a:r>
+              <a:rPr lang="en-US" sz="2100">
+                <a:solidFill>
+                  <a:srgbClr val="2E5C8A"/>
+                </a:solidFill>
+                <a:latin typeface="Arimo"/>
+                <a:ea typeface="Arimo"/>
+                <a:cs typeface="Arimo"/>
+                <a:sym typeface="Arimo"/>
+              </a:rPr>
+              <a:t>01</a:t>
+            </a:r>
+          </a:p>
+        </p:txBody>
+      </p:sp>
+      <p:sp>
+        <p:nvSpPr>
+          <p:cNvPr name="TextBox 9" id="9"/>
+          <p:cNvSpPr txBox="true"/>
+          <p:nvPr/>
+        </p:nvSpPr>
+        <p:spPr>
+          <a:xfrm rot="0">
+            <a:off x="2190750" y="2847975"/>
+            <a:ext cx="14287500" cy="440055"/>
+          </a:xfrm>
+          <a:prstGeom prst="rect">
+            <a:avLst/>
+          </a:prstGeom>
+        </p:spPr>
+        <p:txBody>
+          <a:bodyPr anchor="t" rtlCol="false" tIns="0" lIns="0" bIns="0" rIns="0">
+            <a:spAutoFit/>
+          </a:bodyPr>
+          <a:lstStyle/>
+          <a:p>
+            <a:pPr algn="l">
+              <a:lnSpc>
+                <a:spcPts val="3569"/>
+              </a:lnSpc>
+            </a:pPr>
+            <a:r>
+              <a:rPr lang="en-US" sz="2550">
+                <a:solidFill>
+                  <a:srgbClr val="1B2A3F"/>
+                </a:solidFill>
+                <a:latin typeface="Arimo"/>
+                <a:ea typeface="Arimo"/>
+                <a:cs typeface="Arimo"/>
+                <a:sym typeface="Arimo"/>
+              </a:rPr>
+              <a:t>Bài toán — điểm số cần toàn vẹn</a:t>
+            </a:r>
+          </a:p>
+        </p:txBody>
+      </p:sp>
+      <p:sp>
+        <p:nvSpPr>
+          <p:cNvPr name="TextBox 10" id="10"/>
+          <p:cNvSpPr txBox="true"/>
+          <p:nvPr/>
+        </p:nvSpPr>
+        <p:spPr>
+          <a:xfrm rot="0">
+            <a:off x="1047750" y="3800475"/>
+            <a:ext cx="857250" cy="365760"/>
+          </a:xfrm>
+          <a:prstGeom prst="rect">
+            <a:avLst/>
+          </a:prstGeom>
+        </p:spPr>
+        <p:txBody>
+          <a:bodyPr anchor="t" rtlCol="false" tIns="0" lIns="0" bIns="0" rIns="0">
+            <a:spAutoFit/>
+          </a:bodyPr>
+          <a:lstStyle/>
+          <a:p>
+            <a:pPr algn="l">
+              <a:lnSpc>
+                <a:spcPts val="2940"/>
+              </a:lnSpc>
+            </a:pPr>
+            <a:r>
+              <a:rPr lang="en-US" sz="2100">
+                <a:solidFill>
+                  <a:srgbClr val="2E5C8A"/>
+                </a:solidFill>
+                <a:latin typeface="Arimo"/>
+                <a:ea typeface="Arimo"/>
+                <a:cs typeface="Arimo"/>
+                <a:sym typeface="Arimo"/>
+              </a:rPr>
+              <a:t>02</a:t>
+            </a:r>
+          </a:p>
+        </p:txBody>
+      </p:sp>
+      <p:sp>
+        <p:nvSpPr>
+          <p:cNvPr name="TextBox 11" id="11"/>
+          <p:cNvSpPr txBox="true"/>
+          <p:nvPr/>
+        </p:nvSpPr>
+        <p:spPr>
+          <a:xfrm rot="0">
+            <a:off x="2190750" y="3724275"/>
+            <a:ext cx="14287500" cy="440055"/>
+          </a:xfrm>
+          <a:prstGeom prst="rect">
+            <a:avLst/>
+          </a:prstGeom>
+        </p:spPr>
+        <p:txBody>
+          <a:bodyPr anchor="t" rtlCol="false" tIns="0" lIns="0" bIns="0" rIns="0">
+            <a:spAutoFit/>
+          </a:bodyPr>
+          <a:lstStyle/>
+          <a:p>
+            <a:pPr algn="l">
+              <a:lnSpc>
+                <a:spcPts val="3569"/>
+              </a:lnSpc>
+            </a:pPr>
+            <a:r>
+              <a:rPr lang="en-US" sz="2550">
+                <a:solidFill>
+                  <a:srgbClr val="1B2A3F"/>
+                </a:solidFill>
+                <a:latin typeface="Arimo"/>
+                <a:ea typeface="Arimo"/>
+                <a:cs typeface="Arimo"/>
+                <a:sym typeface="Arimo"/>
+              </a:rPr>
+              <a:t>Kiến trúc phân vùng mạng</a:t>
+            </a:r>
+          </a:p>
+        </p:txBody>
+      </p:sp>
+      <p:sp>
+        <p:nvSpPr>
+          <p:cNvPr name="TextBox 12" id="12"/>
+          <p:cNvSpPr txBox="true"/>
+          <p:nvPr/>
+        </p:nvSpPr>
+        <p:spPr>
+          <a:xfrm rot="0">
+            <a:off x="1047750" y="4676775"/>
+            <a:ext cx="857250" cy="365760"/>
+          </a:xfrm>
+          <a:prstGeom prst="rect">
+            <a:avLst/>
+          </a:prstGeom>
+        </p:spPr>
+        <p:txBody>
+          <a:bodyPr anchor="t" rtlCol="false" tIns="0" lIns="0" bIns="0" rIns="0">
+            <a:spAutoFit/>
+          </a:bodyPr>
+          <a:lstStyle/>
+          <a:p>
+            <a:pPr algn="l">
+              <a:lnSpc>
+                <a:spcPts val="2940"/>
+              </a:lnSpc>
+            </a:pPr>
+            <a:r>
+              <a:rPr lang="en-US" sz="2100">
+                <a:solidFill>
+                  <a:srgbClr val="2E5C8A"/>
+                </a:solidFill>
+                <a:latin typeface="Arimo"/>
+                <a:ea typeface="Arimo"/>
+                <a:cs typeface="Arimo"/>
+                <a:sym typeface="Arimo"/>
+              </a:rPr>
+              <a:t>03</a:t>
+            </a:r>
+          </a:p>
+        </p:txBody>
+      </p:sp>
+      <p:sp>
+        <p:nvSpPr>
+          <p:cNvPr name="TextBox 13" id="13"/>
+          <p:cNvSpPr txBox="true"/>
+          <p:nvPr/>
+        </p:nvSpPr>
+        <p:spPr>
+          <a:xfrm rot="0">
+            <a:off x="2190750" y="4600575"/>
+            <a:ext cx="14287500" cy="440055"/>
+          </a:xfrm>
+          <a:prstGeom prst="rect">
+            <a:avLst/>
+          </a:prstGeom>
+        </p:spPr>
+        <p:txBody>
+          <a:bodyPr anchor="t" rtlCol="false" tIns="0" lIns="0" bIns="0" rIns="0">
+            <a:spAutoFit/>
+          </a:bodyPr>
+          <a:lstStyle/>
+          <a:p>
+            <a:pPr algn="l">
+              <a:lnSpc>
+                <a:spcPts val="3569"/>
+              </a:lnSpc>
+            </a:pPr>
+            <a:r>
+              <a:rPr lang="en-US" sz="2550">
+                <a:solidFill>
+                  <a:srgbClr val="1B2A3F"/>
+                </a:solidFill>
+                <a:latin typeface="Arimo"/>
+                <a:ea typeface="Arimo"/>
+                <a:cs typeface="Arimo"/>
+                <a:sym typeface="Arimo"/>
+              </a:rPr>
+              <a:t>Không tin mặc định — 12 lớp kiểm chứng</a:t>
+            </a:r>
+          </a:p>
+        </p:txBody>
+      </p:sp>
+      <p:sp>
+        <p:nvSpPr>
+          <p:cNvPr name="TextBox 14" id="14"/>
+          <p:cNvSpPr txBox="true"/>
+          <p:nvPr/>
+        </p:nvSpPr>
+        <p:spPr>
+          <a:xfrm rot="0">
+            <a:off x="1047750" y="5553075"/>
+            <a:ext cx="857250" cy="365760"/>
+          </a:xfrm>
+          <a:prstGeom prst="rect">
+            <a:avLst/>
+          </a:prstGeom>
+        </p:spPr>
+        <p:txBody>
+          <a:bodyPr anchor="t" rtlCol="false" tIns="0" lIns="0" bIns="0" rIns="0">
+            <a:spAutoFit/>
+          </a:bodyPr>
+          <a:lstStyle/>
+          <a:p>
+            <a:pPr algn="l">
+              <a:lnSpc>
+                <a:spcPts val="2940"/>
+              </a:lnSpc>
+            </a:pPr>
+            <a:r>
+              <a:rPr lang="en-US" sz="2100">
+                <a:solidFill>
+                  <a:srgbClr val="2E5C8A"/>
+                </a:solidFill>
+                <a:latin typeface="Arimo"/>
+                <a:ea typeface="Arimo"/>
+                <a:cs typeface="Arimo"/>
+                <a:sym typeface="Arimo"/>
+              </a:rPr>
+              <a:t>04</a:t>
+            </a:r>
+          </a:p>
+        </p:txBody>
+      </p:sp>
+      <p:sp>
+        <p:nvSpPr>
+          <p:cNvPr name="TextBox 15" id="15"/>
+          <p:cNvSpPr txBox="true"/>
+          <p:nvPr/>
+        </p:nvSpPr>
+        <p:spPr>
+          <a:xfrm rot="0">
+            <a:off x="2190750" y="5476875"/>
+            <a:ext cx="14287500" cy="440055"/>
+          </a:xfrm>
+          <a:prstGeom prst="rect">
+            <a:avLst/>
+          </a:prstGeom>
+        </p:spPr>
+        <p:txBody>
+          <a:bodyPr anchor="t" rtlCol="false" tIns="0" lIns="0" bIns="0" rIns="0">
+            <a:spAutoFit/>
+          </a:bodyPr>
+          <a:lstStyle/>
+          <a:p>
+            <a:pPr algn="l">
+              <a:lnSpc>
+                <a:spcPts val="3569"/>
+              </a:lnSpc>
+            </a:pPr>
+            <a:r>
+              <a:rPr lang="en-US" sz="2550">
+                <a:solidFill>
+                  <a:srgbClr val="1B2A3F"/>
+                </a:solidFill>
+                <a:latin typeface="Arimo"/>
+                <a:ea typeface="Arimo"/>
+                <a:cs typeface="Arimo"/>
+                <a:sym typeface="Arimo"/>
+              </a:rPr>
+              <a:t>Rủi ro chính và cách kiểm soát</a:t>
+            </a:r>
+          </a:p>
+        </p:txBody>
+      </p:sp>
+      <p:sp>
+        <p:nvSpPr>
+          <p:cNvPr name="TextBox 16" id="16"/>
+          <p:cNvSpPr txBox="true"/>
+          <p:nvPr/>
+        </p:nvSpPr>
+        <p:spPr>
+          <a:xfrm rot="0">
+            <a:off x="1047750" y="6429375"/>
+            <a:ext cx="857250" cy="365760"/>
+          </a:xfrm>
+          <a:prstGeom prst="rect">
+            <a:avLst/>
+          </a:prstGeom>
+        </p:spPr>
+        <p:txBody>
+          <a:bodyPr anchor="t" rtlCol="false" tIns="0" lIns="0" bIns="0" rIns="0">
+            <a:spAutoFit/>
+          </a:bodyPr>
+          <a:lstStyle/>
+          <a:p>
+            <a:pPr algn="l">
+              <a:lnSpc>
+                <a:spcPts val="2940"/>
+              </a:lnSpc>
+            </a:pPr>
+            <a:r>
+              <a:rPr lang="en-US" sz="2100" b="true">
+                <a:solidFill>
+                  <a:srgbClr val="C0392B"/>
+                </a:solidFill>
+                <a:latin typeface="Arimo Bold"/>
+                <a:ea typeface="Arimo Bold"/>
+                <a:cs typeface="Arimo Bold"/>
+                <a:sym typeface="Arimo Bold"/>
+              </a:rPr>
+              <a:t>05</a:t>
+            </a:r>
+          </a:p>
+        </p:txBody>
+      </p:sp>
+      <p:sp>
+        <p:nvSpPr>
+          <p:cNvPr name="TextBox 17" id="17"/>
+          <p:cNvSpPr txBox="true"/>
+          <p:nvPr/>
+        </p:nvSpPr>
+        <p:spPr>
+          <a:xfrm rot="0">
+            <a:off x="2190750" y="6353175"/>
+            <a:ext cx="14287500" cy="440055"/>
+          </a:xfrm>
+          <a:prstGeom prst="rect">
+            <a:avLst/>
+          </a:prstGeom>
+        </p:spPr>
+        <p:txBody>
+          <a:bodyPr anchor="t" rtlCol="false" tIns="0" lIns="0" bIns="0" rIns="0">
+            <a:spAutoFit/>
+          </a:bodyPr>
+          <a:lstStyle/>
+          <a:p>
+            <a:pPr algn="l">
+              <a:lnSpc>
+                <a:spcPts val="3569"/>
+              </a:lnSpc>
+            </a:pPr>
+            <a:r>
+              <a:rPr lang="en-US" sz="2550" b="true">
+                <a:solidFill>
+                  <a:srgbClr val="1B2A3F"/>
+                </a:solidFill>
+                <a:latin typeface="Arimo Bold"/>
+                <a:ea typeface="Arimo Bold"/>
+                <a:cs typeface="Arimo Bold"/>
+                <a:sym typeface="Arimo Bold"/>
+              </a:rPr>
+              <a:t>Demo trực tiếp — cookie bị đánh cắp, insider sửa database</a:t>
+            </a:r>
+          </a:p>
+        </p:txBody>
+      </p:sp>
+      <p:sp>
+        <p:nvSpPr>
+          <p:cNvPr name="TextBox 18" id="18"/>
+          <p:cNvSpPr txBox="true"/>
+          <p:nvPr/>
+        </p:nvSpPr>
+        <p:spPr>
+          <a:xfrm rot="0">
+            <a:off x="1047750" y="7305675"/>
+            <a:ext cx="857250" cy="365760"/>
+          </a:xfrm>
+          <a:prstGeom prst="rect">
+            <a:avLst/>
+          </a:prstGeom>
+        </p:spPr>
+        <p:txBody>
+          <a:bodyPr anchor="t" rtlCol="false" tIns="0" lIns="0" bIns="0" rIns="0">
+            <a:spAutoFit/>
+          </a:bodyPr>
+          <a:lstStyle/>
+          <a:p>
+            <a:pPr algn="l">
+              <a:lnSpc>
+                <a:spcPts val="2940"/>
+              </a:lnSpc>
+            </a:pPr>
+            <a:r>
+              <a:rPr lang="en-US" sz="2100">
+                <a:solidFill>
+                  <a:srgbClr val="2E5C8A"/>
+                </a:solidFill>
+                <a:latin typeface="Arimo"/>
+                <a:ea typeface="Arimo"/>
+                <a:cs typeface="Arimo"/>
+                <a:sym typeface="Arimo"/>
+              </a:rPr>
+              <a:t>06</a:t>
+            </a:r>
+          </a:p>
+        </p:txBody>
+      </p:sp>
+      <p:sp>
+        <p:nvSpPr>
+          <p:cNvPr name="TextBox 19" id="19"/>
+          <p:cNvSpPr txBox="true"/>
+          <p:nvPr/>
+        </p:nvSpPr>
+        <p:spPr>
+          <a:xfrm rot="0">
+            <a:off x="2190750" y="7229475"/>
+            <a:ext cx="14287500" cy="440055"/>
+          </a:xfrm>
+          <a:prstGeom prst="rect">
+            <a:avLst/>
+          </a:prstGeom>
+        </p:spPr>
+        <p:txBody>
+          <a:bodyPr anchor="t" rtlCol="false" tIns="0" lIns="0" bIns="0" rIns="0">
+            <a:spAutoFit/>
+          </a:bodyPr>
+          <a:lstStyle/>
+          <a:p>
+            <a:pPr algn="l">
+              <a:lnSpc>
+                <a:spcPts val="3569"/>
+              </a:lnSpc>
+            </a:pPr>
+            <a:r>
+              <a:rPr lang="en-US" sz="2550">
+                <a:solidFill>
+                  <a:srgbClr val="1B2A3F"/>
+                </a:solidFill>
+                <a:latin typeface="Arimo"/>
+                <a:ea typeface="Arimo"/>
+                <a:cs typeface="Arimo"/>
+                <a:sym typeface="Arimo"/>
+              </a:rPr>
+              <a:t>Kết quả kiểm thử và trade-off</a:t>
+            </a:r>
+          </a:p>
+        </p:txBody>
+      </p:sp>
+      <p:sp>
+        <p:nvSpPr>
+          <p:cNvPr name="TextBox 20" id="20"/>
+          <p:cNvSpPr txBox="true"/>
+          <p:nvPr/>
+        </p:nvSpPr>
+        <p:spPr>
+          <a:xfrm rot="0">
+            <a:off x="1047750" y="8181975"/>
+            <a:ext cx="857250" cy="365760"/>
+          </a:xfrm>
+          <a:prstGeom prst="rect">
+            <a:avLst/>
+          </a:prstGeom>
+        </p:spPr>
+        <p:txBody>
+          <a:bodyPr anchor="t" rtlCol="false" tIns="0" lIns="0" bIns="0" rIns="0">
+            <a:spAutoFit/>
+          </a:bodyPr>
+          <a:lstStyle/>
+          <a:p>
+            <a:pPr algn="l">
+              <a:lnSpc>
+                <a:spcPts val="2940"/>
+              </a:lnSpc>
+            </a:pPr>
+            <a:r>
+              <a:rPr lang="en-US" sz="2100">
+                <a:solidFill>
+                  <a:srgbClr val="2E5C8A"/>
+                </a:solidFill>
+                <a:latin typeface="Arimo"/>
+                <a:ea typeface="Arimo"/>
+                <a:cs typeface="Arimo"/>
+                <a:sym typeface="Arimo"/>
+              </a:rPr>
+              <a:t>07</a:t>
+            </a:r>
+          </a:p>
+        </p:txBody>
+      </p:sp>
+      <p:sp>
+        <p:nvSpPr>
+          <p:cNvPr name="TextBox 21" id="21"/>
+          <p:cNvSpPr txBox="true"/>
+          <p:nvPr/>
+        </p:nvSpPr>
+        <p:spPr>
+          <a:xfrm rot="0">
+            <a:off x="2190750" y="8105775"/>
+            <a:ext cx="14287500" cy="440055"/>
+          </a:xfrm>
+          <a:prstGeom prst="rect">
+            <a:avLst/>
+          </a:prstGeom>
+        </p:spPr>
+        <p:txBody>
+          <a:bodyPr anchor="t" rtlCol="false" tIns="0" lIns="0" bIns="0" rIns="0">
+            <a:spAutoFit/>
+          </a:bodyPr>
+          <a:lstStyle/>
+          <a:p>
+            <a:pPr algn="l">
+              <a:lnSpc>
+                <a:spcPts val="3569"/>
+              </a:lnSpc>
+            </a:pPr>
+            <a:r>
+              <a:rPr lang="en-US" sz="2550">
+                <a:solidFill>
+                  <a:srgbClr val="1B2A3F"/>
+                </a:solidFill>
+                <a:latin typeface="Arimo"/>
+                <a:ea typeface="Arimo"/>
+                <a:cs typeface="Arimo"/>
+                <a:sym typeface="Arimo"/>
+              </a:rPr>
+              <a:t>Hạn chế và kết luận</a:t>
+            </a:r>
+          </a:p>
+        </p:txBody>
+      </p:sp>
+    </p:spTree>
+  </p:cSld>
+  <p:clrMapOvr>
+    <a:masterClrMapping/>
+  </p:clrMapOvr>
+</p:sld>
+</file>
+
+<file path=ppt/slides/slide3.xml><?xml version="1.0" encoding="utf-8"?>
 <p:sld xmlns:p="http://schemas.openxmlformats.org/presentationml/2006/main" xmlns:a="http://schemas.openxmlformats.org/drawingml/2006/main">
   <p:cSld>
     <p:bg>
@@ -9616,13 +11422,16 @@
           </a:bodyPr>
           <a:lstStyle/>
           <a:p>
-            <a:pPr algn="r">
+            <a:pPr algn="r" marL="0" indent="0" lvl="0">
               <a:lnSpc>
                 <a:spcPts val="1889"/>
               </a:lnSpc>
+              <a:spcBef>
+                <a:spcPct val="0"/>
+              </a:spcBef>
             </a:pPr>
             <a:r>
-              <a:rPr lang="en-US" sz="1350">
+              <a:rPr lang="en-US" sz="1350" strike="noStrike" u="none">
                 <a:solidFill>
                   <a:srgbClr val="8A98AA"/>
                 </a:solidFill>
@@ -9631,7 +11440,7 @@
                 <a:cs typeface="JetBrains Mono"/>
                 <a:sym typeface="JetBrains Mono"/>
               </a:rPr>
-              <a:t>02</a:t>
+              <a:t>03</a:t>
             </a:r>
           </a:p>
         </p:txBody>
@@ -9911,7 +11720,7 @@
 </p:sld>
 </file>
 
-<file path=ppt/slides/slide3.xml><?xml version="1.0" encoding="utf-8"?>
+<file path=ppt/slides/slide4.xml><?xml version="1.0" encoding="utf-8"?>
 <p:sld xmlns:p="http://schemas.openxmlformats.org/presentationml/2006/main" xmlns:a="http://schemas.openxmlformats.org/drawingml/2006/main" show="false">
   <p:cSld>
     <p:bg>
@@ -10043,13 +11852,16 @@
           </a:bodyPr>
           <a:lstStyle/>
           <a:p>
-            <a:pPr algn="r">
+            <a:pPr algn="r" marL="0" indent="0" lvl="0">
               <a:lnSpc>
                 <a:spcPts val="1889"/>
               </a:lnSpc>
+              <a:spcBef>
+                <a:spcPct val="0"/>
+              </a:spcBef>
             </a:pPr>
             <a:r>
-              <a:rPr lang="en-US" sz="1350">
+              <a:rPr lang="en-US" sz="1350" strike="noStrike" u="none">
                 <a:solidFill>
                   <a:srgbClr val="8A98AA"/>
                 </a:solidFill>
@@ -10058,7 +11870,7 @@
                 <a:cs typeface="JetBrains Mono"/>
                 <a:sym typeface="JetBrains Mono"/>
               </a:rPr>
-              <a:t>03</a:t>
+              <a:t>04</a:t>
             </a:r>
           </a:p>
         </p:txBody>
@@ -10858,7 +12670,7 @@
 </p:sld>
 </file>
 
-<file path=ppt/slides/slide4.xml><?xml version="1.0" encoding="utf-8"?>
+<file path=ppt/slides/slide5.xml><?xml version="1.0" encoding="utf-8"?>
 <p:sld xmlns:p="http://schemas.openxmlformats.org/presentationml/2006/main" xmlns:a="http://schemas.openxmlformats.org/drawingml/2006/main" xmlns:r="http://schemas.openxmlformats.org/officeDocument/2006/relationships">
   <p:cSld>
     <p:bg>
@@ -10990,13 +12802,16 @@
           </a:bodyPr>
           <a:lstStyle/>
           <a:p>
-            <a:pPr algn="r">
+            <a:pPr algn="r" marL="0" indent="0" lvl="0">
               <a:lnSpc>
                 <a:spcPts val="1889"/>
               </a:lnSpc>
+              <a:spcBef>
+                <a:spcPct val="0"/>
+              </a:spcBef>
             </a:pPr>
             <a:r>
-              <a:rPr lang="en-US" sz="1350">
+              <a:rPr lang="en-US" sz="1350" strike="noStrike" u="none">
                 <a:solidFill>
                   <a:srgbClr val="8A98AA"/>
                 </a:solidFill>
@@ -11005,7 +12820,7 @@
                 <a:cs typeface="JetBrains Mono"/>
                 <a:sym typeface="JetBrains Mono"/>
               </a:rPr>
-              <a:t>04</a:t>
+              <a:t>05</a:t>
             </a:r>
           </a:p>
         </p:txBody>
@@ -11421,7 +13236,7 @@
 </p:sld>
 </file>
 
-<file path=ppt/slides/slide5.xml><?xml version="1.0" encoding="utf-8"?>
+<file path=ppt/slides/slide6.xml><?xml version="1.0" encoding="utf-8"?>
 <p:sld xmlns:p="http://schemas.openxmlformats.org/presentationml/2006/main" xmlns:a="http://schemas.openxmlformats.org/drawingml/2006/main">
   <p:cSld>
     <p:bg>
@@ -11553,13 +13368,16 @@
           </a:bodyPr>
           <a:lstStyle/>
           <a:p>
-            <a:pPr algn="r">
+            <a:pPr algn="r" marL="0" indent="0" lvl="0">
               <a:lnSpc>
                 <a:spcPts val="1889"/>
               </a:lnSpc>
+              <a:spcBef>
+                <a:spcPct val="0"/>
+              </a:spcBef>
             </a:pPr>
             <a:r>
-              <a:rPr lang="en-US" sz="1350">
+              <a:rPr lang="en-US" sz="1350" strike="noStrike" u="none">
                 <a:solidFill>
                   <a:srgbClr val="8A98AA"/>
                 </a:solidFill>
@@ -11568,7 +13386,7 @@
                 <a:cs typeface="JetBrains Mono"/>
                 <a:sym typeface="JetBrains Mono"/>
               </a:rPr>
-              <a:t>05</a:t>
+              <a:t>06</a:t>
             </a:r>
           </a:p>
         </p:txBody>
@@ -12522,7 +14340,7 @@
 </p:sld>
 </file>
 
-<file path=ppt/slides/slide6.xml><?xml version="1.0" encoding="utf-8"?>
+<file path=ppt/slides/slide7.xml><?xml version="1.0" encoding="utf-8"?>
 <p:sld xmlns:p="http://schemas.openxmlformats.org/presentationml/2006/main" xmlns:a="http://schemas.openxmlformats.org/drawingml/2006/main" show="false">
   <p:cSld>
     <p:bg>
@@ -12654,13 +14472,16 @@
           </a:bodyPr>
           <a:lstStyle/>
           <a:p>
-            <a:pPr algn="r">
+            <a:pPr algn="r" marL="0" indent="0" lvl="0">
               <a:lnSpc>
                 <a:spcPts val="1889"/>
               </a:lnSpc>
+              <a:spcBef>
+                <a:spcPct val="0"/>
+              </a:spcBef>
             </a:pPr>
             <a:r>
-              <a:rPr lang="en-US" sz="1350">
+              <a:rPr lang="en-US" sz="1350" strike="noStrike" u="none">
                 <a:solidFill>
                   <a:srgbClr val="8A98AA"/>
                 </a:solidFill>
@@ -12669,7 +14490,7 @@
                 <a:cs typeface="JetBrains Mono"/>
                 <a:sym typeface="JetBrains Mono"/>
               </a:rPr>
-              <a:t>06</a:t>
+              <a:t>07</a:t>
             </a:r>
           </a:p>
         </p:txBody>
@@ -14457,7 +16278,7 @@
 </p:sld>
 </file>
 
-<file path=ppt/slides/slide7.xml><?xml version="1.0" encoding="utf-8"?>
+<file path=ppt/slides/slide8.xml><?xml version="1.0" encoding="utf-8"?>
 <p:sld xmlns:p="http://schemas.openxmlformats.org/presentationml/2006/main" xmlns:a="http://schemas.openxmlformats.org/drawingml/2006/main">
   <p:cSld>
     <p:bg>
@@ -14589,13 +16410,16 @@
           </a:bodyPr>
           <a:lstStyle/>
           <a:p>
-            <a:pPr algn="r">
+            <a:pPr algn="r" marL="0" indent="0" lvl="0">
               <a:lnSpc>
                 <a:spcPts val="1889"/>
               </a:lnSpc>
+              <a:spcBef>
+                <a:spcPct val="0"/>
+              </a:spcBef>
             </a:pPr>
             <a:r>
-              <a:rPr lang="en-US" sz="1350">
+              <a:rPr lang="en-US" sz="1350" strike="noStrike" u="none">
                 <a:solidFill>
                   <a:srgbClr val="8A98AA"/>
                 </a:solidFill>
@@ -14604,7 +16428,7 @@
                 <a:cs typeface="JetBrains Mono"/>
                 <a:sym typeface="JetBrains Mono"/>
               </a:rPr>
-              <a:t>07</a:t>
+              <a:t>08</a:t>
             </a:r>
           </a:p>
         </p:txBody>
@@ -16372,7 +18196,7 @@
 </p:sld>
 </file>
 
-<file path=ppt/slides/slide8.xml><?xml version="1.0" encoding="utf-8"?>
+<file path=ppt/slides/slide9.xml><?xml version="1.0" encoding="utf-8"?>
 <p:sld xmlns:p="http://schemas.openxmlformats.org/presentationml/2006/main" xmlns:a="http://schemas.openxmlformats.org/drawingml/2006/main">
   <p:cSld>
     <p:bg>
@@ -16504,13 +18328,16 @@
           </a:bodyPr>
           <a:lstStyle/>
           <a:p>
-            <a:pPr algn="r">
+            <a:pPr algn="r" marL="0" indent="0" lvl="0">
               <a:lnSpc>
                 <a:spcPts val="1889"/>
               </a:lnSpc>
+              <a:spcBef>
+                <a:spcPct val="0"/>
+              </a:spcBef>
             </a:pPr>
             <a:r>
-              <a:rPr lang="en-US" sz="1350">
+              <a:rPr lang="en-US" sz="1350" strike="noStrike" u="none">
                 <a:solidFill>
                   <a:srgbClr val="8A98AA"/>
                 </a:solidFill>
@@ -16519,7 +18346,7 @@
                 <a:cs typeface="JetBrains Mono"/>
                 <a:sym typeface="JetBrains Mono"/>
               </a:rPr>
-              <a:t>08</a:t>
+              <a:t>09</a:t>
             </a:r>
           </a:p>
         </p:txBody>
@@ -16692,752 +18519,6 @@
                 <a:sym typeface="JetBrains Mono"/>
               </a:rPr>
               <a:t>Màn hình live  ·  KB2 đánh cắp cookie  ·  KB6 insider sửa DB</a:t>
-            </a:r>
-          </a:p>
-        </p:txBody>
-      </p:sp>
-    </p:spTree>
-  </p:cSld>
-  <p:clrMapOvr>
-    <a:masterClrMapping/>
-  </p:clrMapOvr>
-</p:sld>
-</file>
-
-<file path=ppt/slides/slide9.xml><?xml version="1.0" encoding="utf-8"?>
-<p:sld xmlns:p="http://schemas.openxmlformats.org/presentationml/2006/main" xmlns:a="http://schemas.openxmlformats.org/drawingml/2006/main">
-  <p:cSld>
-    <p:bg>
-      <p:bgPr>
-        <a:solidFill>
-          <a:srgbClr val="F7F9FC"/>
-        </a:solidFill>
-      </p:bgPr>
-    </p:bg>
-    <p:spTree>
-      <p:nvGrpSpPr>
-        <p:cNvPr id="1" name=""/>
-        <p:cNvGrpSpPr/>
-        <p:nvPr/>
-      </p:nvGrpSpPr>
-      <p:grpSpPr>
-        <a:xfrm>
-          <a:off x="0" y="0"/>
-          <a:ext cx="0" cy="0"/>
-          <a:chOff x="0" y="0"/>
-          <a:chExt cx="0" cy="0"/>
-        </a:xfrm>
-      </p:grpSpPr>
-      <p:grpSp>
-        <p:nvGrpSpPr>
-          <p:cNvPr name="Group 2" id="2"/>
-          <p:cNvGrpSpPr/>
-          <p:nvPr/>
-        </p:nvGrpSpPr>
-        <p:grpSpPr>
-          <a:xfrm rot="0">
-            <a:off x="1047750" y="819150"/>
-            <a:ext cx="876300" cy="47625"/>
-            <a:chOff x="0" y="0"/>
-            <a:chExt cx="1168400" cy="63500"/>
-          </a:xfrm>
-        </p:grpSpPr>
-        <p:sp>
-          <p:nvSpPr>
-            <p:cNvPr name="Freeform 3" id="3"/>
-            <p:cNvSpPr/>
-            <p:nvPr/>
-          </p:nvSpPr>
-          <p:spPr>
-            <a:xfrm flipH="false" flipV="false" rot="0">
-              <a:off x="0" y="0"/>
-              <a:ext cx="1168400" cy="63500"/>
-            </a:xfrm>
-            <a:custGeom>
-              <a:avLst/>
-              <a:gdLst/>
-              <a:ahLst/>
-              <a:cxnLst/>
-              <a:rect r="r" b="b" t="t" l="l"/>
-              <a:pathLst>
-                <a:path h="63500" w="1168400">
-                  <a:moveTo>
-                    <a:pt x="0" y="0"/>
-                  </a:moveTo>
-                  <a:lnTo>
-                    <a:pt x="1168400" y="0"/>
-                  </a:lnTo>
-                  <a:lnTo>
-                    <a:pt x="1168400" y="63500"/>
-                  </a:lnTo>
-                  <a:lnTo>
-                    <a:pt x="0" y="63500"/>
-                  </a:lnTo>
-                  <a:close/>
-                </a:path>
-              </a:pathLst>
-            </a:custGeom>
-            <a:solidFill>
-              <a:srgbClr val="2E5C8A"/>
-            </a:solidFill>
-            <a:ln cap="sq">
-              <a:noFill/>
-              <a:prstDash val="solid"/>
-              <a:miter/>
-            </a:ln>
-          </p:spPr>
-        </p:sp>
-        <p:sp>
-          <p:nvSpPr>
-            <p:cNvPr name="TextBox 4" id="4"/>
-            <p:cNvSpPr txBox="true"/>
-            <p:nvPr/>
-          </p:nvSpPr>
-          <p:spPr>
-            <a:xfrm>
-              <a:off x="0" y="-38100"/>
-              <a:ext cx="1168400" cy="101600"/>
-            </a:xfrm>
-            <a:prstGeom prst="rect">
-              <a:avLst/>
-            </a:prstGeom>
-          </p:spPr>
-          <p:txBody>
-            <a:bodyPr anchor="ctr" rtlCol="false" tIns="50800" lIns="50800" bIns="50800" rIns="50800"/>
-            <a:lstStyle/>
-            <a:p>
-              <a:pPr algn="l">
-                <a:lnSpc>
-                  <a:spcPts val="1679"/>
-                </a:lnSpc>
-              </a:pPr>
-            </a:p>
-          </p:txBody>
-        </p:sp>
-      </p:grpSp>
-      <p:sp>
-        <p:nvSpPr>
-          <p:cNvPr name="TextBox 5" id="5"/>
-          <p:cNvSpPr txBox="true"/>
-          <p:nvPr/>
-        </p:nvSpPr>
-        <p:spPr>
-          <a:xfrm rot="0">
-            <a:off x="16764000" y="666750"/>
-            <a:ext cx="476250" cy="222885"/>
-          </a:xfrm>
-          <a:prstGeom prst="rect">
-            <a:avLst/>
-          </a:prstGeom>
-        </p:spPr>
-        <p:txBody>
-          <a:bodyPr anchor="t" rtlCol="false" tIns="0" lIns="0" bIns="0" rIns="0">
-            <a:spAutoFit/>
-          </a:bodyPr>
-          <a:lstStyle/>
-          <a:p>
-            <a:pPr algn="r">
-              <a:lnSpc>
-                <a:spcPts val="1889"/>
-              </a:lnSpc>
-            </a:pPr>
-            <a:r>
-              <a:rPr lang="en-US" sz="1350">
-                <a:solidFill>
-                  <a:srgbClr val="8A98AA"/>
-                </a:solidFill>
-                <a:latin typeface="JetBrains Mono"/>
-                <a:ea typeface="JetBrains Mono"/>
-                <a:cs typeface="JetBrains Mono"/>
-                <a:sym typeface="JetBrains Mono"/>
-              </a:rPr>
-              <a:t>09</a:t>
-            </a:r>
-          </a:p>
-        </p:txBody>
-      </p:sp>
-      <p:sp>
-        <p:nvSpPr>
-          <p:cNvPr name="TextBox 6" id="6"/>
-          <p:cNvSpPr txBox="true"/>
-          <p:nvPr/>
-        </p:nvSpPr>
-        <p:spPr>
-          <a:xfrm rot="0">
-            <a:off x="1047750" y="1304925"/>
-            <a:ext cx="8572500" cy="663702"/>
-          </a:xfrm>
-          <a:prstGeom prst="rect">
-            <a:avLst/>
-          </a:prstGeom>
-        </p:spPr>
-        <p:txBody>
-          <a:bodyPr anchor="t" rtlCol="false" tIns="0" lIns="0" bIns="0" rIns="0">
-            <a:spAutoFit/>
-          </a:bodyPr>
-          <a:lstStyle/>
-          <a:p>
-            <a:pPr algn="l">
-              <a:lnSpc>
-                <a:spcPts val="5184"/>
-              </a:lnSpc>
-            </a:pPr>
-            <a:r>
-              <a:rPr lang="en-US" sz="4800" b="true">
-                <a:solidFill>
-                  <a:srgbClr val="1B2A3F"/>
-                </a:solidFill>
-                <a:latin typeface="IBM Plex Sans Bold"/>
-                <a:ea typeface="IBM Plex Sans Bold"/>
-                <a:cs typeface="IBM Plex Sans Bold"/>
-                <a:sym typeface="IBM Plex Sans Bold"/>
-              </a:rPr>
-              <a:t>Kết quả kiểm thử</a:t>
-            </a:r>
-          </a:p>
-        </p:txBody>
-      </p:sp>
-      <p:sp>
-        <p:nvSpPr>
-          <p:cNvPr name="TextBox 7" id="7"/>
-          <p:cNvSpPr txBox="true"/>
-          <p:nvPr/>
-        </p:nvSpPr>
-        <p:spPr>
-          <a:xfrm rot="0">
-            <a:off x="1047750" y="3181350"/>
-            <a:ext cx="6572250" cy="2181225"/>
-          </a:xfrm>
-          <a:prstGeom prst="rect">
-            <a:avLst/>
-          </a:prstGeom>
-        </p:spPr>
-        <p:txBody>
-          <a:bodyPr anchor="t" rtlCol="false" tIns="0" lIns="0" bIns="0" rIns="0">
-            <a:spAutoFit/>
-          </a:bodyPr>
-          <a:lstStyle/>
-          <a:p>
-            <a:pPr algn="l">
-              <a:lnSpc>
-                <a:spcPts val="17850"/>
-              </a:lnSpc>
-            </a:pPr>
-            <a:r>
-              <a:rPr lang="en-US" sz="12750" b="true">
-                <a:solidFill>
-                  <a:srgbClr val="1B2A3F"/>
-                </a:solidFill>
-                <a:latin typeface="JetBrains Mono Bold"/>
-                <a:ea typeface="JetBrains Mono Bold"/>
-                <a:cs typeface="JetBrains Mono Bold"/>
-                <a:sym typeface="JetBrains Mono Bold"/>
-              </a:rPr>
-              <a:t>25/25</a:t>
-            </a:r>
-          </a:p>
-        </p:txBody>
-      </p:sp>
-      <p:sp>
-        <p:nvSpPr>
-          <p:cNvPr name="TextBox 8" id="8"/>
-          <p:cNvSpPr txBox="true"/>
-          <p:nvPr/>
-        </p:nvSpPr>
-        <p:spPr>
-          <a:xfrm rot="0">
-            <a:off x="1047750" y="5543550"/>
-            <a:ext cx="4953000" cy="1128713"/>
-          </a:xfrm>
-          <a:prstGeom prst="rect">
-            <a:avLst/>
-          </a:prstGeom>
-        </p:spPr>
-        <p:txBody>
-          <a:bodyPr anchor="t" rtlCol="false" tIns="0" lIns="0" bIns="0" rIns="0">
-            <a:spAutoFit/>
-          </a:bodyPr>
-          <a:lstStyle/>
-          <a:p>
-            <a:pPr algn="l" marL="0" indent="0" lvl="0">
-              <a:lnSpc>
-                <a:spcPts val="3037"/>
-              </a:lnSpc>
-              <a:spcBef>
-                <a:spcPct val="0"/>
-              </a:spcBef>
-            </a:pPr>
-            <a:r>
-              <a:rPr lang="en-US" sz="2250" strike="noStrike" u="none">
-                <a:solidFill>
-                  <a:srgbClr val="2E5C8A"/>
-                </a:solidFill>
-                <a:latin typeface="IBM Plex Sans"/>
-                <a:ea typeface="IBM Plex Sans"/>
-                <a:cs typeface="IBM Plex Sans"/>
-                <a:sym typeface="IBM Plex Sans"/>
-              </a:rPr>
-              <a:t>test case PASS</a:t>
-            </a:r>
-          </a:p>
-          <a:p>
-            <a:pPr algn="l" marL="0" indent="0" lvl="0">
-              <a:lnSpc>
-                <a:spcPts val="3037"/>
-              </a:lnSpc>
-              <a:spcBef>
-                <a:spcPct val="0"/>
-              </a:spcBef>
-            </a:pPr>
-            <a:r>
-              <a:rPr lang="en-US" sz="2250" strike="noStrike" u="none">
-                <a:solidFill>
-                  <a:srgbClr val="2E5C8A"/>
-                </a:solidFill>
-                <a:latin typeface="IBM Plex Sans"/>
-                <a:ea typeface="IBM Plex Sans"/>
-                <a:cs typeface="IBM Plex Sans"/>
-                <a:sym typeface="IBM Plex Sans"/>
-              </a:rPr>
-              <a:t>6 luồng bình thường</a:t>
-            </a:r>
-          </a:p>
-          <a:p>
-            <a:pPr algn="l" marL="0" indent="0" lvl="0">
-              <a:lnSpc>
-                <a:spcPts val="3037"/>
-              </a:lnSpc>
-              <a:spcBef>
-                <a:spcPct val="0"/>
-              </a:spcBef>
-            </a:pPr>
-            <a:r>
-              <a:rPr lang="en-US" sz="2250" strike="noStrike" u="none">
-                <a:solidFill>
-                  <a:srgbClr val="2E5C8A"/>
-                </a:solidFill>
-                <a:latin typeface="IBM Plex Sans"/>
-                <a:ea typeface="IBM Plex Sans"/>
-                <a:cs typeface="IBM Plex Sans"/>
-                <a:sym typeface="IBM Plex Sans"/>
-              </a:rPr>
-              <a:t>+ 19 test tấn công</a:t>
-            </a:r>
-          </a:p>
-        </p:txBody>
-      </p:sp>
-      <p:grpSp>
-        <p:nvGrpSpPr>
-          <p:cNvPr name="Group 9" id="9"/>
-          <p:cNvGrpSpPr/>
-          <p:nvPr/>
-        </p:nvGrpSpPr>
-        <p:grpSpPr>
-          <a:xfrm rot="0">
-            <a:off x="7620000" y="2190750"/>
-            <a:ext cx="9429750" cy="5905500"/>
-            <a:chOff x="0" y="0"/>
-            <a:chExt cx="12573000" cy="7874000"/>
-          </a:xfrm>
-        </p:grpSpPr>
-        <p:sp>
-          <p:nvSpPr>
-            <p:cNvPr name="Freeform 10" id="10"/>
-            <p:cNvSpPr/>
-            <p:nvPr/>
-          </p:nvSpPr>
-          <p:spPr>
-            <a:xfrm flipH="false" flipV="false" rot="0">
-              <a:off x="0" y="0"/>
-              <a:ext cx="12573000" cy="7874000"/>
-            </a:xfrm>
-            <a:custGeom>
-              <a:avLst/>
-              <a:gdLst/>
-              <a:ahLst/>
-              <a:cxnLst/>
-              <a:rect r="r" b="b" t="t" l="l"/>
-              <a:pathLst>
-                <a:path h="7874000" w="12573000">
-                  <a:moveTo>
-                    <a:pt x="0" y="0"/>
-                  </a:moveTo>
-                  <a:lnTo>
-                    <a:pt x="12573000" y="0"/>
-                  </a:lnTo>
-                  <a:lnTo>
-                    <a:pt x="12573000" y="7874000"/>
-                  </a:lnTo>
-                  <a:lnTo>
-                    <a:pt x="0" y="7874000"/>
-                  </a:lnTo>
-                  <a:close/>
-                </a:path>
-              </a:pathLst>
-            </a:custGeom>
-            <a:solidFill>
-              <a:srgbClr val="FFFFFF"/>
-            </a:solidFill>
-            <a:ln w="9525" cap="sq">
-              <a:solidFill>
-                <a:srgbClr val="D4DCE6"/>
-              </a:solidFill>
-              <a:prstDash val="lgDash"/>
-              <a:miter/>
-            </a:ln>
-          </p:spPr>
-        </p:sp>
-        <p:sp>
-          <p:nvSpPr>
-            <p:cNvPr name="TextBox 11" id="11"/>
-            <p:cNvSpPr txBox="true"/>
-            <p:nvPr/>
-          </p:nvSpPr>
-          <p:spPr>
-            <a:xfrm>
-              <a:off x="0" y="-38100"/>
-              <a:ext cx="12573000" cy="7912100"/>
-            </a:xfrm>
-            <a:prstGeom prst="rect">
-              <a:avLst/>
-            </a:prstGeom>
-          </p:spPr>
-          <p:txBody>
-            <a:bodyPr anchor="ctr" rtlCol="false" tIns="50800" lIns="50800" bIns="50800" rIns="50800"/>
-            <a:lstStyle/>
-            <a:p>
-              <a:pPr algn="l">
-                <a:lnSpc>
-                  <a:spcPts val="1679"/>
-                </a:lnSpc>
-              </a:pPr>
-            </a:p>
-          </p:txBody>
-        </p:sp>
-      </p:grpSp>
-      <p:sp>
-        <p:nvSpPr>
-          <p:cNvPr name="TextBox 12" id="12"/>
-          <p:cNvSpPr txBox="true"/>
-          <p:nvPr/>
-        </p:nvSpPr>
-        <p:spPr>
-          <a:xfrm rot="0">
-            <a:off x="8477250" y="8391525"/>
-            <a:ext cx="7620000" cy="567690"/>
-          </a:xfrm>
-          <a:prstGeom prst="rect">
-            <a:avLst/>
-          </a:prstGeom>
-        </p:spPr>
-        <p:txBody>
-          <a:bodyPr anchor="t" rtlCol="false" tIns="0" lIns="0" bIns="0" rIns="0">
-            <a:spAutoFit/>
-          </a:bodyPr>
-          <a:lstStyle/>
-          <a:p>
-            <a:pPr algn="ctr" marL="0" indent="0" lvl="0">
-              <a:lnSpc>
-                <a:spcPts val="2310"/>
-              </a:lnSpc>
-              <a:spcBef>
-                <a:spcPct val="0"/>
-              </a:spcBef>
-            </a:pPr>
-            <a:r>
-              <a:rPr lang="en-US" sz="1650" strike="noStrike" u="none">
-                <a:solidFill>
-                  <a:srgbClr val="8A98AA"/>
-                </a:solidFill>
-                <a:latin typeface="JetBrains Mono"/>
-                <a:ea typeface="JetBrains Mono"/>
-                <a:cs typeface="JetBrains Mono"/>
-                <a:sym typeface="JetBrains Mono"/>
-              </a:rPr>
-              <a:t>Trích kết quả thực tế — docs/evidence/07-run-tests-output.txt</a:t>
-            </a:r>
-          </a:p>
-        </p:txBody>
-      </p:sp>
-      <p:sp>
-        <p:nvSpPr>
-          <p:cNvPr name="TextBox 13" id="13"/>
-          <p:cNvSpPr txBox="true"/>
-          <p:nvPr/>
-        </p:nvSpPr>
-        <p:spPr>
-          <a:xfrm rot="0">
-            <a:off x="7953375" y="2466975"/>
-            <a:ext cx="8763000" cy="4003358"/>
-          </a:xfrm>
-          <a:prstGeom prst="rect">
-            <a:avLst/>
-          </a:prstGeom>
-        </p:spPr>
-        <p:txBody>
-          <a:bodyPr anchor="t" rtlCol="false" tIns="0" lIns="0" bIns="0" rIns="0">
-            <a:spAutoFit/>
-          </a:bodyPr>
-          <a:lstStyle/>
-          <a:p>
-            <a:pPr algn="l">
-              <a:lnSpc>
-                <a:spcPts val="2137"/>
-              </a:lnSpc>
-            </a:pPr>
-            <a:r>
-              <a:rPr lang="en-US" sz="1425">
-                <a:solidFill>
-                  <a:srgbClr val="3C4A5C"/>
-                </a:solidFill>
-                <a:latin typeface="Arimo"/>
-                <a:ea typeface="Arimo"/>
-                <a:cs typeface="Arimo"/>
-                <a:sym typeface="Arimo"/>
-              </a:rPr>
-              <a:t>$ node tests/run-tests.mjs</a:t>
-            </a:r>
-          </a:p>
-          <a:p>
-            <a:pPr algn="l">
-              <a:lnSpc>
-                <a:spcPts val="2137"/>
-              </a:lnSpc>
-            </a:pPr>
-          </a:p>
-          <a:p>
-            <a:pPr algn="l">
-              <a:lnSpc>
-                <a:spcPts val="2137"/>
-              </a:lnSpc>
-            </a:pPr>
-            <a:r>
-              <a:rPr lang="en-US" sz="1425">
-                <a:solidFill>
-                  <a:srgbClr val="3C4A5C"/>
-                </a:solidFill>
-                <a:latin typeface="Arimo"/>
-                <a:ea typeface="Arimo"/>
-                <a:cs typeface="Arimo"/>
-                <a:sym typeface="Arimo"/>
-              </a:rPr>
-              <a:t> TC01   PASS   bat buoc MFA lan dau</a:t>
-            </a:r>
-          </a:p>
-          <a:p>
-            <a:pPr algn="l">
-              <a:lnSpc>
-                <a:spcPts val="2137"/>
-              </a:lnSpc>
-            </a:pPr>
-            <a:r>
-              <a:rPr lang="en-US" sz="1425">
-                <a:solidFill>
-                  <a:srgbClr val="3C4A5C"/>
-                </a:solidFill>
-                <a:latin typeface="Arimo"/>
-                <a:ea typeface="Arimo"/>
-                <a:cs typeface="Arimo"/>
-                <a:sym typeface="Arimo"/>
-              </a:rPr>
-              <a:t> TC11   PASS   sua payload JWT</a:t>
-            </a:r>
-          </a:p>
-          <a:p>
-            <a:pPr algn="l">
-              <a:lnSpc>
-                <a:spcPts val="2137"/>
-              </a:lnSpc>
-            </a:pPr>
-            <a:r>
-              <a:rPr lang="en-US" sz="1425">
-                <a:solidFill>
-                  <a:srgbClr val="3C4A5C"/>
-                </a:solidFill>
-                <a:latin typeface="Arimo"/>
-                <a:ea typeface="Arimo"/>
-                <a:cs typeface="Arimo"/>
-                <a:sym typeface="Arimo"/>
-              </a:rPr>
-              <a:t> TC12   PASS   JWT alg=none</a:t>
-            </a:r>
-          </a:p>
-          <a:p>
-            <a:pPr algn="l">
-              <a:lnSpc>
-                <a:spcPts val="2137"/>
-              </a:lnSpc>
-            </a:pPr>
-            <a:r>
-              <a:rPr lang="en-US" sz="1425">
-                <a:solidFill>
-                  <a:srgbClr val="3C4A5C"/>
-                </a:solidFill>
-                <a:latin typeface="Arimo"/>
-                <a:ea typeface="Arimo"/>
-                <a:cs typeface="Arimo"/>
-                <a:sym typeface="Arimo"/>
-              </a:rPr>
-              <a:t> TC05   PASS   chuoi hash 268 dong, khong vi pham</a:t>
-            </a:r>
-          </a:p>
-          <a:p>
-            <a:pPr algn="l">
-              <a:lnSpc>
-                <a:spcPts val="2137"/>
-              </a:lnSpc>
-            </a:pPr>
-            <a:r>
-              <a:rPr lang="en-US" sz="1425">
-                <a:solidFill>
-                  <a:srgbClr val="3C4A5C"/>
-                </a:solidFill>
-                <a:latin typeface="Arimo"/>
-                <a:ea typeface="Arimo"/>
-                <a:cs typeface="Arimo"/>
-                <a:sym typeface="Arimo"/>
-              </a:rPr>
-              <a:t> TC22   PASS   sua diem thang trong DB -&gt; phat hien lech</a:t>
-            </a:r>
-          </a:p>
-          <a:p>
-            <a:pPr algn="l">
-              <a:lnSpc>
-                <a:spcPts val="2137"/>
-              </a:lnSpc>
-            </a:pPr>
-            <a:r>
-              <a:rPr lang="en-US" sz="1425">
-                <a:solidFill>
-                  <a:srgbClr val="3C4A5C"/>
-                </a:solidFill>
-                <a:latin typeface="Arimo"/>
-                <a:ea typeface="Arimo"/>
-                <a:cs typeface="Arimo"/>
-                <a:sym typeface="Arimo"/>
-              </a:rPr>
-              <a:t> TC24   PASS   sua audit id 3 -&gt; dut chuoi hash</a:t>
-            </a:r>
-          </a:p>
-          <a:p>
-            <a:pPr algn="l">
-              <a:lnSpc>
-                <a:spcPts val="2137"/>
-              </a:lnSpc>
-            </a:pPr>
-            <a:r>
-              <a:rPr lang="en-US" sz="1425">
-                <a:solidFill>
-                  <a:srgbClr val="3C4A5C"/>
-                </a:solidFill>
-                <a:latin typeface="Arimo"/>
-                <a:ea typeface="Arimo"/>
-                <a:cs typeface="Arimo"/>
-                <a:sym typeface="Arimo"/>
-              </a:rPr>
-              <a:t> TC23   PASS   app_user bi tu choi 4 lenh pha hoai</a:t>
-            </a:r>
-          </a:p>
-          <a:p>
-            <a:pPr algn="l">
-              <a:lnSpc>
-                <a:spcPts val="2137"/>
-              </a:lnSpc>
-            </a:pPr>
-            <a:r>
-              <a:rPr lang="en-US" sz="1425">
-                <a:solidFill>
-                  <a:srgbClr val="3C4A5C"/>
-                </a:solidFill>
-                <a:latin typeface="Arimo"/>
-                <a:ea typeface="Arimo"/>
-                <a:cs typeface="Arimo"/>
-                <a:sym typeface="Arimo"/>
-              </a:rPr>
-              <a:t> TC19   PASS   SQLi qua WAF -&gt; 403</a:t>
-            </a:r>
-          </a:p>
-          <a:p>
-            <a:pPr algn="l">
-              <a:lnSpc>
-                <a:spcPts val="2137"/>
-              </a:lnSpc>
-            </a:pPr>
-            <a:r>
-              <a:rPr lang="en-US" sz="1425">
-                <a:solidFill>
-                  <a:srgbClr val="3C4A5C"/>
-                </a:solidFill>
-                <a:latin typeface="Arimo"/>
-                <a:ea typeface="Arimo"/>
-                <a:cs typeface="Arimo"/>
-                <a:sym typeface="Arimo"/>
-              </a:rPr>
-              <a:t> TC21   PASS   chi waf anh xa port ra host</a:t>
-            </a:r>
-          </a:p>
-          <a:p>
-            <a:pPr algn="l">
-              <a:lnSpc>
-                <a:spcPts val="2137"/>
-              </a:lnSpc>
-            </a:pPr>
-            <a:r>
-              <a:rPr lang="en-US" sz="1425">
-                <a:solidFill>
-                  <a:srgbClr val="3C4A5C"/>
-                </a:solidFill>
-                <a:latin typeface="Arimo"/>
-                <a:ea typeface="Arimo"/>
-                <a:cs typeface="Arimo"/>
-                <a:sym typeface="Arimo"/>
-              </a:rPr>
-              <a:t> TC09   PASS   3 lan OTP sai -&gt; khoa, canh bao HIGH</a:t>
-            </a:r>
-          </a:p>
-          <a:p>
-            <a:pPr algn="l">
-              <a:lnSpc>
-                <a:spcPts val="2137"/>
-              </a:lnSpc>
-            </a:pPr>
-            <a:r>
-              <a:rPr lang="en-US" sz="1425">
-                <a:solidFill>
-                  <a:srgbClr val="3C4A5C"/>
-                </a:solidFill>
-                <a:latin typeface="Arimo"/>
-                <a:ea typeface="Arimo"/>
-                <a:cs typeface="Arimo"/>
-                <a:sym typeface="Arimo"/>
-              </a:rPr>
-              <a:t> ...</a:t>
-            </a:r>
-          </a:p>
-          <a:p>
-            <a:pPr algn="l">
-              <a:lnSpc>
-                <a:spcPts val="2137"/>
-              </a:lnSpc>
-            </a:pPr>
-          </a:p>
-          <a:p>
-            <a:pPr algn="l">
-              <a:lnSpc>
-                <a:spcPts val="2137"/>
-              </a:lnSpc>
-            </a:pPr>
-            <a:r>
-              <a:rPr lang="en-US" sz="1425">
-                <a:solidFill>
-                  <a:srgbClr val="3C4A5C"/>
-                </a:solidFill>
-                <a:latin typeface="Arimo"/>
-                <a:ea typeface="Arimo"/>
-                <a:cs typeface="Arimo"/>
-                <a:sym typeface="Arimo"/>
-              </a:rPr>
-              <a:t>25/25 PASS</a:t>
             </a:r>
           </a:p>
         </p:txBody>

</xml_diff>

<commit_message>
Doi tieu de slide 6 thanh "Khong tin cay mac dinh"
Doi o tieu de slide 6, muc 03 cua trang muc luc, va cac tai lieu thuyet
trinh de loi noi khop voi slide.

Co-Authored-By: Claude Opus 5.5 <noreply@anthropic.com>
</commit_message>
<xml_diff>
--- a/docs/SLIDE.pptx
+++ b/docs/SLIDE.pptx
@@ -10949,7 +10949,7 @@
                 <a:cs typeface="Arimo"/>
                 <a:sym typeface="Arimo"/>
               </a:rPr>
-              <a:t>Không tin mặc định — 12 lớp kiểm chứng</a:t>
+              <a:t>Không tin cậy mặc định — 12 lớp kiểm chứng</a:t>
             </a:r>
           </a:p>
         </p:txBody>
@@ -13427,7 +13427,7 @@
                 <a:cs typeface="IBM Plex Sans Bold"/>
                 <a:sym typeface="IBM Plex Sans Bold"/>
               </a:rPr>
-              <a:t>Không tin mặc định</a:t>
+              <a:t>Không tin cậy mặc định</a:t>
             </a:r>
           </a:p>
         </p:txBody>

</xml_diff>